<commit_message>
Add GPU utilization subtitle to the presentation cover
</commit_message>
<xml_diff>
--- a/Inference_Optimization_Final.pptx
+++ b/Inference_Optimization_Final.pptx
@@ -2,40 +2,40 @@
 <file path=ppt/presentation.xml><?xml version="1.0" encoding="utf-8"?>
 <p:presentation xmlns:p="http://schemas.openxmlformats.org/presentationml/2006/main" embedTrueTypeFonts="1" saveSubsetFonts="0">
   <p:sldMasterIdLst>
-    <p:sldMasterId xmlns:r="http://schemas.openxmlformats.org/officeDocument/2006/relationships" id="2147483648" r:id="R43976c4bc9ad4873"/>
+    <p:sldMasterId xmlns:r="http://schemas.openxmlformats.org/officeDocument/2006/relationships" id="2147483648" r:id="Rdc7c341d59e04c78"/>
   </p:sldMasterIdLst>
   <p:notesMasterIdLst>
-    <p:notesMasterId xmlns:r="http://schemas.openxmlformats.org/officeDocument/2006/relationships" r:id="Rbc3365e2ca9f43e6"/>
+    <p:notesMasterId xmlns:r="http://schemas.openxmlformats.org/officeDocument/2006/relationships" r:id="R9fdfae68cffe4cf0"/>
   </p:notesMasterIdLst>
   <p:sldIdLst>
-    <p:sldId xmlns:r="http://schemas.openxmlformats.org/officeDocument/2006/relationships" id="256" r:id="Rc40acd3fa83e4e12"/>
-    <p:sldId xmlns:r="http://schemas.openxmlformats.org/officeDocument/2006/relationships" id="257" r:id="R0733239788b94406"/>
-    <p:sldId xmlns:r="http://schemas.openxmlformats.org/officeDocument/2006/relationships" id="258" r:id="R0743b5b53d2f4f15"/>
-    <p:sldId xmlns:r="http://schemas.openxmlformats.org/officeDocument/2006/relationships" id="259" r:id="R150c9ea6cd6a4825"/>
-    <p:sldId xmlns:r="http://schemas.openxmlformats.org/officeDocument/2006/relationships" id="260" r:id="Ra556e032515e449f"/>
-    <p:sldId xmlns:r="http://schemas.openxmlformats.org/officeDocument/2006/relationships" id="261" r:id="Rfe2148f12a034dcd"/>
-    <p:sldId xmlns:r="http://schemas.openxmlformats.org/officeDocument/2006/relationships" id="262" r:id="R8f0bcbbddb944508"/>
-    <p:sldId xmlns:r="http://schemas.openxmlformats.org/officeDocument/2006/relationships" id="263" r:id="R70c665e583314643"/>
-    <p:sldId xmlns:r="http://schemas.openxmlformats.org/officeDocument/2006/relationships" id="264" r:id="R0f17cbfca8004d4a"/>
-    <p:sldId xmlns:r="http://schemas.openxmlformats.org/officeDocument/2006/relationships" id="265" r:id="Rfc8633f31fc0416d"/>
-    <p:sldId xmlns:r="http://schemas.openxmlformats.org/officeDocument/2006/relationships" id="266" r:id="R73c8f1b728e9443a"/>
-    <p:sldId xmlns:r="http://schemas.openxmlformats.org/officeDocument/2006/relationships" id="267" r:id="R3732894c21bb4f84"/>
-    <p:sldId xmlns:r="http://schemas.openxmlformats.org/officeDocument/2006/relationships" id="268" r:id="Rf76afb2a7cc24429"/>
-    <p:sldId xmlns:r="http://schemas.openxmlformats.org/officeDocument/2006/relationships" id="269" r:id="Rb7ca06ab229b45d1"/>
-    <p:sldId xmlns:r="http://schemas.openxmlformats.org/officeDocument/2006/relationships" id="270" r:id="R0a8029a898164834"/>
-    <p:sldId xmlns:r="http://schemas.openxmlformats.org/officeDocument/2006/relationships" id="271" r:id="R1dee9c56008f4d58"/>
-    <p:sldId xmlns:r="http://schemas.openxmlformats.org/officeDocument/2006/relationships" id="272" r:id="R4960822fc88c49ed"/>
-    <p:sldId xmlns:r="http://schemas.openxmlformats.org/officeDocument/2006/relationships" id="273" r:id="R56822af830d44b07"/>
+    <p:sldId xmlns:r="http://schemas.openxmlformats.org/officeDocument/2006/relationships" id="256" r:id="R3726e3434c3d412c"/>
+    <p:sldId xmlns:r="http://schemas.openxmlformats.org/officeDocument/2006/relationships" id="257" r:id="Ree07c08cfd2449c8"/>
+    <p:sldId xmlns:r="http://schemas.openxmlformats.org/officeDocument/2006/relationships" id="258" r:id="Rfa2a19c0ee7c4693"/>
+    <p:sldId xmlns:r="http://schemas.openxmlformats.org/officeDocument/2006/relationships" id="259" r:id="R0741ad89c3c24b9d"/>
+    <p:sldId xmlns:r="http://schemas.openxmlformats.org/officeDocument/2006/relationships" id="260" r:id="R8e6c18cbce81464a"/>
+    <p:sldId xmlns:r="http://schemas.openxmlformats.org/officeDocument/2006/relationships" id="261" r:id="Rc3d7f9ce40254f59"/>
+    <p:sldId xmlns:r="http://schemas.openxmlformats.org/officeDocument/2006/relationships" id="262" r:id="Rff798ad1940341c1"/>
+    <p:sldId xmlns:r="http://schemas.openxmlformats.org/officeDocument/2006/relationships" id="263" r:id="R1d8333cde8bc4958"/>
+    <p:sldId xmlns:r="http://schemas.openxmlformats.org/officeDocument/2006/relationships" id="264" r:id="R330c258cf6f74bdd"/>
+    <p:sldId xmlns:r="http://schemas.openxmlformats.org/officeDocument/2006/relationships" id="265" r:id="R6d577c4a0a084d23"/>
+    <p:sldId xmlns:r="http://schemas.openxmlformats.org/officeDocument/2006/relationships" id="266" r:id="R892e80431dcc446a"/>
+    <p:sldId xmlns:r="http://schemas.openxmlformats.org/officeDocument/2006/relationships" id="267" r:id="Rc4ada68def7c4df9"/>
+    <p:sldId xmlns:r="http://schemas.openxmlformats.org/officeDocument/2006/relationships" id="268" r:id="R12853195cd814ef9"/>
+    <p:sldId xmlns:r="http://schemas.openxmlformats.org/officeDocument/2006/relationships" id="269" r:id="R19540b3b8d4c4106"/>
+    <p:sldId xmlns:r="http://schemas.openxmlformats.org/officeDocument/2006/relationships" id="270" r:id="R804d3243776f486a"/>
+    <p:sldId xmlns:r="http://schemas.openxmlformats.org/officeDocument/2006/relationships" id="271" r:id="R559998c9ea144e50"/>
+    <p:sldId xmlns:r="http://schemas.openxmlformats.org/officeDocument/2006/relationships" id="272" r:id="Re2dcbad94dfd4d01"/>
+    <p:sldId xmlns:r="http://schemas.openxmlformats.org/officeDocument/2006/relationships" id="273" r:id="R622c2b4194374845"/>
   </p:sldIdLst>
   <p:sldSz cx="12192000" cy="6858000"/>
   <p:notesSz cx="6858000" cy="9144000"/>
   <p:embeddedFontLst>
     <p:embeddedFont>
       <p:font typeface="OpenAI Sans"/>
-      <p:regular xmlns:r="http://schemas.openxmlformats.org/officeDocument/2006/relationships" r:id="R749500a9285744bb"/>
-      <p:bold xmlns:r="http://schemas.openxmlformats.org/officeDocument/2006/relationships" r:id="R2b3adfa01b344d9b"/>
-      <p:italic xmlns:r="http://schemas.openxmlformats.org/officeDocument/2006/relationships" r:id="R5c0fb10b68784263"/>
-      <p:boldItalic xmlns:r="http://schemas.openxmlformats.org/officeDocument/2006/relationships" r:id="R7155704674b04cd3"/>
+      <p:regular xmlns:r="http://schemas.openxmlformats.org/officeDocument/2006/relationships" r:id="Ra2a245ba46404730"/>
+      <p:bold xmlns:r="http://schemas.openxmlformats.org/officeDocument/2006/relationships" r:id="Rb5892e2b0be94e64"/>
+      <p:italic xmlns:r="http://schemas.openxmlformats.org/officeDocument/2006/relationships" r:id="Ra882ca89d6084324"/>
+      <p:boldItalic xmlns:r="http://schemas.openxmlformats.org/officeDocument/2006/relationships" r:id="Ra1ba33c2b0d744cd"/>
     </p:embeddedFont>
   </p:embeddedFontLst>
 </p:presentation>
@@ -4047,14 +4047,14 @@
   </p:cSld>
   <p:clrMap bg1="lt1" tx1="dk1" bg2="lt2" tx2="dk2" accent1="accent1" accent2="accent2" accent3="accent3" accent4="accent4" accent5="accent5" accent6="accent6" hlink="hlink" folHlink="folHlink"/>
   <p:sldLayoutIdLst>
-    <p:sldLayoutId xmlns:r="http://schemas.openxmlformats.org/officeDocument/2006/relationships" id="2147483649" r:id="R7f26749f5dd048e2"/>
-    <p:sldLayoutId xmlns:r="http://schemas.openxmlformats.org/officeDocument/2006/relationships" id="2147483650" r:id="R8e6fd6f2e8474102"/>
-    <p:sldLayoutId xmlns:r="http://schemas.openxmlformats.org/officeDocument/2006/relationships" id="2147483651" r:id="Re65bdbe258dc43c8"/>
-    <p:sldLayoutId xmlns:r="http://schemas.openxmlformats.org/officeDocument/2006/relationships" id="2147483652" r:id="R49fc7fdb6a9441cc"/>
-    <p:sldLayoutId xmlns:r="http://schemas.openxmlformats.org/officeDocument/2006/relationships" id="2147483653" r:id="R5752d6725b5d49e6"/>
-    <p:sldLayoutId xmlns:r="http://schemas.openxmlformats.org/officeDocument/2006/relationships" id="2147483654" r:id="Rd3dc1f7b68cf45dd"/>
-    <p:sldLayoutId xmlns:r="http://schemas.openxmlformats.org/officeDocument/2006/relationships" id="2147483655" r:id="R8b2c15d4fec54921"/>
-    <p:sldLayoutId xmlns:r="http://schemas.openxmlformats.org/officeDocument/2006/relationships" id="2147483656" r:id="R758d433f31b74451"/>
+    <p:sldLayoutId xmlns:r="http://schemas.openxmlformats.org/officeDocument/2006/relationships" id="2147483649" r:id="R768045dfd20b43dd"/>
+    <p:sldLayoutId xmlns:r="http://schemas.openxmlformats.org/officeDocument/2006/relationships" id="2147483650" r:id="Ra859fd1d01384966"/>
+    <p:sldLayoutId xmlns:r="http://schemas.openxmlformats.org/officeDocument/2006/relationships" id="2147483651" r:id="Rf87ec76a897f4887"/>
+    <p:sldLayoutId xmlns:r="http://schemas.openxmlformats.org/officeDocument/2006/relationships" id="2147483652" r:id="Rdb7fc0ee77e042e8"/>
+    <p:sldLayoutId xmlns:r="http://schemas.openxmlformats.org/officeDocument/2006/relationships" id="2147483653" r:id="Rad6f2837db7a4496"/>
+    <p:sldLayoutId xmlns:r="http://schemas.openxmlformats.org/officeDocument/2006/relationships" id="2147483654" r:id="R4ec302fb235d4961"/>
+    <p:sldLayoutId xmlns:r="http://schemas.openxmlformats.org/officeDocument/2006/relationships" id="2147483655" r:id="R62a644a3e66b4624"/>
+    <p:sldLayoutId xmlns:r="http://schemas.openxmlformats.org/officeDocument/2006/relationships" id="2147483656" r:id="R96b2f7d0521b4366"/>
   </p:sldLayoutIdLst>
   <p:hf hdr="0" dt="0"/>
   <p:txStyles>
@@ -11059,8 +11059,8 @@
         </p:nvSpPr>
         <p:spPr>
           <a:xfrm xmlns:a="http://schemas.openxmlformats.org/drawingml/2006/main">
-            <a:off x="390525" y="3619500"/>
-            <a:ext cx="10953750" cy="1238250"/>
+            <a:off x="390525" y="4276725"/>
+            <a:ext cx="10953750" cy="495300"/>
           </a:xfrm>
         </p:spPr>
         <p:txBody>
@@ -11074,7 +11074,7 @@
                 <a:spcPct val="100000"/>
               </a:lnSpc>
               <a:buNone/>
-              <a:defRPr sz="3225" b="0">
+              <a:defRPr sz="2400" b="0">
                 <a:solidFill>
                   <a:srgbClr val="000000"/>
                 </a:solidFill>
@@ -11084,7 +11084,7 @@
               </a:defRPr>
             </a:pPr>
             <a:r>
-              <a:rPr sz="3225" b="0">
+              <a:rPr sz="2400" b="0">
                 <a:solidFill>
                   <a:srgbClr val="000000"/>
                 </a:solidFill>
@@ -11092,7 +11092,7 @@
                 <a:ea typeface="Helvetica Neue"/>
                 <a:cs typeface="Helvetica Neue"/>
               </a:rPr>
-              <a:t/>
+              <a:t>Improving GPU Utilization for LLM Inference</a:t>
             </a:r>
           </a:p>
         </p:txBody>
@@ -11499,7 +11499,7 @@
                 <a:latin typeface="Helvetica Neue"/>
                 <a:ea typeface="Helvetica Neue"/>
                 <a:cs typeface="Helvetica Neue"/>
-                <a:hlinkClick xmlns:r="http://schemas.openxmlformats.org/officeDocument/2006/relationships" r:id="Rf3e4c158a5e342de"/>
+                <a:hlinkClick xmlns:r="http://schemas.openxmlformats.org/officeDocument/2006/relationships" r:id="R3f06c149006f42a4"/>
               </a:rPr>
               <a:t>Our executed capture protocol</a:t>
             </a:r>
@@ -11519,7 +11519,7 @@
                 <a:latin typeface="Helvetica Neue"/>
                 <a:ea typeface="Helvetica Neue"/>
                 <a:cs typeface="Helvetica Neue"/>
-                <a:hlinkClick xmlns:r="http://schemas.openxmlformats.org/officeDocument/2006/relationships" r:id="R8f267c4aa8bb4648"/>
+                <a:hlinkClick xmlns:r="http://schemas.openxmlformats.org/officeDocument/2006/relationships" r:id="R7397f6e4960e4758"/>
               </a:rPr>
               <a:t>NVIDIA capture-size tradeoff</a:t>
             </a:r>
@@ -11638,7 +11638,7 @@
           <p:cNvPr id="534" name="">
             <a:extLst xmlns:a="http://schemas.openxmlformats.org/drawingml/2006/main">
               <a:ext uri="{FF2B5EF4-FFF2-40B4-BE49-F238E27FC236}">
-                <a16:creationId xmlns:a16="http://schemas.microsoft.com/office/drawing/2014/main" id="{37BF55FE-A206-4E0B-8CB8-2A5AF785C91F}"/>
+                <a16:creationId xmlns:a16="http://schemas.microsoft.com/office/drawing/2014/main" id="{7E28DBB9-35BF-4F1B-9CA6-CD751EB3400D}"/>
               </a:ext>
             </a:extLst>
           </p:cNvPr>
@@ -12037,7 +12037,7 @@
           <p:cNvPr id="536" name="">
             <a:extLst xmlns:a="http://schemas.openxmlformats.org/drawingml/2006/main">
               <a:ext uri="{FF2B5EF4-FFF2-40B4-BE49-F238E27FC236}">
-                <a16:creationId xmlns:a16="http://schemas.microsoft.com/office/drawing/2014/main" id="{AC1E57AC-3992-4189-A512-310327F45F6D}"/>
+                <a16:creationId xmlns:a16="http://schemas.microsoft.com/office/drawing/2014/main" id="{75CDF067-3F7A-44D6-9B41-6E06F47E63B2}"/>
               </a:ext>
             </a:extLst>
           </p:cNvPr>
@@ -12094,7 +12094,7 @@
           <p:cNvPr id="537" name="">
             <a:extLst xmlns:a="http://schemas.openxmlformats.org/drawingml/2006/main">
               <a:ext uri="{FF2B5EF4-FFF2-40B4-BE49-F238E27FC236}">
-                <a16:creationId xmlns:a16="http://schemas.microsoft.com/office/drawing/2014/main" id="{900BAE8B-3F99-46BC-960B-E598A1520681}"/>
+                <a16:creationId xmlns:a16="http://schemas.microsoft.com/office/drawing/2014/main" id="{82F03C7B-34AA-4CFE-95D9-07C921A5279A}"/>
               </a:ext>
             </a:extLst>
           </p:cNvPr>
@@ -12238,7 +12238,7 @@
                 <a:latin typeface="Helvetica Neue"/>
                 <a:ea typeface="Helvetica Neue"/>
                 <a:cs typeface="Helvetica Neue"/>
-                <a:hlinkClick xmlns:r="http://schemas.openxmlformats.org/officeDocument/2006/relationships" r:id="R25418b3e15aa4f68"/>
+                <a:hlinkClick xmlns:r="http://schemas.openxmlformats.org/officeDocument/2006/relationships" r:id="R2c81fb890c5845ce"/>
               </a:rPr>
               <a:t>Our frozen protocol and exact settings</a:t>
             </a:r>
@@ -12258,7 +12258,7 @@
                 <a:latin typeface="Helvetica Neue"/>
                 <a:ea typeface="Helvetica Neue"/>
                 <a:cs typeface="Helvetica Neue"/>
-                <a:hlinkClick xmlns:r="http://schemas.openxmlformats.org/officeDocument/2006/relationships" r:id="R2af65e0998c84b5f"/>
+                <a:hlinkClick xmlns:r="http://schemas.openxmlformats.org/officeDocument/2006/relationships" r:id="Rf8ce2cf8813540a1"/>
               </a:rPr>
               <a:t>W&amp;B runs</a:t>
             </a:r>
@@ -12377,7 +12377,7 @@
           <p:cNvPr id="534" name="">
             <a:extLst xmlns:a="http://schemas.openxmlformats.org/drawingml/2006/main">
               <a:ext uri="{FF2B5EF4-FFF2-40B4-BE49-F238E27FC236}">
-                <a16:creationId xmlns:a16="http://schemas.microsoft.com/office/drawing/2014/main" id="{92CDE663-812D-4349-81DA-42F4929F7306}"/>
+                <a16:creationId xmlns:a16="http://schemas.microsoft.com/office/drawing/2014/main" id="{2CCC637A-1978-4C96-BDFC-16BD27056BA4}"/>
               </a:ext>
             </a:extLst>
           </p:cNvPr>
@@ -12656,7 +12656,7 @@
           <p:cNvPr id="536" name="">
             <a:extLst xmlns:a="http://schemas.openxmlformats.org/drawingml/2006/main">
               <a:ext uri="{FF2B5EF4-FFF2-40B4-BE49-F238E27FC236}">
-                <a16:creationId xmlns:a16="http://schemas.microsoft.com/office/drawing/2014/main" id="{8AF94CA3-F7E9-4A38-8BC6-4F3E601C83E6}"/>
+                <a16:creationId xmlns:a16="http://schemas.microsoft.com/office/drawing/2014/main" id="{413C4C8A-9154-422E-9801-12884E533D03}"/>
               </a:ext>
             </a:extLst>
           </p:cNvPr>
@@ -12736,7 +12736,7 @@
           <p:cNvPr id="537" name="">
             <a:extLst xmlns:a="http://schemas.openxmlformats.org/drawingml/2006/main">
               <a:ext uri="{FF2B5EF4-FFF2-40B4-BE49-F238E27FC236}">
-                <a16:creationId xmlns:a16="http://schemas.microsoft.com/office/drawing/2014/main" id="{92DEFC38-3991-416A-BFAE-0B1C702F8AE7}"/>
+                <a16:creationId xmlns:a16="http://schemas.microsoft.com/office/drawing/2014/main" id="{A124E7F0-5E62-4AEC-A06D-134FF97594E3}"/>
               </a:ext>
             </a:extLst>
           </p:cNvPr>
@@ -12816,7 +12816,7 @@
           <p:cNvPr id="538" name="">
             <a:extLst xmlns:a="http://schemas.openxmlformats.org/drawingml/2006/main">
               <a:ext uri="{FF2B5EF4-FFF2-40B4-BE49-F238E27FC236}">
-                <a16:creationId xmlns:a16="http://schemas.microsoft.com/office/drawing/2014/main" id="{75365992-F5EE-403A-817B-3398B3096BD9}"/>
+                <a16:creationId xmlns:a16="http://schemas.microsoft.com/office/drawing/2014/main" id="{72BF1FE3-24D3-4DE4-BB99-83BF191DC696}"/>
               </a:ext>
             </a:extLst>
           </p:cNvPr>
@@ -13056,7 +13056,7 @@
           <p:cNvPr id="534" name="">
             <a:extLst xmlns:a="http://schemas.openxmlformats.org/drawingml/2006/main">
               <a:ext uri="{FF2B5EF4-FFF2-40B4-BE49-F238E27FC236}">
-                <a16:creationId xmlns:a16="http://schemas.microsoft.com/office/drawing/2014/main" id="{F2EBF10A-F65E-46F2-BC08-2ED32A9C77DC}"/>
+                <a16:creationId xmlns:a16="http://schemas.microsoft.com/office/drawing/2014/main" id="{1A0D4CCE-8D78-456A-92A9-83678613E8B1}"/>
               </a:ext>
             </a:extLst>
           </p:cNvPr>
@@ -13159,7 +13159,7 @@
                 <a:latin typeface="Helvetica Neue"/>
                 <a:ea typeface="Helvetica Neue"/>
                 <a:cs typeface="Helvetica Neue"/>
-                <a:hlinkClick xmlns:r="http://schemas.openxmlformats.org/officeDocument/2006/relationships" r:id="Rb86b6baf72a342c7"/>
+                <a:hlinkClick xmlns:r="http://schemas.openxmlformats.org/officeDocument/2006/relationships" r:id="Red881a2820694fae"/>
               </a:rPr>
               <a:t>Source: our raw timing records and W&amp;B</a:t>
             </a:r>
@@ -13278,7 +13278,7 @@
           <p:cNvPr id="534" name="">
             <a:extLst xmlns:a="http://schemas.openxmlformats.org/drawingml/2006/main">
               <a:ext uri="{FF2B5EF4-FFF2-40B4-BE49-F238E27FC236}">
-                <a16:creationId xmlns:a16="http://schemas.microsoft.com/office/drawing/2014/main" id="{CD5942B5-029F-45AC-B9E1-ED0B1F6AE8A2}"/>
+                <a16:creationId xmlns:a16="http://schemas.microsoft.com/office/drawing/2014/main" id="{4BF5D1C7-4EA1-4872-86E0-0E878C207A13}"/>
               </a:ext>
             </a:extLst>
           </p:cNvPr>
@@ -13358,7 +13358,7 @@
           <p:cNvPr id="535" name="">
             <a:extLst xmlns:a="http://schemas.openxmlformats.org/drawingml/2006/main">
               <a:ext uri="{FF2B5EF4-FFF2-40B4-BE49-F238E27FC236}">
-                <a16:creationId xmlns:a16="http://schemas.microsoft.com/office/drawing/2014/main" id="{730CD48E-87D0-4CAC-9972-FB19F8032F43}"/>
+                <a16:creationId xmlns:a16="http://schemas.microsoft.com/office/drawing/2014/main" id="{41CAB78E-A276-43FF-8500-C32C38D2174E}"/>
               </a:ext>
             </a:extLst>
           </p:cNvPr>
@@ -13422,7 +13422,7 @@
         </p:xfrm>
         <a:graphic xmlns:a="http://schemas.openxmlformats.org/drawingml/2006/main">
           <a:graphicData uri="http://schemas.openxmlformats.org/drawingml/2006/chart">
-            <c:chart xmlns:r="http://schemas.openxmlformats.org/officeDocument/2006/relationships" xmlns:c="http://schemas.openxmlformats.org/drawingml/2006/chart" r:id="Ref214b70dd0041a6"/>
+            <c:chart xmlns:r="http://schemas.openxmlformats.org/officeDocument/2006/relationships" xmlns:c="http://schemas.openxmlformats.org/drawingml/2006/chart" r:id="R3a843dc101c84a47"/>
           </a:graphicData>
         </a:graphic>
       </p:graphicFrame>
@@ -13431,7 +13431,7 @@
           <p:cNvPr id="537" name="">
             <a:extLst xmlns:a="http://schemas.openxmlformats.org/drawingml/2006/main">
               <a:ext uri="{FF2B5EF4-FFF2-40B4-BE49-F238E27FC236}">
-                <a16:creationId xmlns:a16="http://schemas.microsoft.com/office/drawing/2014/main" id="{8E5A4C10-9F8B-48CC-B221-0CDB95EEB223}"/>
+                <a16:creationId xmlns:a16="http://schemas.microsoft.com/office/drawing/2014/main" id="{87904CFD-2F3E-49D2-AD18-75734018AE35}"/>
               </a:ext>
             </a:extLst>
           </p:cNvPr>
@@ -13488,7 +13488,7 @@
           <p:cNvPr id="538" name="">
             <a:extLst xmlns:a="http://schemas.openxmlformats.org/drawingml/2006/main">
               <a:ext uri="{FF2B5EF4-FFF2-40B4-BE49-F238E27FC236}">
-                <a16:creationId xmlns:a16="http://schemas.microsoft.com/office/drawing/2014/main" id="{D25D8E23-4692-43BB-8A8F-2FAD68DA5E18}"/>
+                <a16:creationId xmlns:a16="http://schemas.microsoft.com/office/drawing/2014/main" id="{0EF534B2-296A-4C59-BC70-DFECAB2B8712}"/>
               </a:ext>
             </a:extLst>
           </p:cNvPr>
@@ -13545,7 +13545,7 @@
           <p:cNvPr id="539" name="">
             <a:extLst xmlns:a="http://schemas.openxmlformats.org/drawingml/2006/main">
               <a:ext uri="{FF2B5EF4-FFF2-40B4-BE49-F238E27FC236}">
-                <a16:creationId xmlns:a16="http://schemas.microsoft.com/office/drawing/2014/main" id="{3EE3ECB4-30D0-4655-A0D9-125A57337BDE}"/>
+                <a16:creationId xmlns:a16="http://schemas.microsoft.com/office/drawing/2014/main" id="{F4FA576D-58FD-4341-83C4-4BD7EC557629}"/>
               </a:ext>
             </a:extLst>
           </p:cNvPr>
@@ -13609,7 +13609,7 @@
         </p:xfrm>
         <a:graphic xmlns:a="http://schemas.openxmlformats.org/drawingml/2006/main">
           <a:graphicData uri="http://schemas.openxmlformats.org/drawingml/2006/chart">
-            <c:chart xmlns:r="http://schemas.openxmlformats.org/officeDocument/2006/relationships" xmlns:c="http://schemas.openxmlformats.org/drawingml/2006/chart" r:id="R87782e4d9f784729"/>
+            <c:chart xmlns:r="http://schemas.openxmlformats.org/officeDocument/2006/relationships" xmlns:c="http://schemas.openxmlformats.org/drawingml/2006/chart" r:id="R8ba54b1a4f354396"/>
           </a:graphicData>
         </a:graphic>
       </p:graphicFrame>
@@ -13618,7 +13618,7 @@
           <p:cNvPr id="541" name="">
             <a:extLst xmlns:a="http://schemas.openxmlformats.org/drawingml/2006/main">
               <a:ext uri="{FF2B5EF4-FFF2-40B4-BE49-F238E27FC236}">
-                <a16:creationId xmlns:a16="http://schemas.microsoft.com/office/drawing/2014/main" id="{D79BB462-34D5-456C-906D-462717709091}"/>
+                <a16:creationId xmlns:a16="http://schemas.microsoft.com/office/drawing/2014/main" id="{B25C0B26-347E-476C-9940-A75300CE1A01}"/>
               </a:ext>
             </a:extLst>
           </p:cNvPr>
@@ -13675,7 +13675,7 @@
           <p:cNvPr id="542" name="">
             <a:extLst xmlns:a="http://schemas.openxmlformats.org/drawingml/2006/main">
               <a:ext uri="{FF2B5EF4-FFF2-40B4-BE49-F238E27FC236}">
-                <a16:creationId xmlns:a16="http://schemas.microsoft.com/office/drawing/2014/main" id="{19DC3C0E-6968-4DC9-9F94-D38DD0452EF2}"/>
+                <a16:creationId xmlns:a16="http://schemas.microsoft.com/office/drawing/2014/main" id="{C750D3BF-F32A-4C12-A3DB-EBAE9E9DABBD}"/>
               </a:ext>
             </a:extLst>
           </p:cNvPr>
@@ -13732,7 +13732,7 @@
           <p:cNvPr id="543" name="">
             <a:extLst xmlns:a="http://schemas.openxmlformats.org/drawingml/2006/main">
               <a:ext uri="{FF2B5EF4-FFF2-40B4-BE49-F238E27FC236}">
-                <a16:creationId xmlns:a16="http://schemas.microsoft.com/office/drawing/2014/main" id="{E1F52606-7E94-4220-AFE6-8459C35F60CB}"/>
+                <a16:creationId xmlns:a16="http://schemas.microsoft.com/office/drawing/2014/main" id="{B90E651F-E670-43EE-99F0-C1E070C9C0F7}"/>
               </a:ext>
             </a:extLst>
           </p:cNvPr>
@@ -13796,7 +13796,7 @@
         </p:xfrm>
         <a:graphic xmlns:a="http://schemas.openxmlformats.org/drawingml/2006/main">
           <a:graphicData uri="http://schemas.openxmlformats.org/drawingml/2006/chart">
-            <c:chart xmlns:r="http://schemas.openxmlformats.org/officeDocument/2006/relationships" xmlns:c="http://schemas.openxmlformats.org/drawingml/2006/chart" r:id="Rbd6092d2db6440a7"/>
+            <c:chart xmlns:r="http://schemas.openxmlformats.org/officeDocument/2006/relationships" xmlns:c="http://schemas.openxmlformats.org/drawingml/2006/chart" r:id="R71e75670dc94424f"/>
           </a:graphicData>
         </a:graphic>
       </p:graphicFrame>
@@ -13805,7 +13805,7 @@
           <p:cNvPr id="545" name="">
             <a:extLst xmlns:a="http://schemas.openxmlformats.org/drawingml/2006/main">
               <a:ext uri="{FF2B5EF4-FFF2-40B4-BE49-F238E27FC236}">
-                <a16:creationId xmlns:a16="http://schemas.microsoft.com/office/drawing/2014/main" id="{EA137BBD-3A2F-4BDE-A1AD-939862328996}"/>
+                <a16:creationId xmlns:a16="http://schemas.microsoft.com/office/drawing/2014/main" id="{13763ED7-3FAA-4825-BF81-96789549A81F}"/>
               </a:ext>
             </a:extLst>
           </p:cNvPr>
@@ -13862,7 +13862,7 @@
           <p:cNvPr id="546" name="">
             <a:extLst xmlns:a="http://schemas.openxmlformats.org/drawingml/2006/main">
               <a:ext uri="{FF2B5EF4-FFF2-40B4-BE49-F238E27FC236}">
-                <a16:creationId xmlns:a16="http://schemas.microsoft.com/office/drawing/2014/main" id="{EE83FA59-6DDE-46BA-BF43-D975FE8EFDCE}"/>
+                <a16:creationId xmlns:a16="http://schemas.microsoft.com/office/drawing/2014/main" id="{464BFCF4-E5C8-40C6-A197-8DEADAAAFC98}"/>
               </a:ext>
             </a:extLst>
           </p:cNvPr>
@@ -13919,7 +13919,7 @@
           <p:cNvPr id="547" name="">
             <a:extLst xmlns:a="http://schemas.openxmlformats.org/drawingml/2006/main">
               <a:ext uri="{FF2B5EF4-FFF2-40B4-BE49-F238E27FC236}">
-                <a16:creationId xmlns:a16="http://schemas.microsoft.com/office/drawing/2014/main" id="{DF6F92D0-3B71-457B-9D22-0EFCA26D79E5}"/>
+                <a16:creationId xmlns:a16="http://schemas.microsoft.com/office/drawing/2014/main" id="{8DA8E333-8C7D-4318-B647-CF680450D71E}"/>
               </a:ext>
             </a:extLst>
           </p:cNvPr>
@@ -13976,7 +13976,7 @@
           <p:cNvPr id="548" name="">
             <a:extLst xmlns:a="http://schemas.openxmlformats.org/drawingml/2006/main">
               <a:ext uri="{FF2B5EF4-FFF2-40B4-BE49-F238E27FC236}">
-                <a16:creationId xmlns:a16="http://schemas.microsoft.com/office/drawing/2014/main" id="{F68683B4-0B1E-464D-BE46-D2FFA0E9DF3D}"/>
+                <a16:creationId xmlns:a16="http://schemas.microsoft.com/office/drawing/2014/main" id="{ECDE2224-6B22-42AD-BAF2-7581ED299679}"/>
               </a:ext>
             </a:extLst>
           </p:cNvPr>
@@ -14033,7 +14033,7 @@
           <p:cNvPr id="549" name="">
             <a:extLst xmlns:a="http://schemas.openxmlformats.org/drawingml/2006/main">
               <a:ext uri="{FF2B5EF4-FFF2-40B4-BE49-F238E27FC236}">
-                <a16:creationId xmlns:a16="http://schemas.microsoft.com/office/drawing/2014/main" id="{15A4692A-4F6C-4349-8F95-8E811CE73C83}"/>
+                <a16:creationId xmlns:a16="http://schemas.microsoft.com/office/drawing/2014/main" id="{B462EFF5-8F44-45F6-960D-C530AD2A140E}"/>
               </a:ext>
             </a:extLst>
           </p:cNvPr>
@@ -14090,7 +14090,7 @@
           <p:cNvPr id="550" name="">
             <a:extLst xmlns:a="http://schemas.openxmlformats.org/drawingml/2006/main">
               <a:ext uri="{FF2B5EF4-FFF2-40B4-BE49-F238E27FC236}">
-                <a16:creationId xmlns:a16="http://schemas.microsoft.com/office/drawing/2014/main" id="{34AE7D68-04B0-4B45-AE8F-66FB0C452002}"/>
+                <a16:creationId xmlns:a16="http://schemas.microsoft.com/office/drawing/2014/main" id="{C5C4CA85-7FE0-4DFF-82F8-D1E85AA9D953}"/>
               </a:ext>
             </a:extLst>
           </p:cNvPr>
@@ -14211,7 +14211,7 @@
                 <a:latin typeface="Helvetica Neue"/>
                 <a:ea typeface="Helvetica Neue"/>
                 <a:cs typeface="Helvetica Neue"/>
-                <a:hlinkClick xmlns:r="http://schemas.openxmlformats.org/officeDocument/2006/relationships" r:id="Ra2c27b9a2a324eab"/>
+                <a:hlinkClick xmlns:r="http://schemas.openxmlformats.org/officeDocument/2006/relationships" r:id="R936a3a84c2e64a18"/>
               </a:rPr>
               <a:t>Source: our earlier Qwen timing records and W&amp;B</a:t>
             </a:r>
@@ -14330,7 +14330,7 @@
           <p:cNvPr id="534" name="">
             <a:extLst xmlns:a="http://schemas.openxmlformats.org/drawingml/2006/main">
               <a:ext uri="{FF2B5EF4-FFF2-40B4-BE49-F238E27FC236}">
-                <a16:creationId xmlns:a16="http://schemas.microsoft.com/office/drawing/2014/main" id="{81FF8F61-3109-46AF-8808-30501EE579E0}"/>
+                <a16:creationId xmlns:a16="http://schemas.microsoft.com/office/drawing/2014/main" id="{655841DF-CF1A-4A7D-9A5C-AB8125C14B3A}"/>
               </a:ext>
             </a:extLst>
           </p:cNvPr>
@@ -14410,7 +14410,7 @@
           <p:cNvPr id="535" name="">
             <a:extLst xmlns:a="http://schemas.openxmlformats.org/drawingml/2006/main">
               <a:ext uri="{FF2B5EF4-FFF2-40B4-BE49-F238E27FC236}">
-                <a16:creationId xmlns:a16="http://schemas.microsoft.com/office/drawing/2014/main" id="{125ADB0C-88B9-4141-AD8E-7976BBE9B3A5}"/>
+                <a16:creationId xmlns:a16="http://schemas.microsoft.com/office/drawing/2014/main" id="{E17FA96B-3CD8-47A4-A920-B22DBF2ACE76}"/>
               </a:ext>
             </a:extLst>
           </p:cNvPr>
@@ -14474,7 +14474,7 @@
         </p:xfrm>
         <a:graphic xmlns:a="http://schemas.openxmlformats.org/drawingml/2006/main">
           <a:graphicData uri="http://schemas.openxmlformats.org/drawingml/2006/chart">
-            <c:chart xmlns:r="http://schemas.openxmlformats.org/officeDocument/2006/relationships" xmlns:c="http://schemas.openxmlformats.org/drawingml/2006/chart" r:id="R86f0201671574b34"/>
+            <c:chart xmlns:r="http://schemas.openxmlformats.org/officeDocument/2006/relationships" xmlns:c="http://schemas.openxmlformats.org/drawingml/2006/chart" r:id="R3f4f3bf280564aff"/>
           </a:graphicData>
         </a:graphic>
       </p:graphicFrame>
@@ -14483,7 +14483,7 @@
           <p:cNvPr id="537" name="">
             <a:extLst xmlns:a="http://schemas.openxmlformats.org/drawingml/2006/main">
               <a:ext uri="{FF2B5EF4-FFF2-40B4-BE49-F238E27FC236}">
-                <a16:creationId xmlns:a16="http://schemas.microsoft.com/office/drawing/2014/main" id="{14448329-8CC2-4BDC-A45A-3EB8A189CF5F}"/>
+                <a16:creationId xmlns:a16="http://schemas.microsoft.com/office/drawing/2014/main" id="{F8B4E07D-FB4D-4E64-851C-B96D72D56BC1}"/>
               </a:ext>
             </a:extLst>
           </p:cNvPr>
@@ -14540,7 +14540,7 @@
           <p:cNvPr id="538" name="">
             <a:extLst xmlns:a="http://schemas.openxmlformats.org/drawingml/2006/main">
               <a:ext uri="{FF2B5EF4-FFF2-40B4-BE49-F238E27FC236}">
-                <a16:creationId xmlns:a16="http://schemas.microsoft.com/office/drawing/2014/main" id="{0A66C0E9-D83D-4587-B715-81123610C9F1}"/>
+                <a16:creationId xmlns:a16="http://schemas.microsoft.com/office/drawing/2014/main" id="{8562DFF0-B67C-45B6-9E9C-EC477C06F3AE}"/>
               </a:ext>
             </a:extLst>
           </p:cNvPr>
@@ -14597,7 +14597,7 @@
           <p:cNvPr id="539" name="">
             <a:extLst xmlns:a="http://schemas.openxmlformats.org/drawingml/2006/main">
               <a:ext uri="{FF2B5EF4-FFF2-40B4-BE49-F238E27FC236}">
-                <a16:creationId xmlns:a16="http://schemas.microsoft.com/office/drawing/2014/main" id="{5FC9E004-C376-4126-AF78-EC5570C45EFE}"/>
+                <a16:creationId xmlns:a16="http://schemas.microsoft.com/office/drawing/2014/main" id="{1F6EB225-8DB7-4FBD-8A8F-8F71FEDAABEE}"/>
               </a:ext>
             </a:extLst>
           </p:cNvPr>
@@ -14661,7 +14661,7 @@
         </p:xfrm>
         <a:graphic xmlns:a="http://schemas.openxmlformats.org/drawingml/2006/main">
           <a:graphicData uri="http://schemas.openxmlformats.org/drawingml/2006/chart">
-            <c:chart xmlns:r="http://schemas.openxmlformats.org/officeDocument/2006/relationships" xmlns:c="http://schemas.openxmlformats.org/drawingml/2006/chart" r:id="R52a88d8d04034858"/>
+            <c:chart xmlns:r="http://schemas.openxmlformats.org/officeDocument/2006/relationships" xmlns:c="http://schemas.openxmlformats.org/drawingml/2006/chart" r:id="R0dd59f08aed54d86"/>
           </a:graphicData>
         </a:graphic>
       </p:graphicFrame>
@@ -14670,7 +14670,7 @@
           <p:cNvPr id="541" name="">
             <a:extLst xmlns:a="http://schemas.openxmlformats.org/drawingml/2006/main">
               <a:ext uri="{FF2B5EF4-FFF2-40B4-BE49-F238E27FC236}">
-                <a16:creationId xmlns:a16="http://schemas.microsoft.com/office/drawing/2014/main" id="{B1FBB7F0-741A-47FB-8CE2-5A9859CE2FBD}"/>
+                <a16:creationId xmlns:a16="http://schemas.microsoft.com/office/drawing/2014/main" id="{73FC9402-FBAB-4F02-A798-772127534D45}"/>
               </a:ext>
             </a:extLst>
           </p:cNvPr>
@@ -14727,7 +14727,7 @@
           <p:cNvPr id="542" name="">
             <a:extLst xmlns:a="http://schemas.openxmlformats.org/drawingml/2006/main">
               <a:ext uri="{FF2B5EF4-FFF2-40B4-BE49-F238E27FC236}">
-                <a16:creationId xmlns:a16="http://schemas.microsoft.com/office/drawing/2014/main" id="{7EEC9BF0-6FCD-4D03-B0E1-516B5FB891AF}"/>
+                <a16:creationId xmlns:a16="http://schemas.microsoft.com/office/drawing/2014/main" id="{EDA147FA-6092-4ECF-8D33-4C8AEED0751E}"/>
               </a:ext>
             </a:extLst>
           </p:cNvPr>
@@ -14784,7 +14784,7 @@
           <p:cNvPr id="543" name="">
             <a:extLst xmlns:a="http://schemas.openxmlformats.org/drawingml/2006/main">
               <a:ext uri="{FF2B5EF4-FFF2-40B4-BE49-F238E27FC236}">
-                <a16:creationId xmlns:a16="http://schemas.microsoft.com/office/drawing/2014/main" id="{136C8AA4-AAC3-4CD5-B950-62C78AF5413B}"/>
+                <a16:creationId xmlns:a16="http://schemas.microsoft.com/office/drawing/2014/main" id="{9FCDCBED-C29B-4D5F-8DC3-4C8267197EB1}"/>
               </a:ext>
             </a:extLst>
           </p:cNvPr>
@@ -14841,7 +14841,7 @@
           <p:cNvPr id="544" name="">
             <a:extLst xmlns:a="http://schemas.openxmlformats.org/drawingml/2006/main">
               <a:ext uri="{FF2B5EF4-FFF2-40B4-BE49-F238E27FC236}">
-                <a16:creationId xmlns:a16="http://schemas.microsoft.com/office/drawing/2014/main" id="{5D546989-CED7-4D97-BE4B-7613F43DF801}"/>
+                <a16:creationId xmlns:a16="http://schemas.microsoft.com/office/drawing/2014/main" id="{2A06ECA2-600B-492B-AE26-049A4A710ECE}"/>
               </a:ext>
             </a:extLst>
           </p:cNvPr>
@@ -14898,7 +14898,7 @@
           <p:cNvPr id="545" name="">
             <a:extLst xmlns:a="http://schemas.openxmlformats.org/drawingml/2006/main">
               <a:ext uri="{FF2B5EF4-FFF2-40B4-BE49-F238E27FC236}">
-                <a16:creationId xmlns:a16="http://schemas.microsoft.com/office/drawing/2014/main" id="{178F6EE5-D6A6-4C25-B1F0-07C6B8911EF4}"/>
+                <a16:creationId xmlns:a16="http://schemas.microsoft.com/office/drawing/2014/main" id="{C6144AF5-8F46-445E-97F5-A8A406247BF5}"/>
               </a:ext>
             </a:extLst>
           </p:cNvPr>
@@ -14955,7 +14955,7 @@
           <p:cNvPr id="546" name="">
             <a:extLst xmlns:a="http://schemas.openxmlformats.org/drawingml/2006/main">
               <a:ext uri="{FF2B5EF4-FFF2-40B4-BE49-F238E27FC236}">
-                <a16:creationId xmlns:a16="http://schemas.microsoft.com/office/drawing/2014/main" id="{FEAA2404-D5F4-4350-8F63-29A48A8401E3}"/>
+                <a16:creationId xmlns:a16="http://schemas.microsoft.com/office/drawing/2014/main" id="{261C4478-4DEC-4006-9AAE-3D05E56C38AE}"/>
               </a:ext>
             </a:extLst>
           </p:cNvPr>
@@ -15076,7 +15076,7 @@
                 <a:latin typeface="Helvetica Neue"/>
                 <a:ea typeface="Helvetica Neue"/>
                 <a:cs typeface="Helvetica Neue"/>
-                <a:hlinkClick xmlns:r="http://schemas.openxmlformats.org/officeDocument/2006/relationships" r:id="Rdfd2d18570b24a16"/>
+                <a:hlinkClick xmlns:r="http://schemas.openxmlformats.org/officeDocument/2006/relationships" r:id="R2cac0dc7b2484e48"/>
               </a:rPr>
               <a:t>Source: our saved requests, timing summaries and telemetry</a:t>
             </a:r>
@@ -15195,7 +15195,7 @@
           <p:cNvPr id="534" name="">
             <a:extLst xmlns:a="http://schemas.openxmlformats.org/drawingml/2006/main">
               <a:ext uri="{FF2B5EF4-FFF2-40B4-BE49-F238E27FC236}">
-                <a16:creationId xmlns:a16="http://schemas.microsoft.com/office/drawing/2014/main" id="{18102ED5-7743-48EA-9FA9-5D0EE1FBAA80}"/>
+                <a16:creationId xmlns:a16="http://schemas.microsoft.com/office/drawing/2014/main" id="{A3A15B4C-BA2A-4522-8555-5DB3DAD9151F}"/>
               </a:ext>
             </a:extLst>
           </p:cNvPr>
@@ -15252,7 +15252,7 @@
           <p:cNvPr id="535" name="">
             <a:extLst xmlns:a="http://schemas.openxmlformats.org/drawingml/2006/main">
               <a:ext uri="{FF2B5EF4-FFF2-40B4-BE49-F238E27FC236}">
-                <a16:creationId xmlns:a16="http://schemas.microsoft.com/office/drawing/2014/main" id="{69C65030-68A6-49A3-A65D-AE5B5E71D5B2}"/>
+                <a16:creationId xmlns:a16="http://schemas.microsoft.com/office/drawing/2014/main" id="{C7704FEC-8FC8-4D3B-A890-07D17F17CD7F}"/>
               </a:ext>
             </a:extLst>
           </p:cNvPr>
@@ -15316,7 +15316,7 @@
         </p:xfrm>
         <a:graphic xmlns:a="http://schemas.openxmlformats.org/drawingml/2006/main">
           <a:graphicData uri="http://schemas.openxmlformats.org/drawingml/2006/chart">
-            <c:chart xmlns:r="http://schemas.openxmlformats.org/officeDocument/2006/relationships" xmlns:c="http://schemas.openxmlformats.org/drawingml/2006/chart" r:id="Rd4d283f52eaf4e32"/>
+            <c:chart xmlns:r="http://schemas.openxmlformats.org/officeDocument/2006/relationships" xmlns:c="http://schemas.openxmlformats.org/drawingml/2006/chart" r:id="R592e3f30b1104688"/>
           </a:graphicData>
         </a:graphic>
       </p:graphicFrame>
@@ -15325,7 +15325,7 @@
           <p:cNvPr id="537" name="">
             <a:extLst xmlns:a="http://schemas.openxmlformats.org/drawingml/2006/main">
               <a:ext uri="{FF2B5EF4-FFF2-40B4-BE49-F238E27FC236}">
-                <a16:creationId xmlns:a16="http://schemas.microsoft.com/office/drawing/2014/main" id="{46C355B4-5D02-45C4-BE21-CEF094A8CA99}"/>
+                <a16:creationId xmlns:a16="http://schemas.microsoft.com/office/drawing/2014/main" id="{EA3958BA-69CF-4AC9-83F6-C0F1BDA4CFB3}"/>
               </a:ext>
             </a:extLst>
           </p:cNvPr>
@@ -15389,7 +15389,7 @@
         </p:xfrm>
         <a:graphic xmlns:a="http://schemas.openxmlformats.org/drawingml/2006/main">
           <a:graphicData uri="http://schemas.openxmlformats.org/drawingml/2006/chart">
-            <c:chart xmlns:r="http://schemas.openxmlformats.org/officeDocument/2006/relationships" xmlns:c="http://schemas.openxmlformats.org/drawingml/2006/chart" r:id="R61e859bc2170491a"/>
+            <c:chart xmlns:r="http://schemas.openxmlformats.org/officeDocument/2006/relationships" xmlns:c="http://schemas.openxmlformats.org/drawingml/2006/chart" r:id="Rfba47a542b6e4526"/>
           </a:graphicData>
         </a:graphic>
       </p:graphicFrame>
@@ -15398,7 +15398,7 @@
           <p:cNvPr id="539" name="">
             <a:extLst xmlns:a="http://schemas.openxmlformats.org/drawingml/2006/main">
               <a:ext uri="{FF2B5EF4-FFF2-40B4-BE49-F238E27FC236}">
-                <a16:creationId xmlns:a16="http://schemas.microsoft.com/office/drawing/2014/main" id="{5B403DDF-8807-4BCA-9049-98A8E624263C}"/>
+                <a16:creationId xmlns:a16="http://schemas.microsoft.com/office/drawing/2014/main" id="{C83E8897-CFF1-425F-A300-FDA84A108186}"/>
               </a:ext>
             </a:extLst>
           </p:cNvPr>
@@ -15462,7 +15462,7 @@
         </p:xfrm>
         <a:graphic xmlns:a="http://schemas.openxmlformats.org/drawingml/2006/main">
           <a:graphicData uri="http://schemas.openxmlformats.org/drawingml/2006/chart">
-            <c:chart xmlns:r="http://schemas.openxmlformats.org/officeDocument/2006/relationships" xmlns:c="http://schemas.openxmlformats.org/drawingml/2006/chart" r:id="R71210c325dda437c"/>
+            <c:chart xmlns:r="http://schemas.openxmlformats.org/officeDocument/2006/relationships" xmlns:c="http://schemas.openxmlformats.org/drawingml/2006/chart" r:id="R87f3953635a44b04"/>
           </a:graphicData>
         </a:graphic>
       </p:graphicFrame>
@@ -15471,7 +15471,7 @@
           <p:cNvPr id="541" name="">
             <a:extLst xmlns:a="http://schemas.openxmlformats.org/drawingml/2006/main">
               <a:ext uri="{FF2B5EF4-FFF2-40B4-BE49-F238E27FC236}">
-                <a16:creationId xmlns:a16="http://schemas.microsoft.com/office/drawing/2014/main" id="{F97BB1C4-C115-43E2-9D87-4EE2A28C5E7B}"/>
+                <a16:creationId xmlns:a16="http://schemas.microsoft.com/office/drawing/2014/main" id="{38CB5139-D2BD-46B6-8908-87CE4FEC77CB}"/>
               </a:ext>
             </a:extLst>
           </p:cNvPr>
@@ -15535,7 +15535,7 @@
         </p:xfrm>
         <a:graphic xmlns:a="http://schemas.openxmlformats.org/drawingml/2006/main">
           <a:graphicData uri="http://schemas.openxmlformats.org/drawingml/2006/chart">
-            <c:chart xmlns:r="http://schemas.openxmlformats.org/officeDocument/2006/relationships" xmlns:c="http://schemas.openxmlformats.org/drawingml/2006/chart" r:id="R61e8bf06a04046ee"/>
+            <c:chart xmlns:r="http://schemas.openxmlformats.org/officeDocument/2006/relationships" xmlns:c="http://schemas.openxmlformats.org/drawingml/2006/chart" r:id="Rb423fcbd91524eae"/>
           </a:graphicData>
         </a:graphic>
       </p:graphicFrame>
@@ -15608,7 +15608,7 @@
                 <a:latin typeface="Helvetica Neue"/>
                 <a:ea typeface="Helvetica Neue"/>
                 <a:cs typeface="Helvetica Neue"/>
-                <a:hlinkClick xmlns:r="http://schemas.openxmlformats.org/officeDocument/2006/relationships" r:id="R211caa8573b04b35"/>
+                <a:hlinkClick xmlns:r="http://schemas.openxmlformats.org/officeDocument/2006/relationships" r:id="R813131261af148d8"/>
               </a:rPr>
               <a:t>Our measured comparison</a:t>
             </a:r>
@@ -15628,7 +15628,7 @@
                 <a:latin typeface="Helvetica Neue"/>
                 <a:ea typeface="Helvetica Neue"/>
                 <a:cs typeface="Helvetica Neue"/>
-                <a:hlinkClick xmlns:r="http://schemas.openxmlformats.org/officeDocument/2006/relationships" r:id="Rc3bb50c5775a4fb2"/>
+                <a:hlinkClick xmlns:r="http://schemas.openxmlformats.org/officeDocument/2006/relationships" r:id="Red34c38d7c894c89"/>
               </a:rPr>
               <a:t>Post-hoc phase analysis</a:t>
             </a:r>
@@ -15747,7 +15747,7 @@
           <p:cNvPr id="534" name="">
             <a:extLst xmlns:a="http://schemas.openxmlformats.org/drawingml/2006/main">
               <a:ext uri="{FF2B5EF4-FFF2-40B4-BE49-F238E27FC236}">
-                <a16:creationId xmlns:a16="http://schemas.microsoft.com/office/drawing/2014/main" id="{B0486921-449C-4CC2-8C85-F1C911397975}"/>
+                <a16:creationId xmlns:a16="http://schemas.microsoft.com/office/drawing/2014/main" id="{B58FA6DD-87D6-47B9-99EE-770B96A53DFE}"/>
               </a:ext>
             </a:extLst>
           </p:cNvPr>
@@ -16369,7 +16369,7 @@
           <p:cNvPr id="536" name="">
             <a:extLst xmlns:a="http://schemas.openxmlformats.org/drawingml/2006/main">
               <a:ext uri="{FF2B5EF4-FFF2-40B4-BE49-F238E27FC236}">
-                <a16:creationId xmlns:a16="http://schemas.microsoft.com/office/drawing/2014/main" id="{9BD0BD84-0D5C-450E-BD5A-6B4A5393A8BB}"/>
+                <a16:creationId xmlns:a16="http://schemas.microsoft.com/office/drawing/2014/main" id="{76AF3F21-2BA3-4E29-BB30-689C9E0045BE}"/>
               </a:ext>
             </a:extLst>
           </p:cNvPr>
@@ -16426,7 +16426,7 @@
           <p:cNvPr id="537" name="">
             <a:extLst xmlns:a="http://schemas.openxmlformats.org/drawingml/2006/main">
               <a:ext uri="{FF2B5EF4-FFF2-40B4-BE49-F238E27FC236}">
-                <a16:creationId xmlns:a16="http://schemas.microsoft.com/office/drawing/2014/main" id="{3A413446-BE46-4FDC-909F-5B7778D68B46}"/>
+                <a16:creationId xmlns:a16="http://schemas.microsoft.com/office/drawing/2014/main" id="{D770F0E2-3D70-4DCD-A6F0-4B754BEDE1AF}"/>
               </a:ext>
             </a:extLst>
           </p:cNvPr>
@@ -16483,7 +16483,7 @@
           <p:cNvPr id="538" name="">
             <a:extLst xmlns:a="http://schemas.openxmlformats.org/drawingml/2006/main">
               <a:ext uri="{FF2B5EF4-FFF2-40B4-BE49-F238E27FC236}">
-                <a16:creationId xmlns:a16="http://schemas.microsoft.com/office/drawing/2014/main" id="{7232CA02-FDF9-4CA6-9039-1E494C9847A9}"/>
+                <a16:creationId xmlns:a16="http://schemas.microsoft.com/office/drawing/2014/main" id="{E922C8F4-3C44-44CA-ABF6-2E1CC679D283}"/>
               </a:ext>
             </a:extLst>
           </p:cNvPr>
@@ -16563,7 +16563,7 @@
           <p:cNvPr id="539" name="">
             <a:extLst xmlns:a="http://schemas.openxmlformats.org/drawingml/2006/main">
               <a:ext uri="{FF2B5EF4-FFF2-40B4-BE49-F238E27FC236}">
-                <a16:creationId xmlns:a16="http://schemas.microsoft.com/office/drawing/2014/main" id="{8666CAE8-1F1E-4646-B517-F306E0822855}"/>
+                <a16:creationId xmlns:a16="http://schemas.microsoft.com/office/drawing/2014/main" id="{1D5D1266-518D-4AAA-A568-F03909A2AF80}"/>
               </a:ext>
             </a:extLst>
           </p:cNvPr>
@@ -16684,7 +16684,7 @@
                 <a:latin typeface="Helvetica Neue"/>
                 <a:ea typeface="Helvetica Neue"/>
                 <a:cs typeface="Helvetica Neue"/>
-                <a:hlinkClick xmlns:r="http://schemas.openxmlformats.org/officeDocument/2006/relationships" r:id="R62505e559e1f4eb7"/>
+                <a:hlinkClick xmlns:r="http://schemas.openxmlformats.org/officeDocument/2006/relationships" r:id="R014dea2fabf94849"/>
               </a:rPr>
               <a:t>Research question and methodology assessment</a:t>
             </a:r>
@@ -16803,7 +16803,7 @@
           <p:cNvPr id="534" name="">
             <a:extLst xmlns:a="http://schemas.openxmlformats.org/drawingml/2006/main">
               <a:ext uri="{FF2B5EF4-FFF2-40B4-BE49-F238E27FC236}">
-                <a16:creationId xmlns:a16="http://schemas.microsoft.com/office/drawing/2014/main" id="{3907B1B3-4798-46BE-A69B-C89891382233}"/>
+                <a16:creationId xmlns:a16="http://schemas.microsoft.com/office/drawing/2014/main" id="{3FB3C1EF-36EF-4CF8-93F0-D663197A01E4}"/>
               </a:ext>
             </a:extLst>
           </p:cNvPr>
@@ -16860,7 +16860,7 @@
           <p:cNvPr id="535" name="">
             <a:extLst xmlns:a="http://schemas.openxmlformats.org/drawingml/2006/main">
               <a:ext uri="{FF2B5EF4-FFF2-40B4-BE49-F238E27FC236}">
-                <a16:creationId xmlns:a16="http://schemas.microsoft.com/office/drawing/2014/main" id="{0E6016FB-E64D-4503-BC00-6CDCB0CDA757}"/>
+                <a16:creationId xmlns:a16="http://schemas.microsoft.com/office/drawing/2014/main" id="{E4580DD1-1521-45FA-BC0F-CC231AF0795E}"/>
               </a:ext>
             </a:extLst>
           </p:cNvPr>
@@ -16917,7 +16917,7 @@
           <p:cNvPr id="536" name="">
             <a:extLst xmlns:a="http://schemas.openxmlformats.org/drawingml/2006/main">
               <a:ext uri="{FF2B5EF4-FFF2-40B4-BE49-F238E27FC236}">
-                <a16:creationId xmlns:a16="http://schemas.microsoft.com/office/drawing/2014/main" id="{49555BD6-1768-450F-9CC2-DF602AA6CEB5}"/>
+                <a16:creationId xmlns:a16="http://schemas.microsoft.com/office/drawing/2014/main" id="{32D55B0F-BE41-4EA8-8640-1BF0296D88D1}"/>
               </a:ext>
             </a:extLst>
           </p:cNvPr>
@@ -16974,7 +16974,7 @@
           <p:cNvPr id="537" name="">
             <a:extLst xmlns:a="http://schemas.openxmlformats.org/drawingml/2006/main">
               <a:ext uri="{FF2B5EF4-FFF2-40B4-BE49-F238E27FC236}">
-                <a16:creationId xmlns:a16="http://schemas.microsoft.com/office/drawing/2014/main" id="{8F5F8AF9-2BDB-4B12-8045-A7DF29CD8BC1}"/>
+                <a16:creationId xmlns:a16="http://schemas.microsoft.com/office/drawing/2014/main" id="{64C3548B-16FD-44F7-9734-106DD600148B}"/>
               </a:ext>
             </a:extLst>
           </p:cNvPr>
@@ -17031,7 +17031,7 @@
           <p:cNvPr id="538" name="">
             <a:extLst xmlns:a="http://schemas.openxmlformats.org/drawingml/2006/main">
               <a:ext uri="{FF2B5EF4-FFF2-40B4-BE49-F238E27FC236}">
-                <a16:creationId xmlns:a16="http://schemas.microsoft.com/office/drawing/2014/main" id="{DC0AE93E-28EE-456E-8898-3EC6850ACE47}"/>
+                <a16:creationId xmlns:a16="http://schemas.microsoft.com/office/drawing/2014/main" id="{5D16B9CB-6E76-4A3E-8F30-29C542DFA13A}"/>
               </a:ext>
             </a:extLst>
           </p:cNvPr>
@@ -17088,7 +17088,7 @@
           <p:cNvPr id="539" name="">
             <a:extLst xmlns:a="http://schemas.openxmlformats.org/drawingml/2006/main">
               <a:ext uri="{FF2B5EF4-FFF2-40B4-BE49-F238E27FC236}">
-                <a16:creationId xmlns:a16="http://schemas.microsoft.com/office/drawing/2014/main" id="{C58D1D43-3EA3-48CE-8347-88D11C326E2B}"/>
+                <a16:creationId xmlns:a16="http://schemas.microsoft.com/office/drawing/2014/main" id="{B0F7D76A-0A39-4944-ADD2-4C46AE5C9768}"/>
               </a:ext>
             </a:extLst>
           </p:cNvPr>
@@ -17145,7 +17145,7 @@
           <p:cNvPr id="540" name="">
             <a:extLst xmlns:a="http://schemas.openxmlformats.org/drawingml/2006/main">
               <a:ext uri="{FF2B5EF4-FFF2-40B4-BE49-F238E27FC236}">
-                <a16:creationId xmlns:a16="http://schemas.microsoft.com/office/drawing/2014/main" id="{D4A89EE0-9E80-49BF-BB31-746520F27E80}"/>
+                <a16:creationId xmlns:a16="http://schemas.microsoft.com/office/drawing/2014/main" id="{5F6E2162-F808-4D88-8F44-4A1E48050702}"/>
               </a:ext>
             </a:extLst>
           </p:cNvPr>
@@ -17266,7 +17266,7 @@
                 <a:latin typeface="Helvetica Neue"/>
                 <a:ea typeface="Helvetica Neue"/>
                 <a:cs typeface="Helvetica Neue"/>
-                <a:hlinkClick xmlns:r="http://schemas.openxmlformats.org/officeDocument/2006/relationships" r:id="R3bca53cd85e34755"/>
+                <a:hlinkClick xmlns:r="http://schemas.openxmlformats.org/officeDocument/2006/relationships" r:id="Rd6b5dad5bdcf4f78"/>
               </a:rPr>
               <a:t>Full references and additional background</a:t>
             </a:r>
@@ -17385,7 +17385,7 @@
           <p:cNvPr id="534" name="">
             <a:extLst xmlns:a="http://schemas.openxmlformats.org/drawingml/2006/main">
               <a:ext uri="{FF2B5EF4-FFF2-40B4-BE49-F238E27FC236}">
-                <a16:creationId xmlns:a16="http://schemas.microsoft.com/office/drawing/2014/main" id="{9A45E733-4A67-40A6-A9B6-2E8A33AE6B43}"/>
+                <a16:creationId xmlns:a16="http://schemas.microsoft.com/office/drawing/2014/main" id="{D8125F7F-FC7D-4A52-B393-DB362BFCB330}"/>
               </a:ext>
             </a:extLst>
           </p:cNvPr>
@@ -17431,7 +17431,7 @@
                 <a:latin typeface="Helvetica Neue"/>
                 <a:ea typeface="Helvetica Neue"/>
                 <a:cs typeface="Helvetica Neue"/>
-                <a:hlinkClick xmlns:r="http://schemas.openxmlformats.org/officeDocument/2006/relationships" r:id="R7f5c276281174b90"/>
+                <a:hlinkClick xmlns:r="http://schemas.openxmlformats.org/officeDocument/2006/relationships" r:id="R0d4276af2e52447d"/>
               </a:rPr>
               <a:t>[1] Hong et al. SOLA: state-aware scheduling. MLSys 2025. Figure 1</a:t>
             </a:r>
@@ -17443,7 +17443,7 @@
           <p:cNvPr id="535" name="">
             <a:extLst xmlns:a="http://schemas.openxmlformats.org/drawingml/2006/main">
               <a:ext uri="{FF2B5EF4-FFF2-40B4-BE49-F238E27FC236}">
-                <a16:creationId xmlns:a16="http://schemas.microsoft.com/office/drawing/2014/main" id="{21EFDA27-3B67-4834-8E39-9495653BAC81}"/>
+                <a16:creationId xmlns:a16="http://schemas.microsoft.com/office/drawing/2014/main" id="{05A2A0A7-BDBF-4D28-8FF6-E833067D24FA}"/>
               </a:ext>
             </a:extLst>
           </p:cNvPr>
@@ -17489,7 +17489,7 @@
                 <a:latin typeface="Helvetica Neue"/>
                 <a:ea typeface="Helvetica Neue"/>
                 <a:cs typeface="Helvetica Neue"/>
-                <a:hlinkClick xmlns:r="http://schemas.openxmlformats.org/officeDocument/2006/relationships" r:id="Rc412ea549423417c"/>
+                <a:hlinkClick xmlns:r="http://schemas.openxmlformats.org/officeDocument/2006/relationships" r:id="R83ec86b4f6994f93"/>
               </a:rPr>
               <a:t>[2] Gao et al. DuetServe: adaptive GPU multiplexing. ICML 2026. Figure 6</a:t>
             </a:r>
@@ -17501,7 +17501,7 @@
           <p:cNvPr id="536" name="">
             <a:extLst xmlns:a="http://schemas.openxmlformats.org/drawingml/2006/main">
               <a:ext uri="{FF2B5EF4-FFF2-40B4-BE49-F238E27FC236}">
-                <a16:creationId xmlns:a16="http://schemas.microsoft.com/office/drawing/2014/main" id="{335E5FD1-7FD2-49A9-9CBD-F0DC186B230F}"/>
+                <a16:creationId xmlns:a16="http://schemas.microsoft.com/office/drawing/2014/main" id="{282C3880-2B4C-488B-9CB1-A586EE4DD0D4}"/>
               </a:ext>
             </a:extLst>
           </p:cNvPr>
@@ -17547,7 +17547,7 @@
                 <a:latin typeface="Helvetica Neue"/>
                 <a:ea typeface="Helvetica Neue"/>
                 <a:cs typeface="Helvetica Neue"/>
-                <a:hlinkClick xmlns:r="http://schemas.openxmlformats.org/officeDocument/2006/relationships" r:id="Rb7d9ff4cc3944176"/>
+                <a:hlinkClick xmlns:r="http://schemas.openxmlformats.org/officeDocument/2006/relationships" r:id="R56c1497504254250"/>
               </a:rPr>
               <a:t>[3] Yang et al. GPU-disaggregated DLRM serving. NSDI 2025. Figure 17</a:t>
             </a:r>
@@ -17559,7 +17559,7 @@
           <p:cNvPr id="537" name="">
             <a:extLst xmlns:a="http://schemas.openxmlformats.org/drawingml/2006/main">
               <a:ext uri="{FF2B5EF4-FFF2-40B4-BE49-F238E27FC236}">
-                <a16:creationId xmlns:a16="http://schemas.microsoft.com/office/drawing/2014/main" id="{FEE1E120-FCAC-4B76-93A0-9486EBB65335}"/>
+                <a16:creationId xmlns:a16="http://schemas.microsoft.com/office/drawing/2014/main" id="{64E6207F-2429-499D-A186-8AD4E3562826}"/>
               </a:ext>
             </a:extLst>
           </p:cNvPr>
@@ -17605,7 +17605,7 @@
                 <a:latin typeface="Helvetica Neue"/>
                 <a:ea typeface="Helvetica Neue"/>
                 <a:cs typeface="Helvetica Neue"/>
-                <a:hlinkClick xmlns:r="http://schemas.openxmlformats.org/officeDocument/2006/relationships" r:id="R31dcaeac50c24afb"/>
+                <a:hlinkClick xmlns:r="http://schemas.openxmlformats.org/officeDocument/2006/relationships" r:id="R5f8af2e629d74c16"/>
               </a:rPr>
               <a:t>[4] NVIDIA. Tuning CUDA graph batch sizes. Engineering report, August 2026</a:t>
             </a:r>
@@ -17617,7 +17617,7 @@
           <p:cNvPr id="538" name="">
             <a:extLst xmlns:a="http://schemas.openxmlformats.org/drawingml/2006/main">
               <a:ext uri="{FF2B5EF4-FFF2-40B4-BE49-F238E27FC236}">
-                <a16:creationId xmlns:a16="http://schemas.microsoft.com/office/drawing/2014/main" id="{6EDFF1F0-AC76-4A13-AF16-2484037D04CA}"/>
+                <a16:creationId xmlns:a16="http://schemas.microsoft.com/office/drawing/2014/main" id="{6EFAF33D-052D-43B0-86C2-4DA9FFA7B26B}"/>
               </a:ext>
             </a:extLst>
           </p:cNvPr>
@@ -17663,7 +17663,7 @@
                 <a:latin typeface="Helvetica Neue"/>
                 <a:ea typeface="Helvetica Neue"/>
                 <a:cs typeface="Helvetica Neue"/>
-                <a:hlinkClick xmlns:r="http://schemas.openxmlformats.org/officeDocument/2006/relationships" r:id="R315718e387d04b30"/>
+                <a:hlinkClick xmlns:r="http://schemas.openxmlformats.org/officeDocument/2006/relationships" r:id="R29eb873dd0c040f1"/>
               </a:rPr>
               <a:t>[5] vLLM. CUDA graph design and serving implementation documentation</a:t>
             </a:r>
@@ -17675,7 +17675,7 @@
           <p:cNvPr id="539" name="">
             <a:extLst xmlns:a="http://schemas.openxmlformats.org/drawingml/2006/main">
               <a:ext uri="{FF2B5EF4-FFF2-40B4-BE49-F238E27FC236}">
-                <a16:creationId xmlns:a16="http://schemas.microsoft.com/office/drawing/2014/main" id="{1218E013-661C-46B7-9593-0A83C0795B11}"/>
+                <a16:creationId xmlns:a16="http://schemas.microsoft.com/office/drawing/2014/main" id="{35A3F282-27A4-4645-A1F1-BF4A9758BDE4}"/>
               </a:ext>
             </a:extLst>
           </p:cNvPr>
@@ -17721,7 +17721,7 @@
                 <a:latin typeface="Helvetica Neue"/>
                 <a:ea typeface="Helvetica Neue"/>
                 <a:cs typeface="Helvetica Neue"/>
-                <a:hlinkClick xmlns:r="http://schemas.openxmlformats.org/officeDocument/2006/relationships" r:id="R9b6dd55a095b455a"/>
+                <a:hlinkClick xmlns:r="http://schemas.openxmlformats.org/officeDocument/2006/relationships" r:id="R7095c60cca2944e4"/>
               </a:rPr>
               <a:t>[6] NVIDIA. NVML GPU-utilization metric definition</a:t>
             </a:r>
@@ -17733,7 +17733,7 @@
           <p:cNvPr id="540" name="">
             <a:extLst xmlns:a="http://schemas.openxmlformats.org/drawingml/2006/main">
               <a:ext uri="{FF2B5EF4-FFF2-40B4-BE49-F238E27FC236}">
-                <a16:creationId xmlns:a16="http://schemas.microsoft.com/office/drawing/2014/main" id="{B5191D1A-53C3-44CE-9D73-E3BA930DD2A7}"/>
+                <a16:creationId xmlns:a16="http://schemas.microsoft.com/office/drawing/2014/main" id="{165264F9-2117-4A91-B97D-C550A29F0864}"/>
               </a:ext>
             </a:extLst>
           </p:cNvPr>
@@ -17779,7 +17779,7 @@
                 <a:latin typeface="Helvetica Neue"/>
                 <a:ea typeface="Helvetica Neue"/>
                 <a:cs typeface="Helvetica Neue"/>
-                <a:hlinkClick xmlns:r="http://schemas.openxmlformats.org/officeDocument/2006/relationships" r:id="R4ecde6c44bec42fd"/>
+                <a:hlinkClick xmlns:r="http://schemas.openxmlformats.org/officeDocument/2006/relationships" r:id="Rf82f88f2bf2948e3"/>
               </a:rPr>
               <a:t>[7] Official model and WikiText revisions: saved experiment manifests</a:t>
             </a:r>
@@ -17791,7 +17791,7 @@
           <p:cNvPr id="541" name="">
             <a:extLst xmlns:a="http://schemas.openxmlformats.org/drawingml/2006/main">
               <a:ext uri="{FF2B5EF4-FFF2-40B4-BE49-F238E27FC236}">
-                <a16:creationId xmlns:a16="http://schemas.microsoft.com/office/drawing/2014/main" id="{A1AC1ECE-8382-451C-BCA5-07340A47F222}"/>
+                <a16:creationId xmlns:a16="http://schemas.microsoft.com/office/drawing/2014/main" id="{0E2D9647-02C1-46B3-8D12-987242F393F9}"/>
               </a:ext>
             </a:extLst>
           </p:cNvPr>
@@ -17837,7 +17837,7 @@
                 <a:latin typeface="Helvetica Neue"/>
                 <a:ea typeface="Helvetica Neue"/>
                 <a:cs typeface="Helvetica Neue"/>
-                <a:hlinkClick xmlns:r="http://schemas.openxmlformats.org/officeDocument/2006/relationships" r:id="R928e29f49ebb4906"/>
+                <a:hlinkClick xmlns:r="http://schemas.openxmlformats.org/officeDocument/2006/relationships" r:id="R9f9de0ef98f74f68"/>
               </a:rPr>
               <a:t>[8] Our experiment code, raw results, graph data and full bibliography</a:t>
             </a:r>
@@ -17849,7 +17849,7 @@
           <p:cNvPr id="542" name="">
             <a:extLst xmlns:a="http://schemas.openxmlformats.org/drawingml/2006/main">
               <a:ext uri="{FF2B5EF4-FFF2-40B4-BE49-F238E27FC236}">
-                <a16:creationId xmlns:a16="http://schemas.microsoft.com/office/drawing/2014/main" id="{6ACEFE6B-374E-42E7-AC39-DF442428DBF8}"/>
+                <a16:creationId xmlns:a16="http://schemas.microsoft.com/office/drawing/2014/main" id="{7AA2F5AD-9CA0-4B6B-9D65-541E06A5C0C9}"/>
               </a:ext>
             </a:extLst>
           </p:cNvPr>
@@ -17895,7 +17895,7 @@
                 <a:latin typeface="Helvetica Neue"/>
                 <a:ea typeface="Helvetica Neue"/>
                 <a:cs typeface="Helvetica Neue"/>
-                <a:hlinkClick xmlns:r="http://schemas.openxmlformats.org/officeDocument/2006/relationships" r:id="Rf2b3aefc596a47c3"/>
+                <a:hlinkClick xmlns:r="http://schemas.openxmlformats.org/officeDocument/2006/relationships" r:id="Re1da8f1d0ab84392"/>
               </a:rPr>
               <a:t>[9] Our W&amp;B project and exact run records</a:t>
             </a:r>
@@ -17907,7 +17907,7 @@
           <p:cNvPr id="543" name="">
             <a:extLst xmlns:a="http://schemas.openxmlformats.org/drawingml/2006/main">
               <a:ext uri="{FF2B5EF4-FFF2-40B4-BE49-F238E27FC236}">
-                <a16:creationId xmlns:a16="http://schemas.microsoft.com/office/drawing/2014/main" id="{09EC297F-D367-42D2-BBFE-70F3E53FB030}"/>
+                <a16:creationId xmlns:a16="http://schemas.microsoft.com/office/drawing/2014/main" id="{077ACC33-888A-474C-979A-FBF779F4C9AB}"/>
               </a:ext>
             </a:extLst>
           </p:cNvPr>
@@ -18028,7 +18028,7 @@
                 <a:latin typeface="Helvetica Neue"/>
                 <a:ea typeface="Helvetica Neue"/>
                 <a:cs typeface="Helvetica Neue"/>
-                <a:hlinkClick xmlns:r="http://schemas.openxmlformats.org/officeDocument/2006/relationships" r:id="R82a83443d8674998"/>
+                <a:hlinkClick xmlns:r="http://schemas.openxmlformats.org/officeDocument/2006/relationships" r:id="R4931dd51216b48ea"/>
               </a:rPr>
               <a:t>Research question and evidence</a:t>
             </a:r>
@@ -18147,7 +18147,7 @@
           <p:cNvPr id="534" name="">
             <a:extLst xmlns:a="http://schemas.openxmlformats.org/drawingml/2006/main">
               <a:ext uri="{FF2B5EF4-FFF2-40B4-BE49-F238E27FC236}">
-                <a16:creationId xmlns:a16="http://schemas.microsoft.com/office/drawing/2014/main" id="{E41D6953-A079-4C72-8629-C916107D48C5}"/>
+                <a16:creationId xmlns:a16="http://schemas.microsoft.com/office/drawing/2014/main" id="{066F6A0C-4466-4074-8103-D701BBA5FDD0}"/>
               </a:ext>
             </a:extLst>
           </p:cNvPr>
@@ -18204,7 +18204,7 @@
           <p:cNvPr id="535" name="">
             <a:extLst xmlns:a="http://schemas.openxmlformats.org/drawingml/2006/main">
               <a:ext uri="{FF2B5EF4-FFF2-40B4-BE49-F238E27FC236}">
-                <a16:creationId xmlns:a16="http://schemas.microsoft.com/office/drawing/2014/main" id="{574803E4-D4AB-4605-81CC-BF84989FF2CC}"/>
+                <a16:creationId xmlns:a16="http://schemas.microsoft.com/office/drawing/2014/main" id="{D66CF298-08C0-437C-9C82-7CF9774DBC86}"/>
               </a:ext>
             </a:extLst>
           </p:cNvPr>
@@ -18261,7 +18261,7 @@
           <p:cNvPr id="536" name="">
             <a:extLst xmlns:a="http://schemas.openxmlformats.org/drawingml/2006/main">
               <a:ext uri="{FF2B5EF4-FFF2-40B4-BE49-F238E27FC236}">
-                <a16:creationId xmlns:a16="http://schemas.microsoft.com/office/drawing/2014/main" id="{4EB6294E-027A-4D0B-9D34-6A40255182DB}"/>
+                <a16:creationId xmlns:a16="http://schemas.microsoft.com/office/drawing/2014/main" id="{8CB95D54-A0B8-4464-AA60-602F10C22AAC}"/>
               </a:ext>
             </a:extLst>
           </p:cNvPr>
@@ -18318,7 +18318,7 @@
           <p:cNvPr id="537" name="">
             <a:extLst xmlns:a="http://schemas.openxmlformats.org/drawingml/2006/main">
               <a:ext uri="{FF2B5EF4-FFF2-40B4-BE49-F238E27FC236}">
-                <a16:creationId xmlns:a16="http://schemas.microsoft.com/office/drawing/2014/main" id="{B7414503-AE13-496A-849F-F5015675AA7A}"/>
+                <a16:creationId xmlns:a16="http://schemas.microsoft.com/office/drawing/2014/main" id="{62047756-3160-49C8-B430-3E6A15BAB155}"/>
               </a:ext>
             </a:extLst>
           </p:cNvPr>
@@ -18375,7 +18375,7 @@
           <p:cNvPr id="538" name="">
             <a:extLst xmlns:a="http://schemas.openxmlformats.org/drawingml/2006/main">
               <a:ext uri="{FF2B5EF4-FFF2-40B4-BE49-F238E27FC236}">
-                <a16:creationId xmlns:a16="http://schemas.microsoft.com/office/drawing/2014/main" id="{2F1B05B6-10D3-4313-9850-7128C69135A7}"/>
+                <a16:creationId xmlns:a16="http://schemas.microsoft.com/office/drawing/2014/main" id="{63C54401-5CB4-4242-B3CD-5B0130571FAB}"/>
               </a:ext>
             </a:extLst>
           </p:cNvPr>
@@ -18432,7 +18432,7 @@
           <p:cNvPr id="539" name="">
             <a:extLst xmlns:a="http://schemas.openxmlformats.org/drawingml/2006/main">
               <a:ext uri="{FF2B5EF4-FFF2-40B4-BE49-F238E27FC236}">
-                <a16:creationId xmlns:a16="http://schemas.microsoft.com/office/drawing/2014/main" id="{FEBDFEFA-C27C-4813-BF2B-55A4EB042A58}"/>
+                <a16:creationId xmlns:a16="http://schemas.microsoft.com/office/drawing/2014/main" id="{07B93E80-883A-42D0-A484-43C56DF3C3C3}"/>
               </a:ext>
             </a:extLst>
           </p:cNvPr>
@@ -18489,7 +18489,7 @@
           <p:cNvPr id="540" name="">
             <a:extLst xmlns:a="http://schemas.openxmlformats.org/drawingml/2006/main">
               <a:ext uri="{FF2B5EF4-FFF2-40B4-BE49-F238E27FC236}">
-                <a16:creationId xmlns:a16="http://schemas.microsoft.com/office/drawing/2014/main" id="{9F1C0DDF-1A73-4FCA-A6A7-A5BA0FD5EAD9}"/>
+                <a16:creationId xmlns:a16="http://schemas.microsoft.com/office/drawing/2014/main" id="{105355EB-D56D-4F63-A6E6-5551DBAC5573}"/>
               </a:ext>
             </a:extLst>
           </p:cNvPr>
@@ -18729,7 +18729,7 @@
           <p:cNvPr id="534" name="">
             <a:extLst xmlns:a="http://schemas.openxmlformats.org/drawingml/2006/main">
               <a:ext uri="{FF2B5EF4-FFF2-40B4-BE49-F238E27FC236}">
-                <a16:creationId xmlns:a16="http://schemas.microsoft.com/office/drawing/2014/main" id="{845B7458-E151-42C5-B4E6-92776DC00463}"/>
+                <a16:creationId xmlns:a16="http://schemas.microsoft.com/office/drawing/2014/main" id="{EFB460E8-C07B-48D5-B5EC-4B66C986A1ED}"/>
               </a:ext>
             </a:extLst>
           </p:cNvPr>
@@ -18832,7 +18832,7 @@
                 <a:latin typeface="Helvetica Neue"/>
                 <a:ea typeface="Helvetica Neue"/>
                 <a:cs typeface="Helvetica Neue"/>
-                <a:hlinkClick xmlns:r="http://schemas.openxmlformats.org/officeDocument/2006/relationships" r:id="R9438732d743245ae"/>
+                <a:hlinkClick xmlns:r="http://schemas.openxmlformats.org/officeDocument/2006/relationships" r:id="R1ece2e6b659f4840"/>
               </a:rPr>
               <a:t>SOLA</a:t>
             </a:r>
@@ -18852,7 +18852,7 @@
                 <a:latin typeface="Helvetica Neue"/>
                 <a:ea typeface="Helvetica Neue"/>
                 <a:cs typeface="Helvetica Neue"/>
-                <a:hlinkClick xmlns:r="http://schemas.openxmlformats.org/officeDocument/2006/relationships" r:id="R1117d9f4f0cc4a1a"/>
+                <a:hlinkClick xmlns:r="http://schemas.openxmlformats.org/officeDocument/2006/relationships" r:id="R3e21068cb5a648b8"/>
               </a:rPr>
               <a:t>DuetServe</a:t>
             </a:r>
@@ -18872,7 +18872,7 @@
                 <a:latin typeface="Helvetica Neue"/>
                 <a:ea typeface="Helvetica Neue"/>
                 <a:cs typeface="Helvetica Neue"/>
-                <a:hlinkClick xmlns:r="http://schemas.openxmlformats.org/officeDocument/2006/relationships" r:id="Rbb74e51eb3154f25"/>
+                <a:hlinkClick xmlns:r="http://schemas.openxmlformats.org/officeDocument/2006/relationships" r:id="Racf9f0f031684497"/>
               </a:rPr>
               <a:t>Prism recommendation serving</a:t>
             </a:r>
@@ -18991,7 +18991,7 @@
           <p:cNvPr id="534" name="">
             <a:extLst xmlns:a="http://schemas.openxmlformats.org/drawingml/2006/main">
               <a:ext uri="{FF2B5EF4-FFF2-40B4-BE49-F238E27FC236}">
-                <a16:creationId xmlns:a16="http://schemas.microsoft.com/office/drawing/2014/main" id="{2D053E37-2FC8-48CE-8648-EAE92BF1AF72}"/>
+                <a16:creationId xmlns:a16="http://schemas.microsoft.com/office/drawing/2014/main" id="{96CD065C-0F58-44C4-A6CC-79E76F39D5C8}"/>
               </a:ext>
             </a:extLst>
           </p:cNvPr>
@@ -19406,7 +19406,7 @@
           <p:cNvPr id="536" name="">
             <a:extLst xmlns:a="http://schemas.openxmlformats.org/drawingml/2006/main">
               <a:ext uri="{FF2B5EF4-FFF2-40B4-BE49-F238E27FC236}">
-                <a16:creationId xmlns:a16="http://schemas.microsoft.com/office/drawing/2014/main" id="{186D209C-8B39-467A-9CDB-FB135C1092CE}"/>
+                <a16:creationId xmlns:a16="http://schemas.microsoft.com/office/drawing/2014/main" id="{648102C5-73E5-4E11-92F9-5B12B3BB87D2}"/>
               </a:ext>
             </a:extLst>
           </p:cNvPr>
@@ -19527,7 +19527,7 @@
                 <a:latin typeface="Helvetica Neue"/>
                 <a:ea typeface="Helvetica Neue"/>
                 <a:cs typeface="Helvetica Neue"/>
-                <a:hlinkClick xmlns:r="http://schemas.openxmlformats.org/officeDocument/2006/relationships" r:id="R27db893fe448493d"/>
+                <a:hlinkClick xmlns:r="http://schemas.openxmlformats.org/officeDocument/2006/relationships" r:id="R2ad4b702158a4064"/>
               </a:rPr>
               <a:t>Hong et al., SOLA, MLSys 2025. Original Figure 1</a:t>
             </a:r>
@@ -19650,7 +19650,7 @@
           <p:nvPr/>
         </p:nvPicPr>
         <p:blipFill>
-          <a:blip xmlns:r="http://schemas.openxmlformats.org/officeDocument/2006/relationships" xmlns:a="http://schemas.openxmlformats.org/drawingml/2006/main" r:embed="R182306f90c4240f3"/>
+          <a:blip xmlns:r="http://schemas.openxmlformats.org/officeDocument/2006/relationships" xmlns:a="http://schemas.openxmlformats.org/drawingml/2006/main" r:embed="R3a74ed1078974eeb"/>
           <a:stretch xmlns:a="http://schemas.openxmlformats.org/drawingml/2006/main"/>
         </p:blipFill>
         <p:spPr>
@@ -19668,7 +19668,7 @@
           <p:cNvPr id="535" name="">
             <a:extLst xmlns:a="http://schemas.openxmlformats.org/drawingml/2006/main">
               <a:ext uri="{FF2B5EF4-FFF2-40B4-BE49-F238E27FC236}">
-                <a16:creationId xmlns:a16="http://schemas.microsoft.com/office/drawing/2014/main" id="{67C1DDB1-8A9A-41FE-9AEC-701B1DE4D32A}"/>
+                <a16:creationId xmlns:a16="http://schemas.microsoft.com/office/drawing/2014/main" id="{BF76E13B-85BC-4213-BD50-29F2B3C40D88}"/>
               </a:ext>
             </a:extLst>
           </p:cNvPr>
@@ -19748,7 +19748,7 @@
           <p:cNvPr id="536" name="">
             <a:extLst xmlns:a="http://schemas.openxmlformats.org/drawingml/2006/main">
               <a:ext uri="{FF2B5EF4-FFF2-40B4-BE49-F238E27FC236}">
-                <a16:creationId xmlns:a16="http://schemas.microsoft.com/office/drawing/2014/main" id="{F210CFEC-C9F8-4AB1-A4D1-1FB5A0257226}"/>
+                <a16:creationId xmlns:a16="http://schemas.microsoft.com/office/drawing/2014/main" id="{72D9F420-3753-4DA1-AD73-BC2773DA2FAF}"/>
               </a:ext>
             </a:extLst>
           </p:cNvPr>
@@ -19805,7 +19805,7 @@
           <p:cNvPr id="537" name="">
             <a:extLst xmlns:a="http://schemas.openxmlformats.org/drawingml/2006/main">
               <a:ext uri="{FF2B5EF4-FFF2-40B4-BE49-F238E27FC236}">
-                <a16:creationId xmlns:a16="http://schemas.microsoft.com/office/drawing/2014/main" id="{77230B78-5E34-46D8-9366-EF42284DA55C}"/>
+                <a16:creationId xmlns:a16="http://schemas.microsoft.com/office/drawing/2014/main" id="{59F6CFCB-1CD3-428F-9E1E-DAA0AE4D8829}"/>
               </a:ext>
             </a:extLst>
           </p:cNvPr>
@@ -19862,7 +19862,7 @@
           <p:cNvPr id="538" name="">
             <a:extLst xmlns:a="http://schemas.openxmlformats.org/drawingml/2006/main">
               <a:ext uri="{FF2B5EF4-FFF2-40B4-BE49-F238E27FC236}">
-                <a16:creationId xmlns:a16="http://schemas.microsoft.com/office/drawing/2014/main" id="{4C802106-F65D-42B3-A85E-C27494B204D1}"/>
+                <a16:creationId xmlns:a16="http://schemas.microsoft.com/office/drawing/2014/main" id="{5C661DDC-BF29-4C92-8C74-C129E4563FFF}"/>
               </a:ext>
             </a:extLst>
           </p:cNvPr>
@@ -19919,7 +19919,7 @@
           <p:cNvPr id="539" name="">
             <a:extLst xmlns:a="http://schemas.openxmlformats.org/drawingml/2006/main">
               <a:ext uri="{FF2B5EF4-FFF2-40B4-BE49-F238E27FC236}">
-                <a16:creationId xmlns:a16="http://schemas.microsoft.com/office/drawing/2014/main" id="{8096A6F5-28B5-4E17-AFDF-36CB489B4D54}"/>
+                <a16:creationId xmlns:a16="http://schemas.microsoft.com/office/drawing/2014/main" id="{0B2A5541-6291-439F-9F22-CCDE0A1EC83C}"/>
               </a:ext>
             </a:extLst>
           </p:cNvPr>
@@ -19976,7 +19976,7 @@
           <p:cNvPr id="540" name="">
             <a:extLst xmlns:a="http://schemas.openxmlformats.org/drawingml/2006/main">
               <a:ext uri="{FF2B5EF4-FFF2-40B4-BE49-F238E27FC236}">
-                <a16:creationId xmlns:a16="http://schemas.microsoft.com/office/drawing/2014/main" id="{499B861D-5E18-4887-AF15-D27A91E1DCB4}"/>
+                <a16:creationId xmlns:a16="http://schemas.microsoft.com/office/drawing/2014/main" id="{4471423A-E32F-4788-8038-9FFB062F2BCA}"/>
               </a:ext>
             </a:extLst>
           </p:cNvPr>
@@ -20033,7 +20033,7 @@
           <p:cNvPr id="541" name="">
             <a:extLst xmlns:a="http://schemas.openxmlformats.org/drawingml/2006/main">
               <a:ext uri="{FF2B5EF4-FFF2-40B4-BE49-F238E27FC236}">
-                <a16:creationId xmlns:a16="http://schemas.microsoft.com/office/drawing/2014/main" id="{ECAC32AA-6024-4BA2-B100-7329D4D90D24}"/>
+                <a16:creationId xmlns:a16="http://schemas.microsoft.com/office/drawing/2014/main" id="{389ADF0D-44C4-4031-937F-B96A6E428714}"/>
               </a:ext>
             </a:extLst>
           </p:cNvPr>
@@ -20154,7 +20154,7 @@
                 <a:latin typeface="Helvetica Neue"/>
                 <a:ea typeface="Helvetica Neue"/>
                 <a:cs typeface="Helvetica Neue"/>
-                <a:hlinkClick xmlns:r="http://schemas.openxmlformats.org/officeDocument/2006/relationships" r:id="Rb94588a5dfb54237"/>
+                <a:hlinkClick xmlns:r="http://schemas.openxmlformats.org/officeDocument/2006/relationships" r:id="Ra6fecedc4e9e4390"/>
               </a:rPr>
               <a:t>Gao et al., DuetServe, ICML 2026. Figure 6 and §5.2</a:t>
             </a:r>
@@ -20277,7 +20277,7 @@
           <p:nvPr/>
         </p:nvPicPr>
         <p:blipFill>
-          <a:blip xmlns:r="http://schemas.openxmlformats.org/officeDocument/2006/relationships" xmlns:a="http://schemas.openxmlformats.org/drawingml/2006/main" r:embed="R7570edda29ac48d3"/>
+          <a:blip xmlns:r="http://schemas.openxmlformats.org/officeDocument/2006/relationships" xmlns:a="http://schemas.openxmlformats.org/drawingml/2006/main" r:embed="R09e6e82d889f4e54"/>
           <a:stretch xmlns:a="http://schemas.openxmlformats.org/drawingml/2006/main"/>
         </p:blipFill>
         <p:spPr>
@@ -20295,7 +20295,7 @@
           <p:cNvPr id="535" name="">
             <a:extLst xmlns:a="http://schemas.openxmlformats.org/drawingml/2006/main">
               <a:ext uri="{FF2B5EF4-FFF2-40B4-BE49-F238E27FC236}">
-                <a16:creationId xmlns:a16="http://schemas.microsoft.com/office/drawing/2014/main" id="{B988688B-1E26-4865-AB48-8BF6B8BA4F0F}"/>
+                <a16:creationId xmlns:a16="http://schemas.microsoft.com/office/drawing/2014/main" id="{96422061-BF7B-4B47-9E9C-2B6F732ACAC5}"/>
               </a:ext>
             </a:extLst>
           </p:cNvPr>
@@ -20379,7 +20379,7 @@
           <p:nvPr/>
         </p:nvPicPr>
         <p:blipFill>
-          <a:blip xmlns:r="http://schemas.openxmlformats.org/officeDocument/2006/relationships" xmlns:a="http://schemas.openxmlformats.org/drawingml/2006/main" r:embed="R9a17f69521344a64"/>
+          <a:blip xmlns:r="http://schemas.openxmlformats.org/officeDocument/2006/relationships" xmlns:a="http://schemas.openxmlformats.org/drawingml/2006/main" r:embed="Rda874ec98da34abe"/>
           <a:stretch xmlns:a="http://schemas.openxmlformats.org/drawingml/2006/main"/>
         </p:blipFill>
         <p:spPr>
@@ -20397,7 +20397,7 @@
           <p:cNvPr id="537" name="">
             <a:extLst xmlns:a="http://schemas.openxmlformats.org/drawingml/2006/main">
               <a:ext uri="{FF2B5EF4-FFF2-40B4-BE49-F238E27FC236}">
-                <a16:creationId xmlns:a16="http://schemas.microsoft.com/office/drawing/2014/main" id="{01902080-D6D0-4407-AF6B-E008C9A6714C}"/>
+                <a16:creationId xmlns:a16="http://schemas.microsoft.com/office/drawing/2014/main" id="{5CFA7613-687E-46A1-9754-237CBD326148}"/>
               </a:ext>
             </a:extLst>
           </p:cNvPr>
@@ -20454,7 +20454,7 @@
           <p:cNvPr id="538" name="">
             <a:extLst xmlns:a="http://schemas.openxmlformats.org/drawingml/2006/main">
               <a:ext uri="{FF2B5EF4-FFF2-40B4-BE49-F238E27FC236}">
-                <a16:creationId xmlns:a16="http://schemas.microsoft.com/office/drawing/2014/main" id="{77D82D96-CB7E-4AF4-8E7B-E529FB5819D1}"/>
+                <a16:creationId xmlns:a16="http://schemas.microsoft.com/office/drawing/2014/main" id="{2E6E0D12-E666-4C5C-B5CF-350C0E05C0C9}"/>
               </a:ext>
             </a:extLst>
           </p:cNvPr>
@@ -20511,7 +20511,7 @@
           <p:cNvPr id="539" name="">
             <a:extLst xmlns:a="http://schemas.openxmlformats.org/drawingml/2006/main">
               <a:ext uri="{FF2B5EF4-FFF2-40B4-BE49-F238E27FC236}">
-                <a16:creationId xmlns:a16="http://schemas.microsoft.com/office/drawing/2014/main" id="{3D0E5285-FB91-4EDE-A282-13703DBA5C9D}"/>
+                <a16:creationId xmlns:a16="http://schemas.microsoft.com/office/drawing/2014/main" id="{0D984156-147E-4C7F-BA00-2B2425A1F44D}"/>
               </a:ext>
             </a:extLst>
           </p:cNvPr>
@@ -20568,7 +20568,7 @@
           <p:cNvPr id="540" name="">
             <a:extLst xmlns:a="http://schemas.openxmlformats.org/drawingml/2006/main">
               <a:ext uri="{FF2B5EF4-FFF2-40B4-BE49-F238E27FC236}">
-                <a16:creationId xmlns:a16="http://schemas.microsoft.com/office/drawing/2014/main" id="{EF16B38C-8AD0-44FD-BB99-57D5C6394616}"/>
+                <a16:creationId xmlns:a16="http://schemas.microsoft.com/office/drawing/2014/main" id="{65F5A740-77BA-49E1-B816-08662D270836}"/>
               </a:ext>
             </a:extLst>
           </p:cNvPr>
@@ -20625,7 +20625,7 @@
           <p:cNvPr id="541" name="">
             <a:extLst xmlns:a="http://schemas.openxmlformats.org/drawingml/2006/main">
               <a:ext uri="{FF2B5EF4-FFF2-40B4-BE49-F238E27FC236}">
-                <a16:creationId xmlns:a16="http://schemas.microsoft.com/office/drawing/2014/main" id="{066601E0-6F04-4C15-98C5-FF4D1EFDCACE}"/>
+                <a16:creationId xmlns:a16="http://schemas.microsoft.com/office/drawing/2014/main" id="{CF945564-015D-4C07-9D9C-E76D2330A038}"/>
               </a:ext>
             </a:extLst>
           </p:cNvPr>
@@ -20682,7 +20682,7 @@
           <p:cNvPr id="542" name="">
             <a:extLst xmlns:a="http://schemas.openxmlformats.org/drawingml/2006/main">
               <a:ext uri="{FF2B5EF4-FFF2-40B4-BE49-F238E27FC236}">
-                <a16:creationId xmlns:a16="http://schemas.microsoft.com/office/drawing/2014/main" id="{990004D3-E8C0-4820-8F0F-25DE9DB59505}"/>
+                <a16:creationId xmlns:a16="http://schemas.microsoft.com/office/drawing/2014/main" id="{09BD47BA-92EA-4D70-83A7-7C5F4D02F75E}"/>
               </a:ext>
             </a:extLst>
           </p:cNvPr>
@@ -20803,7 +20803,7 @@
                 <a:latin typeface="Helvetica Neue"/>
                 <a:ea typeface="Helvetica Neue"/>
                 <a:cs typeface="Helvetica Neue"/>
-                <a:hlinkClick xmlns:r="http://schemas.openxmlformats.org/officeDocument/2006/relationships" r:id="Re8fd621d5d2c4c89"/>
+                <a:hlinkClick xmlns:r="http://schemas.openxmlformats.org/officeDocument/2006/relationships" r:id="Rb16fa643e9ee4e34"/>
               </a:rPr>
               <a:t>Yang et al., GPU-Disaggregated DLRM Serving, NSDI 2025. Figure 17</a:t>
             </a:r>
@@ -20922,7 +20922,7 @@
           <p:cNvPr id="534" name="">
             <a:extLst xmlns:a="http://schemas.openxmlformats.org/drawingml/2006/main">
               <a:ext uri="{FF2B5EF4-FFF2-40B4-BE49-F238E27FC236}">
-                <a16:creationId xmlns:a16="http://schemas.microsoft.com/office/drawing/2014/main" id="{9CAAA767-BA7B-4927-800D-6CBFEE419749}"/>
+                <a16:creationId xmlns:a16="http://schemas.microsoft.com/office/drawing/2014/main" id="{0705C5C4-9061-49A1-BAC5-FF5F0E32B087}"/>
               </a:ext>
             </a:extLst>
           </p:cNvPr>
@@ -20983,7 +20983,7 @@
           <p:nvPr/>
         </p:nvPicPr>
         <p:blipFill>
-          <a:blip xmlns:r="http://schemas.openxmlformats.org/officeDocument/2006/relationships" xmlns:a="http://schemas.openxmlformats.org/drawingml/2006/main" r:embed="Rd56371ed89154a14"/>
+          <a:blip xmlns:r="http://schemas.openxmlformats.org/officeDocument/2006/relationships" xmlns:a="http://schemas.openxmlformats.org/drawingml/2006/main" r:embed="R14f40248b07f4934"/>
           <a:stretch xmlns:a="http://schemas.openxmlformats.org/drawingml/2006/main"/>
         </p:blipFill>
         <p:spPr>
@@ -21001,7 +21001,7 @@
           <p:cNvPr id="536" name="">
             <a:extLst xmlns:a="http://schemas.openxmlformats.org/drawingml/2006/main">
               <a:ext uri="{FF2B5EF4-FFF2-40B4-BE49-F238E27FC236}">
-                <a16:creationId xmlns:a16="http://schemas.microsoft.com/office/drawing/2014/main" id="{C915A0A7-B8B0-46B4-B609-F7EC7B5BC406}"/>
+                <a16:creationId xmlns:a16="http://schemas.microsoft.com/office/drawing/2014/main" id="{4B9E81DD-0F7E-47B8-9EBF-555E3B0EF37E}"/>
               </a:ext>
             </a:extLst>
           </p:cNvPr>
@@ -21081,7 +21081,7 @@
           <p:cNvPr id="537" name="">
             <a:extLst xmlns:a="http://schemas.openxmlformats.org/drawingml/2006/main">
               <a:ext uri="{FF2B5EF4-FFF2-40B4-BE49-F238E27FC236}">
-                <a16:creationId xmlns:a16="http://schemas.microsoft.com/office/drawing/2014/main" id="{0A6D59DB-0234-46D2-925A-C29805B815A3}"/>
+                <a16:creationId xmlns:a16="http://schemas.microsoft.com/office/drawing/2014/main" id="{C90D12B4-E729-42AF-8FB0-F5021E83CBF3}"/>
               </a:ext>
             </a:extLst>
           </p:cNvPr>
@@ -21138,7 +21138,7 @@
           <p:cNvPr id="538" name="">
             <a:extLst xmlns:a="http://schemas.openxmlformats.org/drawingml/2006/main">
               <a:ext uri="{FF2B5EF4-FFF2-40B4-BE49-F238E27FC236}">
-                <a16:creationId xmlns:a16="http://schemas.microsoft.com/office/drawing/2014/main" id="{6228CE5C-06A3-451E-A965-E3458AB36279}"/>
+                <a16:creationId xmlns:a16="http://schemas.microsoft.com/office/drawing/2014/main" id="{6F03A157-089A-44F3-B2A9-39187F88F50D}"/>
               </a:ext>
             </a:extLst>
           </p:cNvPr>
@@ -21195,7 +21195,7 @@
           <p:cNvPr id="539" name="">
             <a:extLst xmlns:a="http://schemas.openxmlformats.org/drawingml/2006/main">
               <a:ext uri="{FF2B5EF4-FFF2-40B4-BE49-F238E27FC236}">
-                <a16:creationId xmlns:a16="http://schemas.microsoft.com/office/drawing/2014/main" id="{11BEC0AC-6258-4B0E-8E41-CB8C16AC8D9E}"/>
+                <a16:creationId xmlns:a16="http://schemas.microsoft.com/office/drawing/2014/main" id="{78EE556C-F2EF-4315-AD3B-DB8EA06907B6}"/>
               </a:ext>
             </a:extLst>
           </p:cNvPr>
@@ -21252,7 +21252,7 @@
           <p:cNvPr id="540" name="">
             <a:extLst xmlns:a="http://schemas.openxmlformats.org/drawingml/2006/main">
               <a:ext uri="{FF2B5EF4-FFF2-40B4-BE49-F238E27FC236}">
-                <a16:creationId xmlns:a16="http://schemas.microsoft.com/office/drawing/2014/main" id="{0DED86F0-31F4-494D-AEB8-4AEE15D837F9}"/>
+                <a16:creationId xmlns:a16="http://schemas.microsoft.com/office/drawing/2014/main" id="{79571CA6-CC67-4E59-AF5D-4657CFE76BFF}"/>
               </a:ext>
             </a:extLst>
           </p:cNvPr>
@@ -21309,7 +21309,7 @@
           <p:cNvPr id="541" name="">
             <a:extLst xmlns:a="http://schemas.openxmlformats.org/drawingml/2006/main">
               <a:ext uri="{FF2B5EF4-FFF2-40B4-BE49-F238E27FC236}">
-                <a16:creationId xmlns:a16="http://schemas.microsoft.com/office/drawing/2014/main" id="{4BFCDFB4-67D7-400F-AA83-5CD7B6206EB6}"/>
+                <a16:creationId xmlns:a16="http://schemas.microsoft.com/office/drawing/2014/main" id="{D0ED4318-BBCD-49BA-8F9D-2C4918818B1B}"/>
               </a:ext>
             </a:extLst>
           </p:cNvPr>
@@ -21366,7 +21366,7 @@
           <p:cNvPr id="542" name="">
             <a:extLst xmlns:a="http://schemas.openxmlformats.org/drawingml/2006/main">
               <a:ext uri="{FF2B5EF4-FFF2-40B4-BE49-F238E27FC236}">
-                <a16:creationId xmlns:a16="http://schemas.microsoft.com/office/drawing/2014/main" id="{6C7F9A49-2B5A-468A-B541-4534AFD9B6F1}"/>
+                <a16:creationId xmlns:a16="http://schemas.microsoft.com/office/drawing/2014/main" id="{448988AB-307B-4FD4-8634-422DD10953B9}"/>
               </a:ext>
             </a:extLst>
           </p:cNvPr>
@@ -21606,7 +21606,7 @@
           <p:cNvPr id="534" name="">
             <a:extLst xmlns:a="http://schemas.openxmlformats.org/drawingml/2006/main">
               <a:ext uri="{FF2B5EF4-FFF2-40B4-BE49-F238E27FC236}">
-                <a16:creationId xmlns:a16="http://schemas.microsoft.com/office/drawing/2014/main" id="{00E64D98-14F4-44F9-BB0B-D88739C1BE93}"/>
+                <a16:creationId xmlns:a16="http://schemas.microsoft.com/office/drawing/2014/main" id="{05A5952A-47A7-47C8-91E4-6604DB1F964C}"/>
               </a:ext>
             </a:extLst>
           </p:cNvPr>
@@ -21709,7 +21709,7 @@
                 <a:latin typeface="Helvetica Neue"/>
                 <a:ea typeface="Helvetica Neue"/>
                 <a:cs typeface="Helvetica Neue"/>
-                <a:hlinkClick xmlns:r="http://schemas.openxmlformats.org/officeDocument/2006/relationships" r:id="Rbac3d2b862a14610"/>
+                <a:hlinkClick xmlns:r="http://schemas.openxmlformats.org/officeDocument/2006/relationships" r:id="Rde2cf3068e934eca"/>
               </a:rPr>
               <a:t>Recorded system and model revisions</a:t>
             </a:r>
@@ -21729,7 +21729,7 @@
                 <a:latin typeface="Helvetica Neue"/>
                 <a:ea typeface="Helvetica Neue"/>
                 <a:cs typeface="Helvetica Neue"/>
-                <a:hlinkClick xmlns:r="http://schemas.openxmlformats.org/officeDocument/2006/relationships" r:id="R4a90d491b9df4ad2"/>
+                <a:hlinkClick xmlns:r="http://schemas.openxmlformats.org/officeDocument/2006/relationships" r:id="Rae8ac7e3bcbb4991"/>
               </a:rPr>
               <a:t>NVIDIA metric definition</a:t>
             </a:r>
@@ -22235,7 +22235,7 @@
           <p:cNvPr id="535" name="">
             <a:extLst xmlns:a="http://schemas.openxmlformats.org/drawingml/2006/main">
               <a:ext uri="{FF2B5EF4-FFF2-40B4-BE49-F238E27FC236}">
-                <a16:creationId xmlns:a16="http://schemas.microsoft.com/office/drawing/2014/main" id="{A1A1FFC2-ACF5-4671-8FB1-5FC3C6C03939}"/>
+                <a16:creationId xmlns:a16="http://schemas.microsoft.com/office/drawing/2014/main" id="{402EC61B-991B-4DD1-88F2-169ACD5AABCB}"/>
               </a:ext>
             </a:extLst>
           </p:cNvPr>
@@ -22292,7 +22292,7 @@
           <p:cNvPr id="536" name="">
             <a:extLst xmlns:a="http://schemas.openxmlformats.org/drawingml/2006/main">
               <a:ext uri="{FF2B5EF4-FFF2-40B4-BE49-F238E27FC236}">
-                <a16:creationId xmlns:a16="http://schemas.microsoft.com/office/drawing/2014/main" id="{E32800CF-273C-4563-AD6E-467DBA882024}"/>
+                <a16:creationId xmlns:a16="http://schemas.microsoft.com/office/drawing/2014/main" id="{9CAC0667-D3BE-4168-B89C-D1D8D0D3D4B3}"/>
               </a:ext>
             </a:extLst>
           </p:cNvPr>
@@ -22349,7 +22349,7 @@
           <p:cNvPr id="537" name="">
             <a:extLst xmlns:a="http://schemas.openxmlformats.org/drawingml/2006/main">
               <a:ext uri="{FF2B5EF4-FFF2-40B4-BE49-F238E27FC236}">
-                <a16:creationId xmlns:a16="http://schemas.microsoft.com/office/drawing/2014/main" id="{03237E41-CE60-4EB9-8CE1-BE7ACD30A93D}"/>
+                <a16:creationId xmlns:a16="http://schemas.microsoft.com/office/drawing/2014/main" id="{8451ADF1-2E67-4632-99DD-E9EB756D2176}"/>
               </a:ext>
             </a:extLst>
           </p:cNvPr>
@@ -22406,7 +22406,7 @@
           <p:cNvPr id="538" name="">
             <a:extLst xmlns:a="http://schemas.openxmlformats.org/drawingml/2006/main">
               <a:ext uri="{FF2B5EF4-FFF2-40B4-BE49-F238E27FC236}">
-                <a16:creationId xmlns:a16="http://schemas.microsoft.com/office/drawing/2014/main" id="{72D0E5EA-009A-417D-85E1-56EA2FA94726}"/>
+                <a16:creationId xmlns:a16="http://schemas.microsoft.com/office/drawing/2014/main" id="{3869D8FD-05AD-4FD9-8EF6-03BA357AEED4}"/>
               </a:ext>
             </a:extLst>
           </p:cNvPr>
@@ -22463,7 +22463,7 @@
           <p:cNvPr id="539" name="">
             <a:extLst xmlns:a="http://schemas.openxmlformats.org/drawingml/2006/main">
               <a:ext uri="{FF2B5EF4-FFF2-40B4-BE49-F238E27FC236}">
-                <a16:creationId xmlns:a16="http://schemas.microsoft.com/office/drawing/2014/main" id="{33F29D37-E948-4BC7-8650-2E5B963D8D4C}"/>
+                <a16:creationId xmlns:a16="http://schemas.microsoft.com/office/drawing/2014/main" id="{1D5502BA-2F1B-4463-86C9-A26348B05A21}"/>
               </a:ext>
             </a:extLst>
           </p:cNvPr>
@@ -22520,7 +22520,7 @@
           <p:cNvPr id="540" name="">
             <a:extLst xmlns:a="http://schemas.openxmlformats.org/drawingml/2006/main">
               <a:ext uri="{FF2B5EF4-FFF2-40B4-BE49-F238E27FC236}">
-                <a16:creationId xmlns:a16="http://schemas.microsoft.com/office/drawing/2014/main" id="{250FED41-89FA-45B5-89BA-C29B87BFE663}"/>
+                <a16:creationId xmlns:a16="http://schemas.microsoft.com/office/drawing/2014/main" id="{B6837C05-96D1-4C09-B84D-6521632A4C9E}"/>
               </a:ext>
             </a:extLst>
           </p:cNvPr>
@@ -22577,7 +22577,7 @@
           <p:cNvPr id="541" name="">
             <a:extLst xmlns:a="http://schemas.openxmlformats.org/drawingml/2006/main">
               <a:ext uri="{FF2B5EF4-FFF2-40B4-BE49-F238E27FC236}">
-                <a16:creationId xmlns:a16="http://schemas.microsoft.com/office/drawing/2014/main" id="{157FBC58-7B7C-415C-ACA1-49D6ECF4E7E4}"/>
+                <a16:creationId xmlns:a16="http://schemas.microsoft.com/office/drawing/2014/main" id="{00F7A371-07FF-4144-A668-FABC5F54AC7A}"/>
               </a:ext>
             </a:extLst>
           </p:cNvPr>

</xml_diff>

<commit_message>
Frame the research question around SLO goodput and controlled progression
</commit_message>
<xml_diff>
--- a/Inference_Optimization_Final.pptx
+++ b/Inference_Optimization_Final.pptx
@@ -2,40 +2,40 @@
 <file path=ppt/presentation.xml><?xml version="1.0" encoding="utf-8"?>
 <p:presentation xmlns:p="http://schemas.openxmlformats.org/presentationml/2006/main" embedTrueTypeFonts="1" saveSubsetFonts="0">
   <p:sldMasterIdLst>
-    <p:sldMasterId xmlns:r="http://schemas.openxmlformats.org/officeDocument/2006/relationships" id="2147483648" r:id="Rdc7c341d59e04c78"/>
+    <p:sldMasterId xmlns:r="http://schemas.openxmlformats.org/officeDocument/2006/relationships" id="2147483648" r:id="Rf01b7d47c970433b"/>
   </p:sldMasterIdLst>
   <p:notesMasterIdLst>
-    <p:notesMasterId xmlns:r="http://schemas.openxmlformats.org/officeDocument/2006/relationships" r:id="R9fdfae68cffe4cf0"/>
+    <p:notesMasterId xmlns:r="http://schemas.openxmlformats.org/officeDocument/2006/relationships" r:id="Rcbcfb738a6214c0c"/>
   </p:notesMasterIdLst>
   <p:sldIdLst>
-    <p:sldId xmlns:r="http://schemas.openxmlformats.org/officeDocument/2006/relationships" id="256" r:id="R3726e3434c3d412c"/>
-    <p:sldId xmlns:r="http://schemas.openxmlformats.org/officeDocument/2006/relationships" id="257" r:id="Ree07c08cfd2449c8"/>
-    <p:sldId xmlns:r="http://schemas.openxmlformats.org/officeDocument/2006/relationships" id="258" r:id="Rfa2a19c0ee7c4693"/>
-    <p:sldId xmlns:r="http://schemas.openxmlformats.org/officeDocument/2006/relationships" id="259" r:id="R0741ad89c3c24b9d"/>
-    <p:sldId xmlns:r="http://schemas.openxmlformats.org/officeDocument/2006/relationships" id="260" r:id="R8e6c18cbce81464a"/>
-    <p:sldId xmlns:r="http://schemas.openxmlformats.org/officeDocument/2006/relationships" id="261" r:id="Rc3d7f9ce40254f59"/>
-    <p:sldId xmlns:r="http://schemas.openxmlformats.org/officeDocument/2006/relationships" id="262" r:id="Rff798ad1940341c1"/>
-    <p:sldId xmlns:r="http://schemas.openxmlformats.org/officeDocument/2006/relationships" id="263" r:id="R1d8333cde8bc4958"/>
-    <p:sldId xmlns:r="http://schemas.openxmlformats.org/officeDocument/2006/relationships" id="264" r:id="R330c258cf6f74bdd"/>
-    <p:sldId xmlns:r="http://schemas.openxmlformats.org/officeDocument/2006/relationships" id="265" r:id="R6d577c4a0a084d23"/>
-    <p:sldId xmlns:r="http://schemas.openxmlformats.org/officeDocument/2006/relationships" id="266" r:id="R892e80431dcc446a"/>
-    <p:sldId xmlns:r="http://schemas.openxmlformats.org/officeDocument/2006/relationships" id="267" r:id="Rc4ada68def7c4df9"/>
-    <p:sldId xmlns:r="http://schemas.openxmlformats.org/officeDocument/2006/relationships" id="268" r:id="R12853195cd814ef9"/>
-    <p:sldId xmlns:r="http://schemas.openxmlformats.org/officeDocument/2006/relationships" id="269" r:id="R19540b3b8d4c4106"/>
-    <p:sldId xmlns:r="http://schemas.openxmlformats.org/officeDocument/2006/relationships" id="270" r:id="R804d3243776f486a"/>
-    <p:sldId xmlns:r="http://schemas.openxmlformats.org/officeDocument/2006/relationships" id="271" r:id="R559998c9ea144e50"/>
-    <p:sldId xmlns:r="http://schemas.openxmlformats.org/officeDocument/2006/relationships" id="272" r:id="Re2dcbad94dfd4d01"/>
-    <p:sldId xmlns:r="http://schemas.openxmlformats.org/officeDocument/2006/relationships" id="273" r:id="R622c2b4194374845"/>
+    <p:sldId xmlns:r="http://schemas.openxmlformats.org/officeDocument/2006/relationships" id="256" r:id="R3ac60d30fad641e8"/>
+    <p:sldId xmlns:r="http://schemas.openxmlformats.org/officeDocument/2006/relationships" id="257" r:id="R4ee64e54d4be4046"/>
+    <p:sldId xmlns:r="http://schemas.openxmlformats.org/officeDocument/2006/relationships" id="258" r:id="R9d2d97ad5ffc4088"/>
+    <p:sldId xmlns:r="http://schemas.openxmlformats.org/officeDocument/2006/relationships" id="259" r:id="R78fc32c291ac4cae"/>
+    <p:sldId xmlns:r="http://schemas.openxmlformats.org/officeDocument/2006/relationships" id="260" r:id="R4c2f0d29e4bd4769"/>
+    <p:sldId xmlns:r="http://schemas.openxmlformats.org/officeDocument/2006/relationships" id="261" r:id="Ra1f6ef9acc6842f9"/>
+    <p:sldId xmlns:r="http://schemas.openxmlformats.org/officeDocument/2006/relationships" id="262" r:id="R36b74079e83340c2"/>
+    <p:sldId xmlns:r="http://schemas.openxmlformats.org/officeDocument/2006/relationships" id="263" r:id="R635c32189b384568"/>
+    <p:sldId xmlns:r="http://schemas.openxmlformats.org/officeDocument/2006/relationships" id="264" r:id="R2100175117c54cde"/>
+    <p:sldId xmlns:r="http://schemas.openxmlformats.org/officeDocument/2006/relationships" id="265" r:id="R0425b2fd072a4aac"/>
+    <p:sldId xmlns:r="http://schemas.openxmlformats.org/officeDocument/2006/relationships" id="266" r:id="R7202232879424f15"/>
+    <p:sldId xmlns:r="http://schemas.openxmlformats.org/officeDocument/2006/relationships" id="267" r:id="R0397adea2ed14637"/>
+    <p:sldId xmlns:r="http://schemas.openxmlformats.org/officeDocument/2006/relationships" id="268" r:id="R7e6142c178984c6d"/>
+    <p:sldId xmlns:r="http://schemas.openxmlformats.org/officeDocument/2006/relationships" id="269" r:id="Rd8ce43586286454a"/>
+    <p:sldId xmlns:r="http://schemas.openxmlformats.org/officeDocument/2006/relationships" id="270" r:id="Rd539c36f769a45bc"/>
+    <p:sldId xmlns:r="http://schemas.openxmlformats.org/officeDocument/2006/relationships" id="271" r:id="R86cf757190ea4bbc"/>
+    <p:sldId xmlns:r="http://schemas.openxmlformats.org/officeDocument/2006/relationships" id="272" r:id="Rc3d0832b4e3d4044"/>
+    <p:sldId xmlns:r="http://schemas.openxmlformats.org/officeDocument/2006/relationships" id="273" r:id="R4c13e8357d30427c"/>
   </p:sldIdLst>
   <p:sldSz cx="12192000" cy="6858000"/>
   <p:notesSz cx="6858000" cy="9144000"/>
   <p:embeddedFontLst>
     <p:embeddedFont>
       <p:font typeface="OpenAI Sans"/>
-      <p:regular xmlns:r="http://schemas.openxmlformats.org/officeDocument/2006/relationships" r:id="Ra2a245ba46404730"/>
-      <p:bold xmlns:r="http://schemas.openxmlformats.org/officeDocument/2006/relationships" r:id="Rb5892e2b0be94e64"/>
-      <p:italic xmlns:r="http://schemas.openxmlformats.org/officeDocument/2006/relationships" r:id="Ra882ca89d6084324"/>
-      <p:boldItalic xmlns:r="http://schemas.openxmlformats.org/officeDocument/2006/relationships" r:id="Ra1ba33c2b0d744cd"/>
+      <p:regular xmlns:r="http://schemas.openxmlformats.org/officeDocument/2006/relationships" r:id="Raec2c0ebcf89461a"/>
+      <p:bold xmlns:r="http://schemas.openxmlformats.org/officeDocument/2006/relationships" r:id="Rac703e6d76814f26"/>
+      <p:italic xmlns:r="http://schemas.openxmlformats.org/officeDocument/2006/relationships" r:id="Ra211b1ffe273438a"/>
+      <p:boldItalic xmlns:r="http://schemas.openxmlformats.org/officeDocument/2006/relationships" r:id="R77b00c9ef6f04988"/>
     </p:embeddedFont>
   </p:embeddedFontLst>
 </p:presentation>
@@ -414,7 +414,7 @@
           <a:lstStyle xmlns:a="http://schemas.openxmlformats.org/drawingml/2006/main"/>
           <a:p xmlns:a="http://schemas.openxmlformats.org/drawingml/2006/main">
             <a:r>
-              <a:t>Our project is called Inference Optimization. The goal is to get more useful inference work from the same GPU while keeping response times acceptable.</a:t>
+              <a:t>Our project is called Inference Optimization. We want better admission decisions to increase SLO goodput: the number of requests completed within their latency targets per second on the same GPU.</a:t>
             </a:r>
           </a:p>
           <a:p xmlns:a="http://schemas.openxmlformats.org/drawingml/2006/main">
@@ -424,7 +424,7 @@
           </a:p>
           <a:p xmlns:a="http://schemas.openxmlformats.org/drawingml/2006/main">
             <a:r>
-              <a:t>We are studying the software decisions around an already trained model. We are not training a new language model. I will first explain the question, then show what published systems do, followed by our own experiments and their results.</a:t>
+              <a:t>The completed tests give us a research progression. We observed a burst-recovery problem, measured default vLLM and a simple admission limit, and tested a context-budget rule. That rule performed worse, so we do not yet have a better scheduler.</a:t>
             </a:r>
           </a:p>
           <a:p xmlns:a="http://schemas.openxmlformats.org/drawingml/2006/main">
@@ -434,7 +434,7 @@
           </a:p>
           <a:p xmlns:a="http://schemas.openxmlformats.org/drawingml/2006/main">
             <a:r>
-              <a:t>The important starting point is that our current experiment did not produce a better scheduler. It gave us a reproducible problem and evidence about a rule that failed.</a:t>
+              <a:t>Our next question is whether estimated processing cost, system state and remaining latency budget can guide better admission decisions. The presentation separates published results, our measurements and this untested next hypothesis.</a:t>
             </a:r>
           </a:p>
         </p:txBody>
@@ -1034,7 +1034,7 @@
           </a:p>
           <a:p xmlns:a="http://schemas.openxmlformats.org/drawingml/2006/main">
             <a:r>
-              <a:t>The upper-left panel is requests meeting both latency targets per second, where higher is better. The upper-right is total generated tokens per second. The lower-left is first-token tail latency, where lower is better. The lower-right is the GPU-busy percentage.</a:t>
+              <a:t>The upper-left panel is SLO goodput: requests meeting both latency targets per second, where higher is better. The upper-right is total generated tokens per second. The lower-left is first-token tail latency, where lower is better. The lower-right is the GPU-busy percentage.</a:t>
             </a:r>
           </a:p>
           <a:p xmlns:a="http://schemas.openxmlformats.org/drawingml/2006/main">
@@ -1044,7 +1044,7 @@
           </a:p>
           <a:p xmlns:a="http://schemas.openxmlformats.org/drawingml/2006/main">
             <a:r>
-              <a:t>The context-budget rule performs worse on goodput and throughput and increases first-token delay. Yet GPU busy time is near one hundred percent for every policy. This shows why that percentage alone is an inadequate optimization target.</a:t>
+              <a:t>The context-budget rule performs worse on SLO goodput and output throughput and increases first-token delay. Yet GPU busy time is near one hundred percent for every policy. This shows why that percentage alone is an inadequate optimization target.</a:t>
             </a:r>
           </a:p>
           <a:p xmlns:a="http://schemas.openxmlformats.org/drawingml/2006/main">
@@ -1134,7 +1134,7 @@
           <a:lstStyle xmlns:a="http://schemas.openxmlformats.org/drawingml/2006/main"/>
           <a:p xmlns:a="http://schemas.openxmlformats.org/drawingml/2006/main">
             <a:r>
-              <a:t>This table gives the exact means behind the scheduling graphs. Direct vLLM produces about 2.588 latency-compliant requests per second, compared with 2.013 for the context rule. Across paired repetitions, that is a twenty-to-twenty-four-percent loss. The latency column is the mean of each run's p99, not a percentile pooled across all requests.</a:t>
+              <a:t>This table gives the means behind the scheduling graphs. Default vLLM produces about 2.588 requests meeting the latency targets per second, compared with 2.013 for the context-budget rule. Across paired repetitions, the rule reduces SLO goodput by twenty to twenty-four percent. The latency column averages each run's p99; it is not a percentile pooled across all requests.</a:t>
             </a:r>
           </a:p>
           <a:p xmlns:a="http://schemas.openxmlformats.org/drawingml/2006/main">
@@ -1144,7 +1144,7 @@
           </a:p>
           <a:p xmlns:a="http://schemas.openxmlformats.org/drawingml/2006/main">
             <a:r>
-              <a:t>The phase analysis exposes the specific problem: all ninety-six initial short requests meet our targets, while none of the ninety-six short requests after the long burst meet them in any trial. The candidate takes longer to finish the outstanding workload. Almost the same number of requests pass, so a longer replay-and-drain time explains much of the goodput difference.</a:t>
+              <a:t>We established two observations under these test conditions. Near-one-hundred-percent GPU busy time coexists with requests missing their latency targets. Also, our first context-budget admission rule performs worse than default vLLM. GPU activity alone therefore does not tell us how much timely service the system provides.</a:t>
             </a:r>
           </a:p>
           <a:p xmlns:a="http://schemas.openxmlformats.org/drawingml/2006/main">
@@ -1154,7 +1154,17 @@
           </a:p>
           <a:p xmlns:a="http://schemas.openxmlformats.org/drawingml/2006/main">
             <a:r>
-              <a:t>This rejects the tested setting. It does not prove the causal bottleneck, and it does not establish sustainable capacity at eight requests per second.</a:t>
+              <a:t>The phase analysis identifies the burst-recovery problem. All ninety-six initial short requests meet the targets, while none of the ninety-six short requests after the long burst meet them in any policy or repetition. Similar numbers pass across policies, but the candidate takes longer to drain the workload, which explains much of its lower SLO goodput.</a:t>
+            </a:r>
+          </a:p>
+          <a:p xmlns:a="http://schemas.openxmlformats.org/drawingml/2006/main">
+            <a:r>
+              <a:t/>
+            </a:r>
+          </a:p>
+          <a:p xmlns:a="http://schemas.openxmlformats.org/drawingml/2006/main">
+            <a:r>
+              <a:t>These results reject this tested setting. They do not isolate the causal bottleneck or establish sustainable capacity at eight requests per second.</a:t>
             </a:r>
           </a:p>
           <a:p xmlns:a="http://schemas.openxmlformats.org/drawingml/2006/main">
@@ -1239,7 +1249,7 @@
           <a:lstStyle xmlns:a="http://schemas.openxmlformats.org/drawingml/2006/main"/>
           <a:p xmlns:a="http://schemas.openxmlformats.org/drawingml/2006/main">
             <a:r>
-              <a:t>The research question remains open: can better admission preserve useful concurrency and improve recovery after a long-prompt burst?</a:t>
+              <a:t>Our research progression is: problem observed, baselines measured, a simple hypothesis tested, the tested rule rejected, then a better-controlled next hypothesis.</a:t>
             </a:r>
           </a:p>
           <a:p xmlns:a="http://schemas.openxmlformats.org/drawingml/2006/main">
@@ -1249,7 +1259,7 @@
           </a:p>
           <a:p xmlns:a="http://schemas.openxmlformats.org/drawingml/2006/main">
             <a:r>
-              <a:t>Our next experiment should test whether measured processing cost and remaining deadline time add value beyond a calibrated simple limit. We would use separate data for calibration, freeze the decision rule and compare on unseen bursts at declared arrival rates. All requested work and waiting must remain accounted for, including any dropped requests and long-request fairness.</a:t>
+              <a:t>We do not yet have a better scheduler. We have a reproducible burst-recovery problem and evidence that this simple size-based gate is insufficient under the tested conditions. The next question is whether admission decisions informed by estimated processing cost, system state and remaining latency budget can increase SLO goodput beyond both default vLLM and simpler admission limits.</a:t>
             </a:r>
           </a:p>
           <a:p xmlns:a="http://schemas.openxmlformats.org/drawingml/2006/main">
@@ -1259,7 +1269,7 @@
           </a:p>
           <a:p xmlns:a="http://schemas.openxmlformats.org/drawingml/2006/main">
             <a:r>
-              <a:t>The current rule admits at most nine requests when all are long. It changes throttling, ordering and age protection together, so we cannot isolate their contributions. A controlled comparison should hold fairness conditions fixed and include a version without the adaptive decision.</a:t>
+              <a:t>We propose one controlled comparison. Use separate data to estimate processing cost, identify useful state signals and calibrate a strong simple admission limit. Freeze the candidate and controls before testing on unseen burst traces at predeclared arrival rates, with independent engine repetitions on the same GPU and model. Include a version with adaptation removed to test what the adaptive decision adds.</a:t>
             </a:r>
           </a:p>
           <a:p xmlns:a="http://schemas.openxmlformats.org/drawingml/2006/main">
@@ -1269,7 +1279,17 @@
           </a:p>
           <a:p xmlns:a="http://schemas.openxmlformats.org/drawingml/2006/main">
             <a:r>
-              <a:t>One model and one workload do not establish generalization. We did not measure achieved SM efficiency or answer-quality equivalence. A negative result remains informative if the experiment honestly determines where a policy helps or fails.</a:t>
+              <a:t>All requests and waiting time must count. Keep fairness conditions matched and check tail latency for long requests as well as SLO goodput. Report any dropped requests. The current gate admits at most nine all-long requests and changes throttling, ordering and age protection together, so its failure does not identify the best replacement or rule out every size-based policy.</a:t>
+            </a:r>
+          </a:p>
+          <a:p xmlns:a="http://schemas.openxmlformats.org/drawingml/2006/main">
+            <a:r>
+              <a:t/>
+            </a:r>
+          </a:p>
+          <a:p xmlns:a="http://schemas.openxmlformats.org/drawingml/2006/main">
+            <a:r>
+              <a:t>The outcome remains open: the adaptive candidate may help, fail, or reveal a load beyond what this hardware can serve within the targets. One model and workload do not establish generalization or improved GPU compute efficiency.</a:t>
             </a:r>
           </a:p>
           <a:p xmlns:a="http://schemas.openxmlformats.org/drawingml/2006/main">
@@ -1369,7 +1389,7 @@
           </a:p>
           <a:p xmlns:a="http://schemas.openxmlformats.org/drawingml/2006/main">
             <a:r>
-              <a:t>The final research message is that we have measured a burst-recovery failure and rejected one simple admission rule. We are proposing a controlled investigation into better decisions, without claiming a solved algorithm or a proven increase in compute efficiency.</a:t>
+              <a:t>The final research message is that we have measured a burst-recovery failure and rejected one simple admission rule. The next hypothesis tests whether processing cost, system state and remaining latency budget can guide admission to increase SLO goodput beyond default vLLM and calibrated simple limits. The algorithm and any improvement remain to be established.</a:t>
             </a:r>
           </a:p>
           <a:p xmlns:a="http://schemas.openxmlformats.org/drawingml/2006/main">
@@ -1449,7 +1469,7 @@
           <a:lstStyle xmlns:a="http://schemas.openxmlformats.org/drawingml/2006/main"/>
           <a:p xmlns:a="http://schemas.openxmlformats.org/drawingml/2006/main">
             <a:r>
-              <a:t>Imagine an AI service receiving short questions, followed by several long documents, and then more short questions. Processing the long inputs takes work, and the later requests may wait.</a:t>
+              <a:t>Can better admission decisions increase SLO goodput during bursts of long prompts? SLO goodput means the number of requests completed within latency targets per second. In our finite replay experiment, the denominator includes the arrival period and the time required to finish all outstanding work.</a:t>
             </a:r>
           </a:p>
           <a:p xmlns:a="http://schemas.openxmlformats.org/drawingml/2006/main">
@@ -1459,7 +1479,7 @@
           </a:p>
           <a:p xmlns:a="http://schemas.openxmlformats.org/drawingml/2006/main">
             <a:r>
-              <a:t>The research question is whether scheduling can make more requests finish within our latency targets on the same GPU. Admission means deciding when a waiting request is submitted to the model-serving engine. Continuous batching means the engine can bring requests into an ongoing batch as other requests finish.</a:t>
+              <a:t>Imagine short questions arriving, followed by long documents and then more short questions. The later questions may spend their latency budget waiting for the backlog to clear. Admission decides when and how many waiting requests enter the serving engine.</a:t>
             </a:r>
           </a:p>
           <a:p xmlns:a="http://schemas.openxmlformats.org/drawingml/2006/main">
@@ -1469,7 +1489,7 @@
           </a:p>
           <a:p xmlns:a="http://schemas.openxmlformats.org/drawingml/2006/main">
             <a:r>
-              <a:t>Our hypothesis is that an estimate of processing cost and remaining deadline time may improve those decisions. The alternative is that an extra admission gate simply delays requests and reduces useful concurrency. Both outcomes must remain possible.</a:t>
+              <a:t>Our hypothesis is that estimated processing cost, system state and remaining latency budget can improve SLO goodput without worsening tail latency. System state could include queued work and available resources; the useful signals still need to be tested. The competing explanation is that an extra gate suppresses useful concurrency and delays work that vLLM handles more effectively.</a:t>
             </a:r>
           </a:p>
           <a:p xmlns:a="http://schemas.openxmlformats.org/drawingml/2006/main">
@@ -2129,7 +2149,7 @@
           </a:p>
           <a:p xmlns:a="http://schemas.openxmlformats.org/drawingml/2006/main">
             <a:r>
-              <a:t>Throughput counts output tokens per second. Goodput counts requests that meet both response-time targets per second. In the scheduling study, the denominator includes replaying arrivals and finishing outstanding work.</a:t>
+              <a:t>Throughput counts output tokens per second. SLO goodput counts requests that meet both response-time targets per second. In the scheduling study, the denominator includes replaying arrivals and finishing outstanding work.</a:t>
             </a:r>
           </a:p>
           <a:p xmlns:a="http://schemas.openxmlformats.org/drawingml/2006/main">
@@ -4047,14 +4067,14 @@
   </p:cSld>
   <p:clrMap bg1="lt1" tx1="dk1" bg2="lt2" tx2="dk2" accent1="accent1" accent2="accent2" accent3="accent3" accent4="accent4" accent5="accent5" accent6="accent6" hlink="hlink" folHlink="folHlink"/>
   <p:sldLayoutIdLst>
-    <p:sldLayoutId xmlns:r="http://schemas.openxmlformats.org/officeDocument/2006/relationships" id="2147483649" r:id="R768045dfd20b43dd"/>
-    <p:sldLayoutId xmlns:r="http://schemas.openxmlformats.org/officeDocument/2006/relationships" id="2147483650" r:id="Ra859fd1d01384966"/>
-    <p:sldLayoutId xmlns:r="http://schemas.openxmlformats.org/officeDocument/2006/relationships" id="2147483651" r:id="Rf87ec76a897f4887"/>
-    <p:sldLayoutId xmlns:r="http://schemas.openxmlformats.org/officeDocument/2006/relationships" id="2147483652" r:id="Rdb7fc0ee77e042e8"/>
-    <p:sldLayoutId xmlns:r="http://schemas.openxmlformats.org/officeDocument/2006/relationships" id="2147483653" r:id="Rad6f2837db7a4496"/>
-    <p:sldLayoutId xmlns:r="http://schemas.openxmlformats.org/officeDocument/2006/relationships" id="2147483654" r:id="R4ec302fb235d4961"/>
-    <p:sldLayoutId xmlns:r="http://schemas.openxmlformats.org/officeDocument/2006/relationships" id="2147483655" r:id="R62a644a3e66b4624"/>
-    <p:sldLayoutId xmlns:r="http://schemas.openxmlformats.org/officeDocument/2006/relationships" id="2147483656" r:id="R96b2f7d0521b4366"/>
+    <p:sldLayoutId xmlns:r="http://schemas.openxmlformats.org/officeDocument/2006/relationships" id="2147483649" r:id="R02cf0483b5bc41fb"/>
+    <p:sldLayoutId xmlns:r="http://schemas.openxmlformats.org/officeDocument/2006/relationships" id="2147483650" r:id="Ra0f5bc91e3c94bee"/>
+    <p:sldLayoutId xmlns:r="http://schemas.openxmlformats.org/officeDocument/2006/relationships" id="2147483651" r:id="R255a55869e0242f9"/>
+    <p:sldLayoutId xmlns:r="http://schemas.openxmlformats.org/officeDocument/2006/relationships" id="2147483652" r:id="R05bbb4cb21014f78"/>
+    <p:sldLayoutId xmlns:r="http://schemas.openxmlformats.org/officeDocument/2006/relationships" id="2147483653" r:id="R8bd582f245474a39"/>
+    <p:sldLayoutId xmlns:r="http://schemas.openxmlformats.org/officeDocument/2006/relationships" id="2147483654" r:id="R366fed52e419490f"/>
+    <p:sldLayoutId xmlns:r="http://schemas.openxmlformats.org/officeDocument/2006/relationships" id="2147483655" r:id="R00340edf2e314b8b"/>
+    <p:sldLayoutId xmlns:r="http://schemas.openxmlformats.org/officeDocument/2006/relationships" id="2147483656" r:id="Rd1037c5f6c5546ae"/>
   </p:sldLayoutIdLst>
   <p:hf hdr="0" dt="0"/>
   <p:txStyles>
@@ -11499,7 +11519,7 @@
                 <a:latin typeface="Helvetica Neue"/>
                 <a:ea typeface="Helvetica Neue"/>
                 <a:cs typeface="Helvetica Neue"/>
-                <a:hlinkClick xmlns:r="http://schemas.openxmlformats.org/officeDocument/2006/relationships" r:id="R3f06c149006f42a4"/>
+                <a:hlinkClick xmlns:r="http://schemas.openxmlformats.org/officeDocument/2006/relationships" r:id="Rfef04ba8031444cd"/>
               </a:rPr>
               <a:t>Our executed capture protocol</a:t>
             </a:r>
@@ -11519,7 +11539,7 @@
                 <a:latin typeface="Helvetica Neue"/>
                 <a:ea typeface="Helvetica Neue"/>
                 <a:cs typeface="Helvetica Neue"/>
-                <a:hlinkClick xmlns:r="http://schemas.openxmlformats.org/officeDocument/2006/relationships" r:id="R7397f6e4960e4758"/>
+                <a:hlinkClick xmlns:r="http://schemas.openxmlformats.org/officeDocument/2006/relationships" r:id="Rb128b36080b4429b"/>
               </a:rPr>
               <a:t>NVIDIA capture-size tradeoff</a:t>
             </a:r>
@@ -11638,7 +11658,7 @@
           <p:cNvPr id="534" name="">
             <a:extLst xmlns:a="http://schemas.openxmlformats.org/drawingml/2006/main">
               <a:ext uri="{FF2B5EF4-FFF2-40B4-BE49-F238E27FC236}">
-                <a16:creationId xmlns:a16="http://schemas.microsoft.com/office/drawing/2014/main" id="{7E28DBB9-35BF-4F1B-9CA6-CD751EB3400D}"/>
+                <a16:creationId xmlns:a16="http://schemas.microsoft.com/office/drawing/2014/main" id="{649EE8D6-2BC2-49C8-92DE-7C7CDB6B92B8}"/>
               </a:ext>
             </a:extLst>
           </p:cNvPr>
@@ -12037,7 +12057,7 @@
           <p:cNvPr id="536" name="">
             <a:extLst xmlns:a="http://schemas.openxmlformats.org/drawingml/2006/main">
               <a:ext uri="{FF2B5EF4-FFF2-40B4-BE49-F238E27FC236}">
-                <a16:creationId xmlns:a16="http://schemas.microsoft.com/office/drawing/2014/main" id="{75CDF067-3F7A-44D6-9B41-6E06F47E63B2}"/>
+                <a16:creationId xmlns:a16="http://schemas.microsoft.com/office/drawing/2014/main" id="{FC899511-DE66-48F5-936C-845BBBE6E742}"/>
               </a:ext>
             </a:extLst>
           </p:cNvPr>
@@ -12094,7 +12114,7 @@
           <p:cNvPr id="537" name="">
             <a:extLst xmlns:a="http://schemas.openxmlformats.org/drawingml/2006/main">
               <a:ext uri="{FF2B5EF4-FFF2-40B4-BE49-F238E27FC236}">
-                <a16:creationId xmlns:a16="http://schemas.microsoft.com/office/drawing/2014/main" id="{82F03C7B-34AA-4CFE-95D9-07C921A5279A}"/>
+                <a16:creationId xmlns:a16="http://schemas.microsoft.com/office/drawing/2014/main" id="{8657D3E3-CCCC-40E0-AC43-313982621FB0}"/>
               </a:ext>
             </a:extLst>
           </p:cNvPr>
@@ -12238,7 +12258,7 @@
                 <a:latin typeface="Helvetica Neue"/>
                 <a:ea typeface="Helvetica Neue"/>
                 <a:cs typeface="Helvetica Neue"/>
-                <a:hlinkClick xmlns:r="http://schemas.openxmlformats.org/officeDocument/2006/relationships" r:id="R2c81fb890c5845ce"/>
+                <a:hlinkClick xmlns:r="http://schemas.openxmlformats.org/officeDocument/2006/relationships" r:id="R4a69896e24be4b9a"/>
               </a:rPr>
               <a:t>Our frozen protocol and exact settings</a:t>
             </a:r>
@@ -12258,7 +12278,7 @@
                 <a:latin typeface="Helvetica Neue"/>
                 <a:ea typeface="Helvetica Neue"/>
                 <a:cs typeface="Helvetica Neue"/>
-                <a:hlinkClick xmlns:r="http://schemas.openxmlformats.org/officeDocument/2006/relationships" r:id="Rf8ce2cf8813540a1"/>
+                <a:hlinkClick xmlns:r="http://schemas.openxmlformats.org/officeDocument/2006/relationships" r:id="Rb8a266e9fc3c4328"/>
               </a:rPr>
               <a:t>W&amp;B runs</a:t>
             </a:r>
@@ -12377,7 +12397,7 @@
           <p:cNvPr id="534" name="">
             <a:extLst xmlns:a="http://schemas.openxmlformats.org/drawingml/2006/main">
               <a:ext uri="{FF2B5EF4-FFF2-40B4-BE49-F238E27FC236}">
-                <a16:creationId xmlns:a16="http://schemas.microsoft.com/office/drawing/2014/main" id="{2CCC637A-1978-4C96-BDFC-16BD27056BA4}"/>
+                <a16:creationId xmlns:a16="http://schemas.microsoft.com/office/drawing/2014/main" id="{DDDB1743-1AA8-423E-AC68-B1AD055F1683}"/>
               </a:ext>
             </a:extLst>
           </p:cNvPr>
@@ -12656,7 +12676,7 @@
           <p:cNvPr id="536" name="">
             <a:extLst xmlns:a="http://schemas.openxmlformats.org/drawingml/2006/main">
               <a:ext uri="{FF2B5EF4-FFF2-40B4-BE49-F238E27FC236}">
-                <a16:creationId xmlns:a16="http://schemas.microsoft.com/office/drawing/2014/main" id="{413C4C8A-9154-422E-9801-12884E533D03}"/>
+                <a16:creationId xmlns:a16="http://schemas.microsoft.com/office/drawing/2014/main" id="{898B79DE-C5AF-4735-88B8-7EC901EC6020}"/>
               </a:ext>
             </a:extLst>
           </p:cNvPr>
@@ -12736,7 +12756,7 @@
           <p:cNvPr id="537" name="">
             <a:extLst xmlns:a="http://schemas.openxmlformats.org/drawingml/2006/main">
               <a:ext uri="{FF2B5EF4-FFF2-40B4-BE49-F238E27FC236}">
-                <a16:creationId xmlns:a16="http://schemas.microsoft.com/office/drawing/2014/main" id="{A124E7F0-5E62-4AEC-A06D-134FF97594E3}"/>
+                <a16:creationId xmlns:a16="http://schemas.microsoft.com/office/drawing/2014/main" id="{2D00BCF6-34DC-4FA0-ABF6-0B2AE6CB8C69}"/>
               </a:ext>
             </a:extLst>
           </p:cNvPr>
@@ -12816,7 +12836,7 @@
           <p:cNvPr id="538" name="">
             <a:extLst xmlns:a="http://schemas.openxmlformats.org/drawingml/2006/main">
               <a:ext uri="{FF2B5EF4-FFF2-40B4-BE49-F238E27FC236}">
-                <a16:creationId xmlns:a16="http://schemas.microsoft.com/office/drawing/2014/main" id="{72BF1FE3-24D3-4DE4-BB99-83BF191DC696}"/>
+                <a16:creationId xmlns:a16="http://schemas.microsoft.com/office/drawing/2014/main" id="{C2D80C34-406F-442D-8352-B773C6763F29}"/>
               </a:ext>
             </a:extLst>
           </p:cNvPr>
@@ -13056,7 +13076,7 @@
           <p:cNvPr id="534" name="">
             <a:extLst xmlns:a="http://schemas.openxmlformats.org/drawingml/2006/main">
               <a:ext uri="{FF2B5EF4-FFF2-40B4-BE49-F238E27FC236}">
-                <a16:creationId xmlns:a16="http://schemas.microsoft.com/office/drawing/2014/main" id="{1A0D4CCE-8D78-456A-92A9-83678613E8B1}"/>
+                <a16:creationId xmlns:a16="http://schemas.microsoft.com/office/drawing/2014/main" id="{81628789-DE62-41C7-B76D-2550748E13F1}"/>
               </a:ext>
             </a:extLst>
           </p:cNvPr>
@@ -13159,7 +13179,7 @@
                 <a:latin typeface="Helvetica Neue"/>
                 <a:ea typeface="Helvetica Neue"/>
                 <a:cs typeface="Helvetica Neue"/>
-                <a:hlinkClick xmlns:r="http://schemas.openxmlformats.org/officeDocument/2006/relationships" r:id="Red881a2820694fae"/>
+                <a:hlinkClick xmlns:r="http://schemas.openxmlformats.org/officeDocument/2006/relationships" r:id="Rd666df03d5814918"/>
               </a:rPr>
               <a:t>Source: our raw timing records and W&amp;B</a:t>
             </a:r>
@@ -13278,7 +13298,7 @@
           <p:cNvPr id="534" name="">
             <a:extLst xmlns:a="http://schemas.openxmlformats.org/drawingml/2006/main">
               <a:ext uri="{FF2B5EF4-FFF2-40B4-BE49-F238E27FC236}">
-                <a16:creationId xmlns:a16="http://schemas.microsoft.com/office/drawing/2014/main" id="{4BF5D1C7-4EA1-4872-86E0-0E878C207A13}"/>
+                <a16:creationId xmlns:a16="http://schemas.microsoft.com/office/drawing/2014/main" id="{B844DE1C-4095-4420-BC5B-C3F944D877D6}"/>
               </a:ext>
             </a:extLst>
           </p:cNvPr>
@@ -13358,7 +13378,7 @@
           <p:cNvPr id="535" name="">
             <a:extLst xmlns:a="http://schemas.openxmlformats.org/drawingml/2006/main">
               <a:ext uri="{FF2B5EF4-FFF2-40B4-BE49-F238E27FC236}">
-                <a16:creationId xmlns:a16="http://schemas.microsoft.com/office/drawing/2014/main" id="{41CAB78E-A276-43FF-8500-C32C38D2174E}"/>
+                <a16:creationId xmlns:a16="http://schemas.microsoft.com/office/drawing/2014/main" id="{21D5A5D0-36B4-43B0-A077-DE6055339A4D}"/>
               </a:ext>
             </a:extLst>
           </p:cNvPr>
@@ -13422,7 +13442,7 @@
         </p:xfrm>
         <a:graphic xmlns:a="http://schemas.openxmlformats.org/drawingml/2006/main">
           <a:graphicData uri="http://schemas.openxmlformats.org/drawingml/2006/chart">
-            <c:chart xmlns:r="http://schemas.openxmlformats.org/officeDocument/2006/relationships" xmlns:c="http://schemas.openxmlformats.org/drawingml/2006/chart" r:id="R3a843dc101c84a47"/>
+            <c:chart xmlns:r="http://schemas.openxmlformats.org/officeDocument/2006/relationships" xmlns:c="http://schemas.openxmlformats.org/drawingml/2006/chart" r:id="R3cfbd7fbbfa6421d"/>
           </a:graphicData>
         </a:graphic>
       </p:graphicFrame>
@@ -13431,7 +13451,7 @@
           <p:cNvPr id="537" name="">
             <a:extLst xmlns:a="http://schemas.openxmlformats.org/drawingml/2006/main">
               <a:ext uri="{FF2B5EF4-FFF2-40B4-BE49-F238E27FC236}">
-                <a16:creationId xmlns:a16="http://schemas.microsoft.com/office/drawing/2014/main" id="{87904CFD-2F3E-49D2-AD18-75734018AE35}"/>
+                <a16:creationId xmlns:a16="http://schemas.microsoft.com/office/drawing/2014/main" id="{811A0C3C-4DA2-4C1D-845E-96A301DE5008}"/>
               </a:ext>
             </a:extLst>
           </p:cNvPr>
@@ -13488,7 +13508,7 @@
           <p:cNvPr id="538" name="">
             <a:extLst xmlns:a="http://schemas.openxmlformats.org/drawingml/2006/main">
               <a:ext uri="{FF2B5EF4-FFF2-40B4-BE49-F238E27FC236}">
-                <a16:creationId xmlns:a16="http://schemas.microsoft.com/office/drawing/2014/main" id="{0EF534B2-296A-4C59-BC70-DFECAB2B8712}"/>
+                <a16:creationId xmlns:a16="http://schemas.microsoft.com/office/drawing/2014/main" id="{79DA8CCF-7A30-4F78-B6AE-7BEA43FC0DEF}"/>
               </a:ext>
             </a:extLst>
           </p:cNvPr>
@@ -13545,7 +13565,7 @@
           <p:cNvPr id="539" name="">
             <a:extLst xmlns:a="http://schemas.openxmlformats.org/drawingml/2006/main">
               <a:ext uri="{FF2B5EF4-FFF2-40B4-BE49-F238E27FC236}">
-                <a16:creationId xmlns:a16="http://schemas.microsoft.com/office/drawing/2014/main" id="{F4FA576D-58FD-4341-83C4-4BD7EC557629}"/>
+                <a16:creationId xmlns:a16="http://schemas.microsoft.com/office/drawing/2014/main" id="{E5C97117-8331-45A6-A89A-882B7CC2FC34}"/>
               </a:ext>
             </a:extLst>
           </p:cNvPr>
@@ -13609,7 +13629,7 @@
         </p:xfrm>
         <a:graphic xmlns:a="http://schemas.openxmlformats.org/drawingml/2006/main">
           <a:graphicData uri="http://schemas.openxmlformats.org/drawingml/2006/chart">
-            <c:chart xmlns:r="http://schemas.openxmlformats.org/officeDocument/2006/relationships" xmlns:c="http://schemas.openxmlformats.org/drawingml/2006/chart" r:id="R8ba54b1a4f354396"/>
+            <c:chart xmlns:r="http://schemas.openxmlformats.org/officeDocument/2006/relationships" xmlns:c="http://schemas.openxmlformats.org/drawingml/2006/chart" r:id="R4c04a7fe82ef4d7c"/>
           </a:graphicData>
         </a:graphic>
       </p:graphicFrame>
@@ -13618,7 +13638,7 @@
           <p:cNvPr id="541" name="">
             <a:extLst xmlns:a="http://schemas.openxmlformats.org/drawingml/2006/main">
               <a:ext uri="{FF2B5EF4-FFF2-40B4-BE49-F238E27FC236}">
-                <a16:creationId xmlns:a16="http://schemas.microsoft.com/office/drawing/2014/main" id="{B25C0B26-347E-476C-9940-A75300CE1A01}"/>
+                <a16:creationId xmlns:a16="http://schemas.microsoft.com/office/drawing/2014/main" id="{F2FAD359-F91A-4FF0-B5AA-0811DD5E178E}"/>
               </a:ext>
             </a:extLst>
           </p:cNvPr>
@@ -13675,7 +13695,7 @@
           <p:cNvPr id="542" name="">
             <a:extLst xmlns:a="http://schemas.openxmlformats.org/drawingml/2006/main">
               <a:ext uri="{FF2B5EF4-FFF2-40B4-BE49-F238E27FC236}">
-                <a16:creationId xmlns:a16="http://schemas.microsoft.com/office/drawing/2014/main" id="{C750D3BF-F32A-4C12-A3DB-EBAE9E9DABBD}"/>
+                <a16:creationId xmlns:a16="http://schemas.microsoft.com/office/drawing/2014/main" id="{12564182-6852-45BF-B9B7-5CD1854FC6E2}"/>
               </a:ext>
             </a:extLst>
           </p:cNvPr>
@@ -13732,7 +13752,7 @@
           <p:cNvPr id="543" name="">
             <a:extLst xmlns:a="http://schemas.openxmlformats.org/drawingml/2006/main">
               <a:ext uri="{FF2B5EF4-FFF2-40B4-BE49-F238E27FC236}">
-                <a16:creationId xmlns:a16="http://schemas.microsoft.com/office/drawing/2014/main" id="{B90E651F-E670-43EE-99F0-C1E070C9C0F7}"/>
+                <a16:creationId xmlns:a16="http://schemas.microsoft.com/office/drawing/2014/main" id="{CD7E504B-81F1-4F5E-8777-51153A5D1A45}"/>
               </a:ext>
             </a:extLst>
           </p:cNvPr>
@@ -13796,7 +13816,7 @@
         </p:xfrm>
         <a:graphic xmlns:a="http://schemas.openxmlformats.org/drawingml/2006/main">
           <a:graphicData uri="http://schemas.openxmlformats.org/drawingml/2006/chart">
-            <c:chart xmlns:r="http://schemas.openxmlformats.org/officeDocument/2006/relationships" xmlns:c="http://schemas.openxmlformats.org/drawingml/2006/chart" r:id="R71e75670dc94424f"/>
+            <c:chart xmlns:r="http://schemas.openxmlformats.org/officeDocument/2006/relationships" xmlns:c="http://schemas.openxmlformats.org/drawingml/2006/chart" r:id="Rd532295e66784791"/>
           </a:graphicData>
         </a:graphic>
       </p:graphicFrame>
@@ -13805,7 +13825,7 @@
           <p:cNvPr id="545" name="">
             <a:extLst xmlns:a="http://schemas.openxmlformats.org/drawingml/2006/main">
               <a:ext uri="{FF2B5EF4-FFF2-40B4-BE49-F238E27FC236}">
-                <a16:creationId xmlns:a16="http://schemas.microsoft.com/office/drawing/2014/main" id="{13763ED7-3FAA-4825-BF81-96789549A81F}"/>
+                <a16:creationId xmlns:a16="http://schemas.microsoft.com/office/drawing/2014/main" id="{82C43290-7A18-4D9D-AA61-36F50E44DDB5}"/>
               </a:ext>
             </a:extLst>
           </p:cNvPr>
@@ -13862,7 +13882,7 @@
           <p:cNvPr id="546" name="">
             <a:extLst xmlns:a="http://schemas.openxmlformats.org/drawingml/2006/main">
               <a:ext uri="{FF2B5EF4-FFF2-40B4-BE49-F238E27FC236}">
-                <a16:creationId xmlns:a16="http://schemas.microsoft.com/office/drawing/2014/main" id="{464BFCF4-E5C8-40C6-A197-8DEADAAAFC98}"/>
+                <a16:creationId xmlns:a16="http://schemas.microsoft.com/office/drawing/2014/main" id="{71CD52A1-02DB-488A-959F-13EB86EA6C9D}"/>
               </a:ext>
             </a:extLst>
           </p:cNvPr>
@@ -13919,7 +13939,7 @@
           <p:cNvPr id="547" name="">
             <a:extLst xmlns:a="http://schemas.openxmlformats.org/drawingml/2006/main">
               <a:ext uri="{FF2B5EF4-FFF2-40B4-BE49-F238E27FC236}">
-                <a16:creationId xmlns:a16="http://schemas.microsoft.com/office/drawing/2014/main" id="{8DA8E333-8C7D-4318-B647-CF680450D71E}"/>
+                <a16:creationId xmlns:a16="http://schemas.microsoft.com/office/drawing/2014/main" id="{371E0879-C68F-4AD5-908E-44B282F01FF7}"/>
               </a:ext>
             </a:extLst>
           </p:cNvPr>
@@ -13976,7 +13996,7 @@
           <p:cNvPr id="548" name="">
             <a:extLst xmlns:a="http://schemas.openxmlformats.org/drawingml/2006/main">
               <a:ext uri="{FF2B5EF4-FFF2-40B4-BE49-F238E27FC236}">
-                <a16:creationId xmlns:a16="http://schemas.microsoft.com/office/drawing/2014/main" id="{ECDE2224-6B22-42AD-BAF2-7581ED299679}"/>
+                <a16:creationId xmlns:a16="http://schemas.microsoft.com/office/drawing/2014/main" id="{05C4F0AC-E40E-4BB9-AF48-6AA60525532D}"/>
               </a:ext>
             </a:extLst>
           </p:cNvPr>
@@ -14033,7 +14053,7 @@
           <p:cNvPr id="549" name="">
             <a:extLst xmlns:a="http://schemas.openxmlformats.org/drawingml/2006/main">
               <a:ext uri="{FF2B5EF4-FFF2-40B4-BE49-F238E27FC236}">
-                <a16:creationId xmlns:a16="http://schemas.microsoft.com/office/drawing/2014/main" id="{B462EFF5-8F44-45F6-960D-C530AD2A140E}"/>
+                <a16:creationId xmlns:a16="http://schemas.microsoft.com/office/drawing/2014/main" id="{E19FC9FF-9066-4886-808E-C45850E67587}"/>
               </a:ext>
             </a:extLst>
           </p:cNvPr>
@@ -14090,7 +14110,7 @@
           <p:cNvPr id="550" name="">
             <a:extLst xmlns:a="http://schemas.openxmlformats.org/drawingml/2006/main">
               <a:ext uri="{FF2B5EF4-FFF2-40B4-BE49-F238E27FC236}">
-                <a16:creationId xmlns:a16="http://schemas.microsoft.com/office/drawing/2014/main" id="{C5C4CA85-7FE0-4DFF-82F8-D1E85AA9D953}"/>
+                <a16:creationId xmlns:a16="http://schemas.microsoft.com/office/drawing/2014/main" id="{92AA8613-0EF8-4BC2-A2F0-70EC40E94628}"/>
               </a:ext>
             </a:extLst>
           </p:cNvPr>
@@ -14211,7 +14231,7 @@
                 <a:latin typeface="Helvetica Neue"/>
                 <a:ea typeface="Helvetica Neue"/>
                 <a:cs typeface="Helvetica Neue"/>
-                <a:hlinkClick xmlns:r="http://schemas.openxmlformats.org/officeDocument/2006/relationships" r:id="R936a3a84c2e64a18"/>
+                <a:hlinkClick xmlns:r="http://schemas.openxmlformats.org/officeDocument/2006/relationships" r:id="R4d1741a47aca46f9"/>
               </a:rPr>
               <a:t>Source: our earlier Qwen timing records and W&amp;B</a:t>
             </a:r>
@@ -14330,7 +14350,7 @@
           <p:cNvPr id="534" name="">
             <a:extLst xmlns:a="http://schemas.openxmlformats.org/drawingml/2006/main">
               <a:ext uri="{FF2B5EF4-FFF2-40B4-BE49-F238E27FC236}">
-                <a16:creationId xmlns:a16="http://schemas.microsoft.com/office/drawing/2014/main" id="{655841DF-CF1A-4A7D-9A5C-AB8125C14B3A}"/>
+                <a16:creationId xmlns:a16="http://schemas.microsoft.com/office/drawing/2014/main" id="{82AFEA61-5272-4B1B-9E95-7DCD23ADA83A}"/>
               </a:ext>
             </a:extLst>
           </p:cNvPr>
@@ -14410,7 +14430,7 @@
           <p:cNvPr id="535" name="">
             <a:extLst xmlns:a="http://schemas.openxmlformats.org/drawingml/2006/main">
               <a:ext uri="{FF2B5EF4-FFF2-40B4-BE49-F238E27FC236}">
-                <a16:creationId xmlns:a16="http://schemas.microsoft.com/office/drawing/2014/main" id="{E17FA96B-3CD8-47A4-A920-B22DBF2ACE76}"/>
+                <a16:creationId xmlns:a16="http://schemas.microsoft.com/office/drawing/2014/main" id="{D9D98EA9-E930-406E-8DAB-FA4EE905C1B4}"/>
               </a:ext>
             </a:extLst>
           </p:cNvPr>
@@ -14474,7 +14494,7 @@
         </p:xfrm>
         <a:graphic xmlns:a="http://schemas.openxmlformats.org/drawingml/2006/main">
           <a:graphicData uri="http://schemas.openxmlformats.org/drawingml/2006/chart">
-            <c:chart xmlns:r="http://schemas.openxmlformats.org/officeDocument/2006/relationships" xmlns:c="http://schemas.openxmlformats.org/drawingml/2006/chart" r:id="R3f4f3bf280564aff"/>
+            <c:chart xmlns:r="http://schemas.openxmlformats.org/officeDocument/2006/relationships" xmlns:c="http://schemas.openxmlformats.org/drawingml/2006/chart" r:id="R9e9d7db444d14633"/>
           </a:graphicData>
         </a:graphic>
       </p:graphicFrame>
@@ -14483,7 +14503,7 @@
           <p:cNvPr id="537" name="">
             <a:extLst xmlns:a="http://schemas.openxmlformats.org/drawingml/2006/main">
               <a:ext uri="{FF2B5EF4-FFF2-40B4-BE49-F238E27FC236}">
-                <a16:creationId xmlns:a16="http://schemas.microsoft.com/office/drawing/2014/main" id="{F8B4E07D-FB4D-4E64-851C-B96D72D56BC1}"/>
+                <a16:creationId xmlns:a16="http://schemas.microsoft.com/office/drawing/2014/main" id="{7DAE86E9-C1EA-4F32-BB93-B1C93BD098E7}"/>
               </a:ext>
             </a:extLst>
           </p:cNvPr>
@@ -14540,7 +14560,7 @@
           <p:cNvPr id="538" name="">
             <a:extLst xmlns:a="http://schemas.openxmlformats.org/drawingml/2006/main">
               <a:ext uri="{FF2B5EF4-FFF2-40B4-BE49-F238E27FC236}">
-                <a16:creationId xmlns:a16="http://schemas.microsoft.com/office/drawing/2014/main" id="{8562DFF0-B67C-45B6-9E9C-EC477C06F3AE}"/>
+                <a16:creationId xmlns:a16="http://schemas.microsoft.com/office/drawing/2014/main" id="{6E8E087E-9B45-430E-8230-FAE1270343F2}"/>
               </a:ext>
             </a:extLst>
           </p:cNvPr>
@@ -14597,7 +14617,7 @@
           <p:cNvPr id="539" name="">
             <a:extLst xmlns:a="http://schemas.openxmlformats.org/drawingml/2006/main">
               <a:ext uri="{FF2B5EF4-FFF2-40B4-BE49-F238E27FC236}">
-                <a16:creationId xmlns:a16="http://schemas.microsoft.com/office/drawing/2014/main" id="{1F6EB225-8DB7-4FBD-8A8F-8F71FEDAABEE}"/>
+                <a16:creationId xmlns:a16="http://schemas.microsoft.com/office/drawing/2014/main" id="{FEEC94F3-6F45-42E6-AAAB-0DEFB328C091}"/>
               </a:ext>
             </a:extLst>
           </p:cNvPr>
@@ -14661,7 +14681,7 @@
         </p:xfrm>
         <a:graphic xmlns:a="http://schemas.openxmlformats.org/drawingml/2006/main">
           <a:graphicData uri="http://schemas.openxmlformats.org/drawingml/2006/chart">
-            <c:chart xmlns:r="http://schemas.openxmlformats.org/officeDocument/2006/relationships" xmlns:c="http://schemas.openxmlformats.org/drawingml/2006/chart" r:id="R0dd59f08aed54d86"/>
+            <c:chart xmlns:r="http://schemas.openxmlformats.org/officeDocument/2006/relationships" xmlns:c="http://schemas.openxmlformats.org/drawingml/2006/chart" r:id="R6a6f1c8db5e74bf4"/>
           </a:graphicData>
         </a:graphic>
       </p:graphicFrame>
@@ -14670,7 +14690,7 @@
           <p:cNvPr id="541" name="">
             <a:extLst xmlns:a="http://schemas.openxmlformats.org/drawingml/2006/main">
               <a:ext uri="{FF2B5EF4-FFF2-40B4-BE49-F238E27FC236}">
-                <a16:creationId xmlns:a16="http://schemas.microsoft.com/office/drawing/2014/main" id="{73FC9402-FBAB-4F02-A798-772127534D45}"/>
+                <a16:creationId xmlns:a16="http://schemas.microsoft.com/office/drawing/2014/main" id="{1B7D542B-0494-4B26-8B70-9710FC0346DA}"/>
               </a:ext>
             </a:extLst>
           </p:cNvPr>
@@ -14727,7 +14747,7 @@
           <p:cNvPr id="542" name="">
             <a:extLst xmlns:a="http://schemas.openxmlformats.org/drawingml/2006/main">
               <a:ext uri="{FF2B5EF4-FFF2-40B4-BE49-F238E27FC236}">
-                <a16:creationId xmlns:a16="http://schemas.microsoft.com/office/drawing/2014/main" id="{EDA147FA-6092-4ECF-8D33-4C8AEED0751E}"/>
+                <a16:creationId xmlns:a16="http://schemas.microsoft.com/office/drawing/2014/main" id="{5E830E3B-B270-4F53-BB98-02F5D9FF43A5}"/>
               </a:ext>
             </a:extLst>
           </p:cNvPr>
@@ -14784,7 +14804,7 @@
           <p:cNvPr id="543" name="">
             <a:extLst xmlns:a="http://schemas.openxmlformats.org/drawingml/2006/main">
               <a:ext uri="{FF2B5EF4-FFF2-40B4-BE49-F238E27FC236}">
-                <a16:creationId xmlns:a16="http://schemas.microsoft.com/office/drawing/2014/main" id="{9FCDCBED-C29B-4D5F-8DC3-4C8267197EB1}"/>
+                <a16:creationId xmlns:a16="http://schemas.microsoft.com/office/drawing/2014/main" id="{86C07398-83CB-4930-AA8A-789807491FAD}"/>
               </a:ext>
             </a:extLst>
           </p:cNvPr>
@@ -14841,7 +14861,7 @@
           <p:cNvPr id="544" name="">
             <a:extLst xmlns:a="http://schemas.openxmlformats.org/drawingml/2006/main">
               <a:ext uri="{FF2B5EF4-FFF2-40B4-BE49-F238E27FC236}">
-                <a16:creationId xmlns:a16="http://schemas.microsoft.com/office/drawing/2014/main" id="{2A06ECA2-600B-492B-AE26-049A4A710ECE}"/>
+                <a16:creationId xmlns:a16="http://schemas.microsoft.com/office/drawing/2014/main" id="{9E20855C-AF53-4C90-AFEB-B19F9CA89266}"/>
               </a:ext>
             </a:extLst>
           </p:cNvPr>
@@ -14898,7 +14918,7 @@
           <p:cNvPr id="545" name="">
             <a:extLst xmlns:a="http://schemas.openxmlformats.org/drawingml/2006/main">
               <a:ext uri="{FF2B5EF4-FFF2-40B4-BE49-F238E27FC236}">
-                <a16:creationId xmlns:a16="http://schemas.microsoft.com/office/drawing/2014/main" id="{C6144AF5-8F46-445E-97F5-A8A406247BF5}"/>
+                <a16:creationId xmlns:a16="http://schemas.microsoft.com/office/drawing/2014/main" id="{B3834BB2-D495-410E-A01A-037E8F4239D5}"/>
               </a:ext>
             </a:extLst>
           </p:cNvPr>
@@ -14955,7 +14975,7 @@
           <p:cNvPr id="546" name="">
             <a:extLst xmlns:a="http://schemas.openxmlformats.org/drawingml/2006/main">
               <a:ext uri="{FF2B5EF4-FFF2-40B4-BE49-F238E27FC236}">
-                <a16:creationId xmlns:a16="http://schemas.microsoft.com/office/drawing/2014/main" id="{261C4478-4DEC-4006-9AAE-3D05E56C38AE}"/>
+                <a16:creationId xmlns:a16="http://schemas.microsoft.com/office/drawing/2014/main" id="{D950E33F-F01B-47B1-A3C9-A66D080CF603}"/>
               </a:ext>
             </a:extLst>
           </p:cNvPr>
@@ -15076,7 +15096,7 @@
                 <a:latin typeface="Helvetica Neue"/>
                 <a:ea typeface="Helvetica Neue"/>
                 <a:cs typeface="Helvetica Neue"/>
-                <a:hlinkClick xmlns:r="http://schemas.openxmlformats.org/officeDocument/2006/relationships" r:id="R2cac0dc7b2484e48"/>
+                <a:hlinkClick xmlns:r="http://schemas.openxmlformats.org/officeDocument/2006/relationships" r:id="R794e34240ea34af9"/>
               </a:rPr>
               <a:t>Source: our saved requests, timing summaries and telemetry</a:t>
             </a:r>
@@ -15195,7 +15215,7 @@
           <p:cNvPr id="534" name="">
             <a:extLst xmlns:a="http://schemas.openxmlformats.org/drawingml/2006/main">
               <a:ext uri="{FF2B5EF4-FFF2-40B4-BE49-F238E27FC236}">
-                <a16:creationId xmlns:a16="http://schemas.microsoft.com/office/drawing/2014/main" id="{A3A15B4C-BA2A-4522-8555-5DB3DAD9151F}"/>
+                <a16:creationId xmlns:a16="http://schemas.microsoft.com/office/drawing/2014/main" id="{86E8123C-4E99-4730-94B9-ED5806DE12E4}"/>
               </a:ext>
             </a:extLst>
           </p:cNvPr>
@@ -15252,7 +15272,7 @@
           <p:cNvPr id="535" name="">
             <a:extLst xmlns:a="http://schemas.openxmlformats.org/drawingml/2006/main">
               <a:ext uri="{FF2B5EF4-FFF2-40B4-BE49-F238E27FC236}">
-                <a16:creationId xmlns:a16="http://schemas.microsoft.com/office/drawing/2014/main" id="{C7704FEC-8FC8-4D3B-A890-07D17F17CD7F}"/>
+                <a16:creationId xmlns:a16="http://schemas.microsoft.com/office/drawing/2014/main" id="{4269BB72-CC80-4CCD-8BBD-F434ADABF326}"/>
               </a:ext>
             </a:extLst>
           </p:cNvPr>
@@ -15299,7 +15319,7 @@
                 <a:ea typeface="Helvetica Neue"/>
                 <a:cs typeface="Helvetica Neue"/>
               </a:rPr>
-              <a:t>Requests meeting targets/s, higher is better</a:t>
+              <a:t>SLO goodput (requests/s), higher is better</a:t>
             </a:r>
           </a:p>
         </p:txBody>
@@ -15316,7 +15336,7 @@
         </p:xfrm>
         <a:graphic xmlns:a="http://schemas.openxmlformats.org/drawingml/2006/main">
           <a:graphicData uri="http://schemas.openxmlformats.org/drawingml/2006/chart">
-            <c:chart xmlns:r="http://schemas.openxmlformats.org/officeDocument/2006/relationships" xmlns:c="http://schemas.openxmlformats.org/drawingml/2006/chart" r:id="R592e3f30b1104688"/>
+            <c:chart xmlns:r="http://schemas.openxmlformats.org/officeDocument/2006/relationships" xmlns:c="http://schemas.openxmlformats.org/drawingml/2006/chart" r:id="Rcd75ff90ee6c4d33"/>
           </a:graphicData>
         </a:graphic>
       </p:graphicFrame>
@@ -15325,7 +15345,7 @@
           <p:cNvPr id="537" name="">
             <a:extLst xmlns:a="http://schemas.openxmlformats.org/drawingml/2006/main">
               <a:ext uri="{FF2B5EF4-FFF2-40B4-BE49-F238E27FC236}">
-                <a16:creationId xmlns:a16="http://schemas.microsoft.com/office/drawing/2014/main" id="{EA3958BA-69CF-4AC9-83F6-C0F1BDA4CFB3}"/>
+                <a16:creationId xmlns:a16="http://schemas.microsoft.com/office/drawing/2014/main" id="{87A6B708-33BC-4072-88E4-4D5D1475182B}"/>
               </a:ext>
             </a:extLst>
           </p:cNvPr>
@@ -15389,7 +15409,7 @@
         </p:xfrm>
         <a:graphic xmlns:a="http://schemas.openxmlformats.org/drawingml/2006/main">
           <a:graphicData uri="http://schemas.openxmlformats.org/drawingml/2006/chart">
-            <c:chart xmlns:r="http://schemas.openxmlformats.org/officeDocument/2006/relationships" xmlns:c="http://schemas.openxmlformats.org/drawingml/2006/chart" r:id="Rfba47a542b6e4526"/>
+            <c:chart xmlns:r="http://schemas.openxmlformats.org/officeDocument/2006/relationships" xmlns:c="http://schemas.openxmlformats.org/drawingml/2006/chart" r:id="R64361b3b58354b9f"/>
           </a:graphicData>
         </a:graphic>
       </p:graphicFrame>
@@ -15398,7 +15418,7 @@
           <p:cNvPr id="539" name="">
             <a:extLst xmlns:a="http://schemas.openxmlformats.org/drawingml/2006/main">
               <a:ext uri="{FF2B5EF4-FFF2-40B4-BE49-F238E27FC236}">
-                <a16:creationId xmlns:a16="http://schemas.microsoft.com/office/drawing/2014/main" id="{C83E8897-CFF1-425F-A300-FDA84A108186}"/>
+                <a16:creationId xmlns:a16="http://schemas.microsoft.com/office/drawing/2014/main" id="{0CBC428C-245E-4134-8237-97031FAF2207}"/>
               </a:ext>
             </a:extLst>
           </p:cNvPr>
@@ -15462,7 +15482,7 @@
         </p:xfrm>
         <a:graphic xmlns:a="http://schemas.openxmlformats.org/drawingml/2006/main">
           <a:graphicData uri="http://schemas.openxmlformats.org/drawingml/2006/chart">
-            <c:chart xmlns:r="http://schemas.openxmlformats.org/officeDocument/2006/relationships" xmlns:c="http://schemas.openxmlformats.org/drawingml/2006/chart" r:id="R87f3953635a44b04"/>
+            <c:chart xmlns:r="http://schemas.openxmlformats.org/officeDocument/2006/relationships" xmlns:c="http://schemas.openxmlformats.org/drawingml/2006/chart" r:id="R99016566769f49eb"/>
           </a:graphicData>
         </a:graphic>
       </p:graphicFrame>
@@ -15471,7 +15491,7 @@
           <p:cNvPr id="541" name="">
             <a:extLst xmlns:a="http://schemas.openxmlformats.org/drawingml/2006/main">
               <a:ext uri="{FF2B5EF4-FFF2-40B4-BE49-F238E27FC236}">
-                <a16:creationId xmlns:a16="http://schemas.microsoft.com/office/drawing/2014/main" id="{38CB5139-D2BD-46B6-8908-87CE4FEC77CB}"/>
+                <a16:creationId xmlns:a16="http://schemas.microsoft.com/office/drawing/2014/main" id="{A7F8F4D6-01A1-449F-9E05-A9E01B54D23A}"/>
               </a:ext>
             </a:extLst>
           </p:cNvPr>
@@ -15535,7 +15555,7 @@
         </p:xfrm>
         <a:graphic xmlns:a="http://schemas.openxmlformats.org/drawingml/2006/main">
           <a:graphicData uri="http://schemas.openxmlformats.org/drawingml/2006/chart">
-            <c:chart xmlns:r="http://schemas.openxmlformats.org/officeDocument/2006/relationships" xmlns:c="http://schemas.openxmlformats.org/drawingml/2006/chart" r:id="Rb423fcbd91524eae"/>
+            <c:chart xmlns:r="http://schemas.openxmlformats.org/officeDocument/2006/relationships" xmlns:c="http://schemas.openxmlformats.org/drawingml/2006/chart" r:id="R611e3b9f33574fa5"/>
           </a:graphicData>
         </a:graphic>
       </p:graphicFrame>
@@ -15608,7 +15628,7 @@
                 <a:latin typeface="Helvetica Neue"/>
                 <a:ea typeface="Helvetica Neue"/>
                 <a:cs typeface="Helvetica Neue"/>
-                <a:hlinkClick xmlns:r="http://schemas.openxmlformats.org/officeDocument/2006/relationships" r:id="R813131261af148d8"/>
+                <a:hlinkClick xmlns:r="http://schemas.openxmlformats.org/officeDocument/2006/relationships" r:id="Rd44ae0a233ec4427"/>
               </a:rPr>
               <a:t>Our measured comparison</a:t>
             </a:r>
@@ -15628,7 +15648,7 @@
                 <a:latin typeface="Helvetica Neue"/>
                 <a:ea typeface="Helvetica Neue"/>
                 <a:cs typeface="Helvetica Neue"/>
-                <a:hlinkClick xmlns:r="http://schemas.openxmlformats.org/officeDocument/2006/relationships" r:id="Red34c38d7c894c89"/>
+                <a:hlinkClick xmlns:r="http://schemas.openxmlformats.org/officeDocument/2006/relationships" r:id="Rae5e15dd24104694"/>
               </a:rPr>
               <a:t>Post-hoc phase analysis</a:t>
             </a:r>
@@ -15747,7 +15767,7 @@
           <p:cNvPr id="534" name="">
             <a:extLst xmlns:a="http://schemas.openxmlformats.org/drawingml/2006/main">
               <a:ext uri="{FF2B5EF4-FFF2-40B4-BE49-F238E27FC236}">
-                <a16:creationId xmlns:a16="http://schemas.microsoft.com/office/drawing/2014/main" id="{B58FA6DD-87D6-47B9-99EE-770B96A53DFE}"/>
+                <a16:creationId xmlns:a16="http://schemas.microsoft.com/office/drawing/2014/main" id="{59FF05CD-C329-4FB8-8EC7-B3017A9FCEC2}"/>
               </a:ext>
             </a:extLst>
           </p:cNvPr>
@@ -16369,7 +16389,7 @@
           <p:cNvPr id="536" name="">
             <a:extLst xmlns:a="http://schemas.openxmlformats.org/drawingml/2006/main">
               <a:ext uri="{FF2B5EF4-FFF2-40B4-BE49-F238E27FC236}">
-                <a16:creationId xmlns:a16="http://schemas.microsoft.com/office/drawing/2014/main" id="{76AF3F21-2BA3-4E29-BB30-689C9E0045BE}"/>
+                <a16:creationId xmlns:a16="http://schemas.microsoft.com/office/drawing/2014/main" id="{568FDB3F-E36C-4D33-8411-213EB22BB01C}"/>
               </a:ext>
             </a:extLst>
           </p:cNvPr>
@@ -16416,7 +16436,7 @@
                 <a:ea typeface="Helvetica Neue"/>
                 <a:cs typeface="Helvetica Neue"/>
               </a:rPr>
-              <a:t>The context-budget rule loses 20–24% goodput versus direct vLLM across paired runs.</a:t>
+              <a:t>The context-budget rule reduces SLO goodput by 20–24% versus default vLLM.</a:t>
             </a:r>
           </a:p>
         </p:txBody>
@@ -16426,7 +16446,7 @@
           <p:cNvPr id="537" name="">
             <a:extLst xmlns:a="http://schemas.openxmlformats.org/drawingml/2006/main">
               <a:ext uri="{FF2B5EF4-FFF2-40B4-BE49-F238E27FC236}">
-                <a16:creationId xmlns:a16="http://schemas.microsoft.com/office/drawing/2014/main" id="{D770F0E2-3D70-4DCD-A6F0-4B754BEDE1AF}"/>
+                <a16:creationId xmlns:a16="http://schemas.microsoft.com/office/drawing/2014/main" id="{F9BE8144-F898-40A8-A102-514073C2E5F0}"/>
               </a:ext>
             </a:extLst>
           </p:cNvPr>
@@ -16473,7 +16493,7 @@
                 <a:ea typeface="Helvetica Neue"/>
                 <a:cs typeface="Helvetica Neue"/>
               </a:rPr>
-              <a:t>It keeps the GPU busy while completing less useful work and increasing first-token delay.</a:t>
+              <a:t>Near-100% GPU busy time coexists with missed latency targets and lower SLO goodput.</a:t>
             </a:r>
           </a:p>
         </p:txBody>
@@ -16483,7 +16503,7 @@
           <p:cNvPr id="538" name="">
             <a:extLst xmlns:a="http://schemas.openxmlformats.org/drawingml/2006/main">
               <a:ext uri="{FF2B5EF4-FFF2-40B4-BE49-F238E27FC236}">
-                <a16:creationId xmlns:a16="http://schemas.microsoft.com/office/drawing/2014/main" id="{E922C8F4-3C44-44CA-ABF6-2E1CC679D283}"/>
+                <a16:creationId xmlns:a16="http://schemas.microsoft.com/office/drawing/2014/main" id="{816BBA81-E230-4EA7-93EB-18A79B077FF6}"/>
               </a:ext>
             </a:extLst>
           </p:cNvPr>
@@ -16563,7 +16583,7 @@
           <p:cNvPr id="539" name="">
             <a:extLst xmlns:a="http://schemas.openxmlformats.org/drawingml/2006/main">
               <a:ext uri="{FF2B5EF4-FFF2-40B4-BE49-F238E27FC236}">
-                <a16:creationId xmlns:a16="http://schemas.microsoft.com/office/drawing/2014/main" id="{1D5D1266-518D-4AAA-A568-F03909A2AF80}"/>
+                <a16:creationId xmlns:a16="http://schemas.microsoft.com/office/drawing/2014/main" id="{A08ED96F-9B7E-4C81-9E56-90643267B326}"/>
               </a:ext>
             </a:extLst>
           </p:cNvPr>
@@ -16684,7 +16704,7 @@
                 <a:latin typeface="Helvetica Neue"/>
                 <a:ea typeface="Helvetica Neue"/>
                 <a:cs typeface="Helvetica Neue"/>
-                <a:hlinkClick xmlns:r="http://schemas.openxmlformats.org/officeDocument/2006/relationships" r:id="R014dea2fabf94849"/>
+                <a:hlinkClick xmlns:r="http://schemas.openxmlformats.org/officeDocument/2006/relationships" r:id="R9a03816b58ce4cdb"/>
               </a:rPr>
               <a:t>Research question and methodology assessment</a:t>
             </a:r>
@@ -16793,7 +16813,7 @@
                 <a:ea typeface="Helvetica Neue"/>
                 <a:cs typeface="Helvetica Neue"/>
               </a:rPr>
-              <a:t>The research question and one next experiment</a:t>
+              <a:t>Research progression and next hypothesis</a:t>
             </a:r>
           </a:p>
         </p:txBody>
@@ -16803,7 +16823,7 @@
           <p:cNvPr id="534" name="">
             <a:extLst xmlns:a="http://schemas.openxmlformats.org/drawingml/2006/main">
               <a:ext uri="{FF2B5EF4-FFF2-40B4-BE49-F238E27FC236}">
-                <a16:creationId xmlns:a16="http://schemas.microsoft.com/office/drawing/2014/main" id="{3FB3C1EF-36EF-4CF8-93F0-D663197A01E4}"/>
+                <a16:creationId xmlns:a16="http://schemas.microsoft.com/office/drawing/2014/main" id="{96944AFB-DB12-4DA7-802A-76787AEED6F8}"/>
               </a:ext>
             </a:extLst>
           </p:cNvPr>
@@ -16815,7 +16835,7 @@
         <p:spPr>
           <a:xfrm xmlns:a="http://schemas.openxmlformats.org/drawingml/2006/main">
             <a:off x="390525" y="1390650"/>
-            <a:ext cx="11401425" cy="971550"/>
+            <a:ext cx="11401425" cy="962025"/>
           </a:xfrm>
           <a:prstGeom xmlns:a="http://schemas.openxmlformats.org/drawingml/2006/main" prst="rect">
             <a:avLst/>
@@ -16832,7 +16852,7 @@
           <a:lstStyle xmlns:a="http://schemas.openxmlformats.org/drawingml/2006/main"/>
           <a:p xmlns:a="http://schemas.openxmlformats.org/drawingml/2006/main">
             <a:pPr algn="l">
-              <a:defRPr sz="2475" b="1">
+              <a:defRPr sz="2400" b="1">
                 <a:solidFill>
                   <a:srgbClr val="000000"/>
                 </a:solidFill>
@@ -16842,7 +16862,7 @@
               </a:defRPr>
             </a:pPr>
             <a:r>
-              <a:rPr sz="2475" b="1">
+              <a:rPr sz="2400" b="1">
                 <a:solidFill>
                   <a:srgbClr val="000000"/>
                 </a:solidFill>
@@ -16850,7 +16870,7 @@
                 <a:ea typeface="Helvetica Neue"/>
                 <a:cs typeface="Helvetica Neue"/>
               </a:rPr>
-              <a:t>Can better admission decisions preserve useful concurrency and improve recovery after a burst of long prompts?</a:t>
+              <a:t>A reproducible burst-recovery problem. We have not yet demonstrated a better scheduler.</a:t>
             </a:r>
           </a:p>
         </p:txBody>
@@ -16860,7 +16880,7 @@
           <p:cNvPr id="535" name="">
             <a:extLst xmlns:a="http://schemas.openxmlformats.org/drawingml/2006/main">
               <a:ext uri="{FF2B5EF4-FFF2-40B4-BE49-F238E27FC236}">
-                <a16:creationId xmlns:a16="http://schemas.microsoft.com/office/drawing/2014/main" id="{E4580DD1-1521-45FA-BC0F-CC231AF0795E}"/>
+                <a16:creationId xmlns:a16="http://schemas.microsoft.com/office/drawing/2014/main" id="{9639D9B3-51F1-49C0-8587-26E1C50D99FF}"/>
               </a:ext>
             </a:extLst>
           </p:cNvPr>
@@ -16871,8 +16891,8 @@
         </p:nvSpPr>
         <p:spPr>
           <a:xfrm xmlns:a="http://schemas.openxmlformats.org/drawingml/2006/main">
-            <a:off x="390525" y="2876550"/>
-            <a:ext cx="5381625" cy="342900"/>
+            <a:off x="390525" y="2524125"/>
+            <a:ext cx="5381625" cy="361950"/>
           </a:xfrm>
           <a:prstGeom xmlns:a="http://schemas.openxmlformats.org/drawingml/2006/main" prst="rect">
             <a:avLst/>
@@ -16889,7 +16909,7 @@
           <a:lstStyle xmlns:a="http://schemas.openxmlformats.org/drawingml/2006/main"/>
           <a:p xmlns:a="http://schemas.openxmlformats.org/drawingml/2006/main">
             <a:pPr algn="l">
-              <a:defRPr sz="2175" b="1">
+              <a:defRPr sz="2100" b="1">
                 <a:solidFill>
                   <a:srgbClr val="000000"/>
                 </a:solidFill>
@@ -16899,7 +16919,7 @@
               </a:defRPr>
             </a:pPr>
             <a:r>
-              <a:rPr sz="2175" b="1">
+              <a:rPr sz="2100" b="1">
                 <a:solidFill>
                   <a:srgbClr val="000000"/>
                 </a:solidFill>
@@ -16907,7 +16927,7 @@
                 <a:ea typeface="Helvetica Neue"/>
                 <a:cs typeface="Helvetica Neue"/>
               </a:rPr>
-              <a:t>One controlled comparison</a:t>
+              <a:t>Evidence so far</a:t>
             </a:r>
           </a:p>
         </p:txBody>
@@ -16917,7 +16937,7 @@
           <p:cNvPr id="536" name="">
             <a:extLst xmlns:a="http://schemas.openxmlformats.org/drawingml/2006/main">
               <a:ext uri="{FF2B5EF4-FFF2-40B4-BE49-F238E27FC236}">
-                <a16:creationId xmlns:a16="http://schemas.microsoft.com/office/drawing/2014/main" id="{32D55B0F-BE41-4EA8-8640-1BF0296D88D1}"/>
+                <a16:creationId xmlns:a16="http://schemas.microsoft.com/office/drawing/2014/main" id="{E8E6D75A-D09C-4AC4-861B-D9D24643CE58}"/>
               </a:ext>
             </a:extLst>
           </p:cNvPr>
@@ -16928,8 +16948,8 @@
         </p:nvSpPr>
         <p:spPr>
           <a:xfrm xmlns:a="http://schemas.openxmlformats.org/drawingml/2006/main">
-            <a:off x="390525" y="3286125"/>
-            <a:ext cx="5381625" cy="1314450"/>
+            <a:off x="390525" y="3038475"/>
+            <a:ext cx="5381625" cy="619125"/>
           </a:xfrm>
           <a:prstGeom xmlns:a="http://schemas.openxmlformats.org/drawingml/2006/main" prst="rect">
             <a:avLst/>
@@ -16946,7 +16966,7 @@
           <a:lstStyle xmlns:a="http://schemas.openxmlformats.org/drawingml/2006/main"/>
           <a:p xmlns:a="http://schemas.openxmlformats.org/drawingml/2006/main">
             <a:pPr algn="l">
-              <a:defRPr sz="1875" b="0">
+              <a:defRPr sz="1800" b="0">
                 <a:solidFill>
                   <a:srgbClr val="000000"/>
                 </a:solidFill>
@@ -16956,7 +16976,7 @@
               </a:defRPr>
             </a:pPr>
             <a:r>
-              <a:rPr sz="1875" b="0">
+              <a:rPr sz="1800" b="0">
                 <a:solidFill>
                   <a:srgbClr val="000000"/>
                 </a:solidFill>
@@ -16964,7 +16984,7 @@
                 <a:ea typeface="Helvetica Neue"/>
                 <a:cs typeface="Helvetica Neue"/>
               </a:rPr>
-              <a:t>Calibrate processing-cost estimates on separate data. Freeze one adaptive rule, then replay unseen burst traces at several arrival rates.</a:t>
+              <a:t>1. Burst-recovery problem observed</a:t>
             </a:r>
           </a:p>
         </p:txBody>
@@ -16974,7 +16994,7 @@
           <p:cNvPr id="537" name="">
             <a:extLst xmlns:a="http://schemas.openxmlformats.org/drawingml/2006/main">
               <a:ext uri="{FF2B5EF4-FFF2-40B4-BE49-F238E27FC236}">
-                <a16:creationId xmlns:a16="http://schemas.microsoft.com/office/drawing/2014/main" id="{64C3548B-16FD-44F7-9734-106DD600148B}"/>
+                <a16:creationId xmlns:a16="http://schemas.microsoft.com/office/drawing/2014/main" id="{DE0D774E-E971-4289-AD7E-1C4B32CDD78C}"/>
               </a:ext>
             </a:extLst>
           </p:cNvPr>
@@ -16985,8 +17005,8 @@
         </p:nvSpPr>
         <p:spPr>
           <a:xfrm xmlns:a="http://schemas.openxmlformats.org/drawingml/2006/main">
-            <a:off x="6257925" y="2876550"/>
-            <a:ext cx="5534025" cy="342900"/>
+            <a:off x="390525" y="3714750"/>
+            <a:ext cx="5381625" cy="619125"/>
           </a:xfrm>
           <a:prstGeom xmlns:a="http://schemas.openxmlformats.org/drawingml/2006/main" prst="rect">
             <a:avLst/>
@@ -17003,7 +17023,7 @@
           <a:lstStyle xmlns:a="http://schemas.openxmlformats.org/drawingml/2006/main"/>
           <a:p xmlns:a="http://schemas.openxmlformats.org/drawingml/2006/main">
             <a:pPr algn="l">
-              <a:defRPr sz="2175" b="1">
+              <a:defRPr sz="1800" b="0">
                 <a:solidFill>
                   <a:srgbClr val="000000"/>
                 </a:solidFill>
@@ -17013,7 +17033,7 @@
               </a:defRPr>
             </a:pPr>
             <a:r>
-              <a:rPr sz="2175" b="1">
+              <a:rPr sz="1800" b="0">
                 <a:solidFill>
                   <a:srgbClr val="000000"/>
                 </a:solidFill>
@@ -17021,7 +17041,7 @@
                 <a:ea typeface="Helvetica Neue"/>
                 <a:cs typeface="Helvetica Neue"/>
               </a:rPr>
-              <a:t>What makes the comparison fair</a:t>
+              <a:t>2. Default vLLM and fixed-32 baselines measured</a:t>
             </a:r>
           </a:p>
         </p:txBody>
@@ -17031,7 +17051,7 @@
           <p:cNvPr id="538" name="">
             <a:extLst xmlns:a="http://schemas.openxmlformats.org/drawingml/2006/main">
               <a:ext uri="{FF2B5EF4-FFF2-40B4-BE49-F238E27FC236}">
-                <a16:creationId xmlns:a16="http://schemas.microsoft.com/office/drawing/2014/main" id="{5D16B9CB-6E76-4A3E-8F30-29C542DFA13A}"/>
+                <a16:creationId xmlns:a16="http://schemas.microsoft.com/office/drawing/2014/main" id="{948F0CDC-D1F6-4529-99A7-80FE3BD57654}"/>
               </a:ext>
             </a:extLst>
           </p:cNvPr>
@@ -17042,7 +17062,178 @@
         </p:nvSpPr>
         <p:spPr>
           <a:xfrm xmlns:a="http://schemas.openxmlformats.org/drawingml/2006/main">
-            <a:off x="6257925" y="3286125"/>
+            <a:off x="390525" y="4391025"/>
+            <a:ext cx="5381625" cy="619125"/>
+          </a:xfrm>
+          <a:prstGeom xmlns:a="http://schemas.openxmlformats.org/drawingml/2006/main" prst="rect">
+            <a:avLst/>
+          </a:prstGeom>
+          <a:noFill xmlns:a="http://schemas.openxmlformats.org/drawingml/2006/main"/>
+          <a:ln xmlns:a="http://schemas.openxmlformats.org/drawingml/2006/main">
+            <a:noFill/>
+          </a:ln>
+        </p:spPr>
+        <p:txBody>
+          <a:bodyPr xmlns:a="http://schemas.openxmlformats.org/drawingml/2006/main" lIns="0" tIns="0" rIns="0" bIns="0" anchor="t">
+            <a:noAutofit/>
+          </a:bodyPr>
+          <a:lstStyle xmlns:a="http://schemas.openxmlformats.org/drawingml/2006/main"/>
+          <a:p xmlns:a="http://schemas.openxmlformats.org/drawingml/2006/main">
+            <a:pPr algn="l">
+              <a:defRPr sz="1800" b="0">
+                <a:solidFill>
+                  <a:srgbClr val="000000"/>
+                </a:solidFill>
+                <a:latin typeface="Helvetica Neue"/>
+                <a:ea typeface="Helvetica Neue"/>
+                <a:cs typeface="Helvetica Neue"/>
+              </a:defRPr>
+            </a:pPr>
+            <a:r>
+              <a:rPr sz="1800" b="0">
+                <a:solidFill>
+                  <a:srgbClr val="000000"/>
+                </a:solidFill>
+                <a:latin typeface="Helvetica Neue"/>
+                <a:ea typeface="Helvetica Neue"/>
+                <a:cs typeface="Helvetica Neue"/>
+              </a:rPr>
+              <a:t>3. Context-budget admission hypothesis tested</a:t>
+            </a:r>
+          </a:p>
+        </p:txBody>
+      </p:sp>
+      <p:sp>
+        <p:nvSpPr>
+          <p:cNvPr id="539" name="">
+            <a:extLst xmlns:a="http://schemas.openxmlformats.org/drawingml/2006/main">
+              <a:ext uri="{FF2B5EF4-FFF2-40B4-BE49-F238E27FC236}">
+                <a16:creationId xmlns:a16="http://schemas.microsoft.com/office/drawing/2014/main" id="{8DAE1CF4-1279-4206-82E2-460329077E06}"/>
+              </a:ext>
+            </a:extLst>
+          </p:cNvPr>
+          <p:cNvSpPr>
+            <a:spLocks xmlns:a="http://schemas.openxmlformats.org/drawingml/2006/main" noGrp="1"/>
+          </p:cNvSpPr>
+          <p:nvPr/>
+        </p:nvSpPr>
+        <p:spPr>
+          <a:xfrm xmlns:a="http://schemas.openxmlformats.org/drawingml/2006/main">
+            <a:off x="390525" y="5067300"/>
+            <a:ext cx="5381625" cy="619125"/>
+          </a:xfrm>
+          <a:prstGeom xmlns:a="http://schemas.openxmlformats.org/drawingml/2006/main" prst="rect">
+            <a:avLst/>
+          </a:prstGeom>
+          <a:noFill xmlns:a="http://schemas.openxmlformats.org/drawingml/2006/main"/>
+          <a:ln xmlns:a="http://schemas.openxmlformats.org/drawingml/2006/main">
+            <a:noFill/>
+          </a:ln>
+        </p:spPr>
+        <p:txBody>
+          <a:bodyPr xmlns:a="http://schemas.openxmlformats.org/drawingml/2006/main" lIns="0" tIns="0" rIns="0" bIns="0" anchor="t">
+            <a:noAutofit/>
+          </a:bodyPr>
+          <a:lstStyle xmlns:a="http://schemas.openxmlformats.org/drawingml/2006/main"/>
+          <a:p xmlns:a="http://schemas.openxmlformats.org/drawingml/2006/main">
+            <a:pPr algn="l">
+              <a:defRPr sz="1800" b="0">
+                <a:solidFill>
+                  <a:srgbClr val="000000"/>
+                </a:solidFill>
+                <a:latin typeface="Helvetica Neue"/>
+                <a:ea typeface="Helvetica Neue"/>
+                <a:cs typeface="Helvetica Neue"/>
+              </a:defRPr>
+            </a:pPr>
+            <a:r>
+              <a:rPr sz="1800" b="0">
+                <a:solidFill>
+                  <a:srgbClr val="000000"/>
+                </a:solidFill>
+                <a:latin typeface="Helvetica Neue"/>
+                <a:ea typeface="Helvetica Neue"/>
+                <a:cs typeface="Helvetica Neue"/>
+              </a:rPr>
+              <a:t>4. Tested gate rejected: 20–24% lower SLO goodput</a:t>
+            </a:r>
+          </a:p>
+        </p:txBody>
+      </p:sp>
+      <p:sp>
+        <p:nvSpPr>
+          <p:cNvPr id="540" name="">
+            <a:extLst xmlns:a="http://schemas.openxmlformats.org/drawingml/2006/main">
+              <a:ext uri="{FF2B5EF4-FFF2-40B4-BE49-F238E27FC236}">
+                <a16:creationId xmlns:a16="http://schemas.microsoft.com/office/drawing/2014/main" id="{A233BC4A-8FFF-4947-ABC2-3951A65B5D8F}"/>
+              </a:ext>
+            </a:extLst>
+          </p:cNvPr>
+          <p:cNvSpPr>
+            <a:spLocks xmlns:a="http://schemas.openxmlformats.org/drawingml/2006/main" noGrp="1"/>
+          </p:cNvSpPr>
+          <p:nvPr/>
+        </p:nvSpPr>
+        <p:spPr>
+          <a:xfrm xmlns:a="http://schemas.openxmlformats.org/drawingml/2006/main">
+            <a:off x="6257925" y="2524125"/>
+            <a:ext cx="5534025" cy="361950"/>
+          </a:xfrm>
+          <a:prstGeom xmlns:a="http://schemas.openxmlformats.org/drawingml/2006/main" prst="rect">
+            <a:avLst/>
+          </a:prstGeom>
+          <a:noFill xmlns:a="http://schemas.openxmlformats.org/drawingml/2006/main"/>
+          <a:ln xmlns:a="http://schemas.openxmlformats.org/drawingml/2006/main">
+            <a:noFill/>
+          </a:ln>
+        </p:spPr>
+        <p:txBody>
+          <a:bodyPr xmlns:a="http://schemas.openxmlformats.org/drawingml/2006/main" lIns="0" tIns="0" rIns="0" bIns="0" anchor="t">
+            <a:noAutofit/>
+          </a:bodyPr>
+          <a:lstStyle xmlns:a="http://schemas.openxmlformats.org/drawingml/2006/main"/>
+          <a:p xmlns:a="http://schemas.openxmlformats.org/drawingml/2006/main">
+            <a:pPr algn="l">
+              <a:defRPr sz="2100" b="1">
+                <a:solidFill>
+                  <a:srgbClr val="000000"/>
+                </a:solidFill>
+                <a:latin typeface="Helvetica Neue"/>
+                <a:ea typeface="Helvetica Neue"/>
+                <a:cs typeface="Helvetica Neue"/>
+              </a:defRPr>
+            </a:pPr>
+            <a:r>
+              <a:rPr sz="2100" b="1">
+                <a:solidFill>
+                  <a:srgbClr val="000000"/>
+                </a:solidFill>
+                <a:latin typeface="Helvetica Neue"/>
+                <a:ea typeface="Helvetica Neue"/>
+                <a:cs typeface="Helvetica Neue"/>
+              </a:rPr>
+              <a:t>Next hypothesis</a:t>
+            </a:r>
+          </a:p>
+        </p:txBody>
+      </p:sp>
+      <p:sp>
+        <p:nvSpPr>
+          <p:cNvPr id="541" name="">
+            <a:extLst xmlns:a="http://schemas.openxmlformats.org/drawingml/2006/main">
+              <a:ext uri="{FF2B5EF4-FFF2-40B4-BE49-F238E27FC236}">
+                <a16:creationId xmlns:a16="http://schemas.microsoft.com/office/drawing/2014/main" id="{91B82AA7-6613-4E47-870D-0A9202D911D1}"/>
+              </a:ext>
+            </a:extLst>
+          </p:cNvPr>
+          <p:cNvSpPr>
+            <a:spLocks xmlns:a="http://schemas.openxmlformats.org/drawingml/2006/main" noGrp="1"/>
+          </p:cNvSpPr>
+          <p:nvPr/>
+        </p:nvSpPr>
+        <p:spPr>
+          <a:xfrm xmlns:a="http://schemas.openxmlformats.org/drawingml/2006/main">
+            <a:off x="6257925" y="3038475"/>
             <a:ext cx="5534025" cy="1343025"/>
           </a:xfrm>
           <a:prstGeom xmlns:a="http://schemas.openxmlformats.org/drawingml/2006/main" prst="rect">
@@ -17078,17 +17269,17 @@
                 <a:ea typeface="Helvetica Neue"/>
                 <a:cs typeface="Helvetica Neue"/>
               </a:rPr>
-              <a:t>Compare with direct vLLM and a calibrated fixed limit. Count all requests and waiting time. Check goodput, tail latency and long-request fairness.</a:t>
-            </a:r>
-          </a:p>
-        </p:txBody>
-      </p:sp>
-      <p:sp>
-        <p:nvSpPr>
-          <p:cNvPr id="539" name="">
+              <a:t>Admission informed by estimated processing cost, system state and remaining latency budget can outperform default vLLM and calibrated simple limits.</a:t>
+            </a:r>
+          </a:p>
+        </p:txBody>
+      </p:sp>
+      <p:sp>
+        <p:nvSpPr>
+          <p:cNvPr id="542" name="">
             <a:extLst xmlns:a="http://schemas.openxmlformats.org/drawingml/2006/main">
               <a:ext uri="{FF2B5EF4-FFF2-40B4-BE49-F238E27FC236}">
-                <a16:creationId xmlns:a16="http://schemas.microsoft.com/office/drawing/2014/main" id="{B0F7D76A-0A39-4944-ADD2-4C46AE5C9768}"/>
+                <a16:creationId xmlns:a16="http://schemas.microsoft.com/office/drawing/2014/main" id="{166E6271-9A99-46C7-90A0-CC62DD182FB3}"/>
               </a:ext>
             </a:extLst>
           </p:cNvPr>
@@ -17099,8 +17290,8 @@
         </p:nvSpPr>
         <p:spPr>
           <a:xfrm xmlns:a="http://schemas.openxmlformats.org/drawingml/2006/main">
-            <a:off x="390525" y="5000625"/>
-            <a:ext cx="11401425" cy="781050"/>
+            <a:off x="6257925" y="4514850"/>
+            <a:ext cx="5534025" cy="361950"/>
           </a:xfrm>
           <a:prstGeom xmlns:a="http://schemas.openxmlformats.org/drawingml/2006/main" prst="rect">
             <a:avLst/>
@@ -17117,7 +17308,7 @@
           <a:lstStyle xmlns:a="http://schemas.openxmlformats.org/drawingml/2006/main"/>
           <a:p xmlns:a="http://schemas.openxmlformats.org/drawingml/2006/main">
             <a:pPr algn="l">
-              <a:defRPr sz="1875" b="0">
+              <a:defRPr sz="2100" b="1">
                 <a:solidFill>
                   <a:srgbClr val="000000"/>
                 </a:solidFill>
@@ -17127,7 +17318,7 @@
               </a:defRPr>
             </a:pPr>
             <a:r>
-              <a:rPr sz="1875" b="0">
+              <a:rPr sz="2100" b="1">
                 <a:solidFill>
                   <a:srgbClr val="000000"/>
                 </a:solidFill>
@@ -17135,17 +17326,17 @@
                 <a:ea typeface="Helvetica Neue"/>
                 <a:cs typeface="Helvetica Neue"/>
               </a:rPr>
-              <a:t>What remains uncertain: our current rule mixes throttling and ordering. One workload cannot establish the best mechanism or cross-model improvement.</a:t>
-            </a:r>
-          </a:p>
-        </p:txBody>
-      </p:sp>
-      <p:sp>
-        <p:nvSpPr>
-          <p:cNvPr id="540" name="">
+              <a:t>One controlled comparison</a:t>
+            </a:r>
+          </a:p>
+        </p:txBody>
+      </p:sp>
+      <p:sp>
+        <p:nvSpPr>
+          <p:cNvPr id="543" name="">
             <a:extLst xmlns:a="http://schemas.openxmlformats.org/drawingml/2006/main">
               <a:ext uri="{FF2B5EF4-FFF2-40B4-BE49-F238E27FC236}">
-                <a16:creationId xmlns:a16="http://schemas.microsoft.com/office/drawing/2014/main" id="{5F6E2162-F808-4D88-8F44-4A1E48050702}"/>
+                <a16:creationId xmlns:a16="http://schemas.microsoft.com/office/drawing/2014/main" id="{4D752EEB-809D-4781-B36E-5B32FA58D561}"/>
               </a:ext>
             </a:extLst>
           </p:cNvPr>
@@ -17156,8 +17347,8 @@
         </p:nvSpPr>
         <p:spPr>
           <a:xfrm xmlns:a="http://schemas.openxmlformats.org/drawingml/2006/main">
-            <a:off x="390525" y="5924550"/>
-            <a:ext cx="11401425" cy="342900"/>
+            <a:off x="6257925" y="4972050"/>
+            <a:ext cx="5534025" cy="962025"/>
           </a:xfrm>
           <a:prstGeom xmlns:a="http://schemas.openxmlformats.org/drawingml/2006/main" prst="rect">
             <a:avLst/>
@@ -17174,7 +17365,7 @@
           <a:lstStyle xmlns:a="http://schemas.openxmlformats.org/drawingml/2006/main"/>
           <a:p xmlns:a="http://schemas.openxmlformats.org/drawingml/2006/main">
             <a:pPr algn="l">
-              <a:defRPr sz="1800" b="1">
+              <a:defRPr sz="1725" b="0">
                 <a:solidFill>
                   <a:srgbClr val="000000"/>
                 </a:solidFill>
@@ -17184,7 +17375,7 @@
               </a:defRPr>
             </a:pPr>
             <a:r>
-              <a:rPr sz="1800" b="1">
+              <a:rPr sz="1725" b="0">
                 <a:solidFill>
                   <a:srgbClr val="000000"/>
                 </a:solidFill>
@@ -17192,7 +17383,64 @@
                 <a:ea typeface="Helvetica Neue"/>
                 <a:cs typeface="Helvetica Neue"/>
               </a:rPr>
-              <a:t>The completed tests motivate the question. They have not demonstrated an improved scheduler.</a:t>
+              <a:t>Calibrate separately, freeze the rule, then test on unseen bursts. Count all requests and waiting. Check tail latency and long-request fairness.</a:t>
+            </a:r>
+          </a:p>
+        </p:txBody>
+      </p:sp>
+      <p:sp>
+        <p:nvSpPr>
+          <p:cNvPr id="544" name="">
+            <a:extLst xmlns:a="http://schemas.openxmlformats.org/drawingml/2006/main">
+              <a:ext uri="{FF2B5EF4-FFF2-40B4-BE49-F238E27FC236}">
+                <a16:creationId xmlns:a16="http://schemas.microsoft.com/office/drawing/2014/main" id="{1CB1E3B4-330B-4C03-A779-58F8DC4B3508}"/>
+              </a:ext>
+            </a:extLst>
+          </p:cNvPr>
+          <p:cNvSpPr>
+            <a:spLocks xmlns:a="http://schemas.openxmlformats.org/drawingml/2006/main" noGrp="1"/>
+          </p:cNvSpPr>
+          <p:nvPr/>
+        </p:nvSpPr>
+        <p:spPr>
+          <a:xfrm xmlns:a="http://schemas.openxmlformats.org/drawingml/2006/main">
+            <a:off x="390525" y="6038850"/>
+            <a:ext cx="11401425" cy="266700"/>
+          </a:xfrm>
+          <a:prstGeom xmlns:a="http://schemas.openxmlformats.org/drawingml/2006/main" prst="rect">
+            <a:avLst/>
+          </a:prstGeom>
+          <a:noFill xmlns:a="http://schemas.openxmlformats.org/drawingml/2006/main"/>
+          <a:ln xmlns:a="http://schemas.openxmlformats.org/drawingml/2006/main">
+            <a:noFill/>
+          </a:ln>
+        </p:spPr>
+        <p:txBody>
+          <a:bodyPr xmlns:a="http://schemas.openxmlformats.org/drawingml/2006/main" lIns="0" tIns="0" rIns="0" bIns="0" anchor="t">
+            <a:noAutofit/>
+          </a:bodyPr>
+          <a:lstStyle xmlns:a="http://schemas.openxmlformats.org/drawingml/2006/main"/>
+          <a:p xmlns:a="http://schemas.openxmlformats.org/drawingml/2006/main">
+            <a:pPr algn="l">
+              <a:defRPr sz="1500" b="0">
+                <a:solidFill>
+                  <a:srgbClr val="000000"/>
+                </a:solidFill>
+                <a:latin typeface="Helvetica Neue"/>
+                <a:ea typeface="Helvetica Neue"/>
+                <a:cs typeface="Helvetica Neue"/>
+              </a:defRPr>
+            </a:pPr>
+            <a:r>
+              <a:rPr sz="1500" b="0">
+                <a:solidFill>
+                  <a:srgbClr val="000000"/>
+                </a:solidFill>
+                <a:latin typeface="Helvetica Neue"/>
+                <a:ea typeface="Helvetica Neue"/>
+                <a:cs typeface="Helvetica Neue"/>
+              </a:rPr>
+              <a:t>Include a comparison with adaptation removed. One workload does not establish causal mechanism or generalization.</a:t>
             </a:r>
           </a:p>
         </p:txBody>
@@ -17266,7 +17514,7 @@
                 <a:latin typeface="Helvetica Neue"/>
                 <a:ea typeface="Helvetica Neue"/>
                 <a:cs typeface="Helvetica Neue"/>
-                <a:hlinkClick xmlns:r="http://schemas.openxmlformats.org/officeDocument/2006/relationships" r:id="Rd6b5dad5bdcf4f78"/>
+                <a:hlinkClick xmlns:r="http://schemas.openxmlformats.org/officeDocument/2006/relationships" r:id="R409b5cbd6fc04940"/>
               </a:rPr>
               <a:t>Full references and additional background</a:t>
             </a:r>
@@ -17385,7 +17633,7 @@
           <p:cNvPr id="534" name="">
             <a:extLst xmlns:a="http://schemas.openxmlformats.org/drawingml/2006/main">
               <a:ext uri="{FF2B5EF4-FFF2-40B4-BE49-F238E27FC236}">
-                <a16:creationId xmlns:a16="http://schemas.microsoft.com/office/drawing/2014/main" id="{D8125F7F-FC7D-4A52-B393-DB362BFCB330}"/>
+                <a16:creationId xmlns:a16="http://schemas.microsoft.com/office/drawing/2014/main" id="{1DC57A49-BEB6-4933-92EA-BFCBA5AE1C66}"/>
               </a:ext>
             </a:extLst>
           </p:cNvPr>
@@ -17431,7 +17679,7 @@
                 <a:latin typeface="Helvetica Neue"/>
                 <a:ea typeface="Helvetica Neue"/>
                 <a:cs typeface="Helvetica Neue"/>
-                <a:hlinkClick xmlns:r="http://schemas.openxmlformats.org/officeDocument/2006/relationships" r:id="R0d4276af2e52447d"/>
+                <a:hlinkClick xmlns:r="http://schemas.openxmlformats.org/officeDocument/2006/relationships" r:id="Rbbf78ec97c21483a"/>
               </a:rPr>
               <a:t>[1] Hong et al. SOLA: state-aware scheduling. MLSys 2025. Figure 1</a:t>
             </a:r>
@@ -17443,7 +17691,7 @@
           <p:cNvPr id="535" name="">
             <a:extLst xmlns:a="http://schemas.openxmlformats.org/drawingml/2006/main">
               <a:ext uri="{FF2B5EF4-FFF2-40B4-BE49-F238E27FC236}">
-                <a16:creationId xmlns:a16="http://schemas.microsoft.com/office/drawing/2014/main" id="{05A2A0A7-BDBF-4D28-8FF6-E833067D24FA}"/>
+                <a16:creationId xmlns:a16="http://schemas.microsoft.com/office/drawing/2014/main" id="{30A53645-C924-4BDB-93D5-8C48C4E253EB}"/>
               </a:ext>
             </a:extLst>
           </p:cNvPr>
@@ -17489,7 +17737,7 @@
                 <a:latin typeface="Helvetica Neue"/>
                 <a:ea typeface="Helvetica Neue"/>
                 <a:cs typeface="Helvetica Neue"/>
-                <a:hlinkClick xmlns:r="http://schemas.openxmlformats.org/officeDocument/2006/relationships" r:id="R83ec86b4f6994f93"/>
+                <a:hlinkClick xmlns:r="http://schemas.openxmlformats.org/officeDocument/2006/relationships" r:id="Ra75da8b12c8c4334"/>
               </a:rPr>
               <a:t>[2] Gao et al. DuetServe: adaptive GPU multiplexing. ICML 2026. Figure 6</a:t>
             </a:r>
@@ -17501,7 +17749,7 @@
           <p:cNvPr id="536" name="">
             <a:extLst xmlns:a="http://schemas.openxmlformats.org/drawingml/2006/main">
               <a:ext uri="{FF2B5EF4-FFF2-40B4-BE49-F238E27FC236}">
-                <a16:creationId xmlns:a16="http://schemas.microsoft.com/office/drawing/2014/main" id="{282C3880-2B4C-488B-9CB1-A586EE4DD0D4}"/>
+                <a16:creationId xmlns:a16="http://schemas.microsoft.com/office/drawing/2014/main" id="{08D50480-B025-4EC1-B674-AE834E0BA294}"/>
               </a:ext>
             </a:extLst>
           </p:cNvPr>
@@ -17547,7 +17795,7 @@
                 <a:latin typeface="Helvetica Neue"/>
                 <a:ea typeface="Helvetica Neue"/>
                 <a:cs typeface="Helvetica Neue"/>
-                <a:hlinkClick xmlns:r="http://schemas.openxmlformats.org/officeDocument/2006/relationships" r:id="R56c1497504254250"/>
+                <a:hlinkClick xmlns:r="http://schemas.openxmlformats.org/officeDocument/2006/relationships" r:id="Rfddd7470312d451b"/>
               </a:rPr>
               <a:t>[3] Yang et al. GPU-disaggregated DLRM serving. NSDI 2025. Figure 17</a:t>
             </a:r>
@@ -17559,7 +17807,7 @@
           <p:cNvPr id="537" name="">
             <a:extLst xmlns:a="http://schemas.openxmlformats.org/drawingml/2006/main">
               <a:ext uri="{FF2B5EF4-FFF2-40B4-BE49-F238E27FC236}">
-                <a16:creationId xmlns:a16="http://schemas.microsoft.com/office/drawing/2014/main" id="{64E6207F-2429-499D-A186-8AD4E3562826}"/>
+                <a16:creationId xmlns:a16="http://schemas.microsoft.com/office/drawing/2014/main" id="{3551E71E-6868-453B-B65C-713466F7EE57}"/>
               </a:ext>
             </a:extLst>
           </p:cNvPr>
@@ -17605,7 +17853,7 @@
                 <a:latin typeface="Helvetica Neue"/>
                 <a:ea typeface="Helvetica Neue"/>
                 <a:cs typeface="Helvetica Neue"/>
-                <a:hlinkClick xmlns:r="http://schemas.openxmlformats.org/officeDocument/2006/relationships" r:id="R5f8af2e629d74c16"/>
+                <a:hlinkClick xmlns:r="http://schemas.openxmlformats.org/officeDocument/2006/relationships" r:id="Rd3e9ecf4fc2b4378"/>
               </a:rPr>
               <a:t>[4] NVIDIA. Tuning CUDA graph batch sizes. Engineering report, August 2026</a:t>
             </a:r>
@@ -17617,7 +17865,7 @@
           <p:cNvPr id="538" name="">
             <a:extLst xmlns:a="http://schemas.openxmlformats.org/drawingml/2006/main">
               <a:ext uri="{FF2B5EF4-FFF2-40B4-BE49-F238E27FC236}">
-                <a16:creationId xmlns:a16="http://schemas.microsoft.com/office/drawing/2014/main" id="{6EFAF33D-052D-43B0-86C2-4DA9FFA7B26B}"/>
+                <a16:creationId xmlns:a16="http://schemas.microsoft.com/office/drawing/2014/main" id="{59A42843-1CF1-476B-BC20-EBA0C4D012EE}"/>
               </a:ext>
             </a:extLst>
           </p:cNvPr>
@@ -17663,7 +17911,7 @@
                 <a:latin typeface="Helvetica Neue"/>
                 <a:ea typeface="Helvetica Neue"/>
                 <a:cs typeface="Helvetica Neue"/>
-                <a:hlinkClick xmlns:r="http://schemas.openxmlformats.org/officeDocument/2006/relationships" r:id="R29eb873dd0c040f1"/>
+                <a:hlinkClick xmlns:r="http://schemas.openxmlformats.org/officeDocument/2006/relationships" r:id="R48c2d5ec883e459b"/>
               </a:rPr>
               <a:t>[5] vLLM. CUDA graph design and serving implementation documentation</a:t>
             </a:r>
@@ -17675,7 +17923,7 @@
           <p:cNvPr id="539" name="">
             <a:extLst xmlns:a="http://schemas.openxmlformats.org/drawingml/2006/main">
               <a:ext uri="{FF2B5EF4-FFF2-40B4-BE49-F238E27FC236}">
-                <a16:creationId xmlns:a16="http://schemas.microsoft.com/office/drawing/2014/main" id="{35A3F282-27A4-4645-A1F1-BF4A9758BDE4}"/>
+                <a16:creationId xmlns:a16="http://schemas.microsoft.com/office/drawing/2014/main" id="{3FF1AB4B-DB15-4417-8D97-686CC7028BA0}"/>
               </a:ext>
             </a:extLst>
           </p:cNvPr>
@@ -17721,7 +17969,7 @@
                 <a:latin typeface="Helvetica Neue"/>
                 <a:ea typeface="Helvetica Neue"/>
                 <a:cs typeface="Helvetica Neue"/>
-                <a:hlinkClick xmlns:r="http://schemas.openxmlformats.org/officeDocument/2006/relationships" r:id="R7095c60cca2944e4"/>
+                <a:hlinkClick xmlns:r="http://schemas.openxmlformats.org/officeDocument/2006/relationships" r:id="Rf509c3953d914b6c"/>
               </a:rPr>
               <a:t>[6] NVIDIA. NVML GPU-utilization metric definition</a:t>
             </a:r>
@@ -17733,7 +17981,7 @@
           <p:cNvPr id="540" name="">
             <a:extLst xmlns:a="http://schemas.openxmlformats.org/drawingml/2006/main">
               <a:ext uri="{FF2B5EF4-FFF2-40B4-BE49-F238E27FC236}">
-                <a16:creationId xmlns:a16="http://schemas.microsoft.com/office/drawing/2014/main" id="{165264F9-2117-4A91-B97D-C550A29F0864}"/>
+                <a16:creationId xmlns:a16="http://schemas.microsoft.com/office/drawing/2014/main" id="{B43D94B1-4775-4D99-82EA-C9F6E47111D5}"/>
               </a:ext>
             </a:extLst>
           </p:cNvPr>
@@ -17779,7 +18027,7 @@
                 <a:latin typeface="Helvetica Neue"/>
                 <a:ea typeface="Helvetica Neue"/>
                 <a:cs typeface="Helvetica Neue"/>
-                <a:hlinkClick xmlns:r="http://schemas.openxmlformats.org/officeDocument/2006/relationships" r:id="Rf82f88f2bf2948e3"/>
+                <a:hlinkClick xmlns:r="http://schemas.openxmlformats.org/officeDocument/2006/relationships" r:id="Rb33e34b5e6de4b8c"/>
               </a:rPr>
               <a:t>[7] Official model and WikiText revisions: saved experiment manifests</a:t>
             </a:r>
@@ -17791,7 +18039,7 @@
           <p:cNvPr id="541" name="">
             <a:extLst xmlns:a="http://schemas.openxmlformats.org/drawingml/2006/main">
               <a:ext uri="{FF2B5EF4-FFF2-40B4-BE49-F238E27FC236}">
-                <a16:creationId xmlns:a16="http://schemas.microsoft.com/office/drawing/2014/main" id="{0E2D9647-02C1-46B3-8D12-987242F393F9}"/>
+                <a16:creationId xmlns:a16="http://schemas.microsoft.com/office/drawing/2014/main" id="{B729FD0A-787A-4C84-8F6A-128AD82C8467}"/>
               </a:ext>
             </a:extLst>
           </p:cNvPr>
@@ -17837,7 +18085,7 @@
                 <a:latin typeface="Helvetica Neue"/>
                 <a:ea typeface="Helvetica Neue"/>
                 <a:cs typeface="Helvetica Neue"/>
-                <a:hlinkClick xmlns:r="http://schemas.openxmlformats.org/officeDocument/2006/relationships" r:id="R9f9de0ef98f74f68"/>
+                <a:hlinkClick xmlns:r="http://schemas.openxmlformats.org/officeDocument/2006/relationships" r:id="R441fc8b30a92424d"/>
               </a:rPr>
               <a:t>[8] Our experiment code, raw results, graph data and full bibliography</a:t>
             </a:r>
@@ -17849,7 +18097,7 @@
           <p:cNvPr id="542" name="">
             <a:extLst xmlns:a="http://schemas.openxmlformats.org/drawingml/2006/main">
               <a:ext uri="{FF2B5EF4-FFF2-40B4-BE49-F238E27FC236}">
-                <a16:creationId xmlns:a16="http://schemas.microsoft.com/office/drawing/2014/main" id="{7AA2F5AD-9CA0-4B6B-9D65-541E06A5C0C9}"/>
+                <a16:creationId xmlns:a16="http://schemas.microsoft.com/office/drawing/2014/main" id="{DA0DBC17-D91D-46AE-B3D6-79B27305BE20}"/>
               </a:ext>
             </a:extLst>
           </p:cNvPr>
@@ -17895,7 +18143,7 @@
                 <a:latin typeface="Helvetica Neue"/>
                 <a:ea typeface="Helvetica Neue"/>
                 <a:cs typeface="Helvetica Neue"/>
-                <a:hlinkClick xmlns:r="http://schemas.openxmlformats.org/officeDocument/2006/relationships" r:id="Re1da8f1d0ab84392"/>
+                <a:hlinkClick xmlns:r="http://schemas.openxmlformats.org/officeDocument/2006/relationships" r:id="Rb29dac88188946ae"/>
               </a:rPr>
               <a:t>[9] Our W&amp;B project and exact run records</a:t>
             </a:r>
@@ -17907,7 +18155,7 @@
           <p:cNvPr id="543" name="">
             <a:extLst xmlns:a="http://schemas.openxmlformats.org/drawingml/2006/main">
               <a:ext uri="{FF2B5EF4-FFF2-40B4-BE49-F238E27FC236}">
-                <a16:creationId xmlns:a16="http://schemas.microsoft.com/office/drawing/2014/main" id="{077ACC33-888A-474C-979A-FBF779F4C9AB}"/>
+                <a16:creationId xmlns:a16="http://schemas.microsoft.com/office/drawing/2014/main" id="{63C1C7D8-25E5-444A-ABD5-5088523963F0}"/>
               </a:ext>
             </a:extLst>
           </p:cNvPr>
@@ -18028,7 +18276,7 @@
                 <a:latin typeface="Helvetica Neue"/>
                 <a:ea typeface="Helvetica Neue"/>
                 <a:cs typeface="Helvetica Neue"/>
-                <a:hlinkClick xmlns:r="http://schemas.openxmlformats.org/officeDocument/2006/relationships" r:id="R4931dd51216b48ea"/>
+                <a:hlinkClick xmlns:r="http://schemas.openxmlformats.org/officeDocument/2006/relationships" r:id="Re51ac9bd81e649fa"/>
               </a:rPr>
               <a:t>Research question and evidence</a:t>
             </a:r>
@@ -18147,7 +18395,7 @@
           <p:cNvPr id="534" name="">
             <a:extLst xmlns:a="http://schemas.openxmlformats.org/drawingml/2006/main">
               <a:ext uri="{FF2B5EF4-FFF2-40B4-BE49-F238E27FC236}">
-                <a16:creationId xmlns:a16="http://schemas.microsoft.com/office/drawing/2014/main" id="{066F6A0C-4466-4074-8103-D701BBA5FDD0}"/>
+                <a16:creationId xmlns:a16="http://schemas.microsoft.com/office/drawing/2014/main" id="{7AD839B9-0174-4453-AF7F-9029A6CB3352}"/>
               </a:ext>
             </a:extLst>
           </p:cNvPr>
@@ -18159,7 +18407,7 @@
         <p:spPr>
           <a:xfrm xmlns:a="http://schemas.openxmlformats.org/drawingml/2006/main">
             <a:off x="390525" y="1371600"/>
-            <a:ext cx="11401425" cy="1000125"/>
+            <a:ext cx="11401425" cy="942975"/>
           </a:xfrm>
           <a:prstGeom xmlns:a="http://schemas.openxmlformats.org/drawingml/2006/main" prst="rect">
             <a:avLst/>
@@ -18194,7 +18442,7 @@
                 <a:ea typeface="Helvetica Neue"/>
                 <a:cs typeface="Helvetica Neue"/>
               </a:rPr>
-              <a:t>Can workload-aware admission improve goodput during long-prompt bursts on the same GPU?</a:t>
+              <a:t>Can better admission decisions increase SLO goodput during bursts of long prompts?</a:t>
             </a:r>
           </a:p>
         </p:txBody>
@@ -18204,7 +18452,7 @@
           <p:cNvPr id="535" name="">
             <a:extLst xmlns:a="http://schemas.openxmlformats.org/drawingml/2006/main">
               <a:ext uri="{FF2B5EF4-FFF2-40B4-BE49-F238E27FC236}">
-                <a16:creationId xmlns:a16="http://schemas.microsoft.com/office/drawing/2014/main" id="{D66CF298-08C0-437C-9C82-7CF9774DBC86}"/>
+                <a16:creationId xmlns:a16="http://schemas.microsoft.com/office/drawing/2014/main" id="{B20958F7-AE7F-4BC7-A93D-80CF0E1582E0}"/>
               </a:ext>
             </a:extLst>
           </p:cNvPr>
@@ -18215,7 +18463,64 @@
         </p:nvSpPr>
         <p:spPr>
           <a:xfrm xmlns:a="http://schemas.openxmlformats.org/drawingml/2006/main">
-            <a:off x="390525" y="2857500"/>
+            <a:off x="390525" y="2409825"/>
+            <a:ext cx="11401425" cy="457200"/>
+          </a:xfrm>
+          <a:prstGeom xmlns:a="http://schemas.openxmlformats.org/drawingml/2006/main" prst="rect">
+            <a:avLst/>
+          </a:prstGeom>
+          <a:noFill xmlns:a="http://schemas.openxmlformats.org/drawingml/2006/main"/>
+          <a:ln xmlns:a="http://schemas.openxmlformats.org/drawingml/2006/main">
+            <a:noFill/>
+          </a:ln>
+        </p:spPr>
+        <p:txBody>
+          <a:bodyPr xmlns:a="http://schemas.openxmlformats.org/drawingml/2006/main" lIns="0" tIns="0" rIns="0" bIns="0" anchor="t">
+            <a:noAutofit/>
+          </a:bodyPr>
+          <a:lstStyle xmlns:a="http://schemas.openxmlformats.org/drawingml/2006/main"/>
+          <a:p xmlns:a="http://schemas.openxmlformats.org/drawingml/2006/main">
+            <a:pPr algn="l">
+              <a:defRPr sz="1950" b="0">
+                <a:solidFill>
+                  <a:srgbClr val="000000"/>
+                </a:solidFill>
+                <a:latin typeface="Helvetica Neue"/>
+                <a:ea typeface="Helvetica Neue"/>
+                <a:cs typeface="Helvetica Neue"/>
+              </a:defRPr>
+            </a:pPr>
+            <a:r>
+              <a:rPr sz="1950" b="0">
+                <a:solidFill>
+                  <a:srgbClr val="000000"/>
+                </a:solidFill>
+                <a:latin typeface="Helvetica Neue"/>
+                <a:ea typeface="Helvetica Neue"/>
+                <a:cs typeface="Helvetica Neue"/>
+              </a:rPr>
+              <a:t>SLO goodput: requests completed within latency targets per second.</a:t>
+            </a:r>
+          </a:p>
+        </p:txBody>
+      </p:sp>
+      <p:sp>
+        <p:nvSpPr>
+          <p:cNvPr id="536" name="">
+            <a:extLst xmlns:a="http://schemas.openxmlformats.org/drawingml/2006/main">
+              <a:ext uri="{FF2B5EF4-FFF2-40B4-BE49-F238E27FC236}">
+                <a16:creationId xmlns:a16="http://schemas.microsoft.com/office/drawing/2014/main" id="{E7D28C30-772B-4A69-92E5-867BD0438158}"/>
+              </a:ext>
+            </a:extLst>
+          </p:cNvPr>
+          <p:cNvSpPr>
+            <a:spLocks xmlns:a="http://schemas.openxmlformats.org/drawingml/2006/main" noGrp="1"/>
+          </p:cNvSpPr>
+          <p:nvPr/>
+        </p:nvSpPr>
+        <p:spPr>
+          <a:xfrm xmlns:a="http://schemas.openxmlformats.org/drawingml/2006/main">
+            <a:off x="390525" y="3171825"/>
             <a:ext cx="5381625" cy="342900"/>
           </a:xfrm>
           <a:prstGeom xmlns:a="http://schemas.openxmlformats.org/drawingml/2006/main" prst="rect">
@@ -18258,10 +18563,10 @@
       </p:sp>
       <p:sp>
         <p:nvSpPr>
-          <p:cNvPr id="536" name="">
+          <p:cNvPr id="537" name="">
             <a:extLst xmlns:a="http://schemas.openxmlformats.org/drawingml/2006/main">
               <a:ext uri="{FF2B5EF4-FFF2-40B4-BE49-F238E27FC236}">
-                <a16:creationId xmlns:a16="http://schemas.microsoft.com/office/drawing/2014/main" id="{8CB95D54-A0B8-4464-AA60-602F10C22AAC}"/>
+                <a16:creationId xmlns:a16="http://schemas.microsoft.com/office/drawing/2014/main" id="{60A175EF-1D47-49F3-A5F7-7A9939D73F39}"/>
               </a:ext>
             </a:extLst>
           </p:cNvPr>
@@ -18272,7 +18577,7 @@
         </p:nvSpPr>
         <p:spPr>
           <a:xfrm xmlns:a="http://schemas.openxmlformats.org/drawingml/2006/main">
-            <a:off x="390525" y="3267075"/>
+            <a:off x="390525" y="3581400"/>
             <a:ext cx="5381625" cy="1200150"/>
           </a:xfrm>
           <a:prstGeom xmlns:a="http://schemas.openxmlformats.org/drawingml/2006/main" prst="rect">
@@ -18308,17 +18613,17 @@
                 <a:ea typeface="Helvetica Neue"/>
                 <a:cs typeface="Helvetica Neue"/>
               </a:rPr>
-              <a:t>Admission limits can leave capacity unused or delay requests. Increased GPU busy time need not improve timely completions.</a:t>
-            </a:r>
-          </a:p>
-        </p:txBody>
-      </p:sp>
-      <p:sp>
-        <p:nvSpPr>
-          <p:cNvPr id="537" name="">
+              <a:t>Admission limits can leave capacity unused or delay requests. Increased GPU busy time need not improve SLO goodput.</a:t>
+            </a:r>
+          </a:p>
+        </p:txBody>
+      </p:sp>
+      <p:sp>
+        <p:nvSpPr>
+          <p:cNvPr id="538" name="">
             <a:extLst xmlns:a="http://schemas.openxmlformats.org/drawingml/2006/main">
               <a:ext uri="{FF2B5EF4-FFF2-40B4-BE49-F238E27FC236}">
-                <a16:creationId xmlns:a16="http://schemas.microsoft.com/office/drawing/2014/main" id="{62047756-3160-49C8-B430-3E6A15BAB155}"/>
+                <a16:creationId xmlns:a16="http://schemas.microsoft.com/office/drawing/2014/main" id="{02748DDE-950D-4E41-9631-EC18662E3E40}"/>
               </a:ext>
             </a:extLst>
           </p:cNvPr>
@@ -18329,7 +18634,7 @@
         </p:nvSpPr>
         <p:spPr>
           <a:xfrm xmlns:a="http://schemas.openxmlformats.org/drawingml/2006/main">
-            <a:off x="6257925" y="2857500"/>
+            <a:off x="6257925" y="3171825"/>
             <a:ext cx="5534025" cy="342900"/>
           </a:xfrm>
           <a:prstGeom xmlns:a="http://schemas.openxmlformats.org/drawingml/2006/main" prst="rect">
@@ -18372,10 +18677,10 @@
       </p:sp>
       <p:sp>
         <p:nvSpPr>
-          <p:cNvPr id="538" name="">
+          <p:cNvPr id="539" name="">
             <a:extLst xmlns:a="http://schemas.openxmlformats.org/drawingml/2006/main">
               <a:ext uri="{FF2B5EF4-FFF2-40B4-BE49-F238E27FC236}">
-                <a16:creationId xmlns:a16="http://schemas.microsoft.com/office/drawing/2014/main" id="{63C54401-5CB4-4242-B3CD-5B0130571FAB}"/>
+                <a16:creationId xmlns:a16="http://schemas.microsoft.com/office/drawing/2014/main" id="{45D5950B-3183-41B6-B5FC-9A1ADD769142}"/>
               </a:ext>
             </a:extLst>
           </p:cNvPr>
@@ -18386,7 +18691,7 @@
         </p:nvSpPr>
         <p:spPr>
           <a:xfrm xmlns:a="http://schemas.openxmlformats.org/drawingml/2006/main">
-            <a:off x="6257925" y="3267075"/>
+            <a:off x="6257925" y="3581400"/>
             <a:ext cx="5534025" cy="1200150"/>
           </a:xfrm>
           <a:prstGeom xmlns:a="http://schemas.openxmlformats.org/drawingml/2006/main" prst="rect">
@@ -18422,17 +18727,17 @@
                 <a:ea typeface="Helvetica Neue"/>
                 <a:cs typeface="Helvetica Neue"/>
               </a:rPr>
-              <a:t>Short prompts, a burst of long prompts, then short prompts. Measure recovery, goodput and tail latency.</a:t>
-            </a:r>
-          </a:p>
-        </p:txBody>
-      </p:sp>
-      <p:sp>
-        <p:nvSpPr>
-          <p:cNvPr id="539" name="">
+              <a:t>Short prompts, a burst of long prompts, then short prompts. Measure recovery, SLO goodput and tail latency.</a:t>
+            </a:r>
+          </a:p>
+        </p:txBody>
+      </p:sp>
+      <p:sp>
+        <p:nvSpPr>
+          <p:cNvPr id="540" name="">
             <a:extLst xmlns:a="http://schemas.openxmlformats.org/drawingml/2006/main">
               <a:ext uri="{FF2B5EF4-FFF2-40B4-BE49-F238E27FC236}">
-                <a16:creationId xmlns:a16="http://schemas.microsoft.com/office/drawing/2014/main" id="{07B93E80-883A-42D0-A484-43C56DF3C3C3}"/>
+                <a16:creationId xmlns:a16="http://schemas.microsoft.com/office/drawing/2014/main" id="{15FDF2F8-BD20-4B94-8638-087B974FC43A}"/>
               </a:ext>
             </a:extLst>
           </p:cNvPr>
@@ -18443,8 +18748,8 @@
         </p:nvSpPr>
         <p:spPr>
           <a:xfrm xmlns:a="http://schemas.openxmlformats.org/drawingml/2006/main">
-            <a:off x="390525" y="4810125"/>
-            <a:ext cx="11401425" cy="876300"/>
+            <a:off x="390525" y="5057775"/>
+            <a:ext cx="11401425" cy="733425"/>
           </a:xfrm>
           <a:prstGeom xmlns:a="http://schemas.openxmlformats.org/drawingml/2006/main" prst="rect">
             <a:avLst/>
@@ -18461,7 +18766,7 @@
           <a:lstStyle xmlns:a="http://schemas.openxmlformats.org/drawingml/2006/main"/>
           <a:p xmlns:a="http://schemas.openxmlformats.org/drawingml/2006/main">
             <a:pPr algn="l">
-              <a:defRPr sz="2025" b="1">
+              <a:defRPr sz="1950" b="1">
                 <a:solidFill>
                   <a:srgbClr val="000000"/>
                 </a:solidFill>
@@ -18471,7 +18776,7 @@
               </a:defRPr>
             </a:pPr>
             <a:r>
-              <a:rPr sz="2025" b="1">
+              <a:rPr sz="1950" b="1">
                 <a:solidFill>
                   <a:srgbClr val="000000"/>
                 </a:solidFill>
@@ -18479,17 +18784,17 @@
                 <a:ea typeface="Helvetica Neue"/>
                 <a:cs typeface="Helvetica Neue"/>
               </a:rPr>
-              <a:t>Hypothesis: estimated processing cost and remaining latency budget can guide admission to improve goodput without worse tail latency.</a:t>
-            </a:r>
-          </a:p>
-        </p:txBody>
-      </p:sp>
-      <p:sp>
-        <p:nvSpPr>
-          <p:cNvPr id="540" name="">
+              <a:t>Hypothesis: estimated processing cost, system state and remaining latency budget can guide admission to increase SLO goodput without worse tail latency.</a:t>
+            </a:r>
+          </a:p>
+        </p:txBody>
+      </p:sp>
+      <p:sp>
+        <p:nvSpPr>
+          <p:cNvPr id="541" name="">
             <a:extLst xmlns:a="http://schemas.openxmlformats.org/drawingml/2006/main">
               <a:ext uri="{FF2B5EF4-FFF2-40B4-BE49-F238E27FC236}">
-                <a16:creationId xmlns:a16="http://schemas.microsoft.com/office/drawing/2014/main" id="{105355EB-D56D-4F63-A6E6-5551DBAC5573}"/>
+                <a16:creationId xmlns:a16="http://schemas.microsoft.com/office/drawing/2014/main" id="{99F215A1-D337-40BE-AD69-47746EED6FA5}"/>
               </a:ext>
             </a:extLst>
           </p:cNvPr>
@@ -18729,7 +19034,7 @@
           <p:cNvPr id="534" name="">
             <a:extLst xmlns:a="http://schemas.openxmlformats.org/drawingml/2006/main">
               <a:ext uri="{FF2B5EF4-FFF2-40B4-BE49-F238E27FC236}">
-                <a16:creationId xmlns:a16="http://schemas.microsoft.com/office/drawing/2014/main" id="{EFB460E8-C07B-48D5-B5EC-4B66C986A1ED}"/>
+                <a16:creationId xmlns:a16="http://schemas.microsoft.com/office/drawing/2014/main" id="{CFB4D5AD-C791-4686-8668-A801171C2D19}"/>
               </a:ext>
             </a:extLst>
           </p:cNvPr>
@@ -18832,7 +19137,7 @@
                 <a:latin typeface="Helvetica Neue"/>
                 <a:ea typeface="Helvetica Neue"/>
                 <a:cs typeface="Helvetica Neue"/>
-                <a:hlinkClick xmlns:r="http://schemas.openxmlformats.org/officeDocument/2006/relationships" r:id="R1ece2e6b659f4840"/>
+                <a:hlinkClick xmlns:r="http://schemas.openxmlformats.org/officeDocument/2006/relationships" r:id="R6ebe34ae422047fe"/>
               </a:rPr>
               <a:t>SOLA</a:t>
             </a:r>
@@ -18852,7 +19157,7 @@
                 <a:latin typeface="Helvetica Neue"/>
                 <a:ea typeface="Helvetica Neue"/>
                 <a:cs typeface="Helvetica Neue"/>
-                <a:hlinkClick xmlns:r="http://schemas.openxmlformats.org/officeDocument/2006/relationships" r:id="R3e21068cb5a648b8"/>
+                <a:hlinkClick xmlns:r="http://schemas.openxmlformats.org/officeDocument/2006/relationships" r:id="R15f3ad7327aa476d"/>
               </a:rPr>
               <a:t>DuetServe</a:t>
             </a:r>
@@ -18872,7 +19177,7 @@
                 <a:latin typeface="Helvetica Neue"/>
                 <a:ea typeface="Helvetica Neue"/>
                 <a:cs typeface="Helvetica Neue"/>
-                <a:hlinkClick xmlns:r="http://schemas.openxmlformats.org/officeDocument/2006/relationships" r:id="Racf9f0f031684497"/>
+                <a:hlinkClick xmlns:r="http://schemas.openxmlformats.org/officeDocument/2006/relationships" r:id="R13b7f24a80b547a8"/>
               </a:rPr>
               <a:t>Prism recommendation serving</a:t>
             </a:r>
@@ -18991,7 +19296,7 @@
           <p:cNvPr id="534" name="">
             <a:extLst xmlns:a="http://schemas.openxmlformats.org/drawingml/2006/main">
               <a:ext uri="{FF2B5EF4-FFF2-40B4-BE49-F238E27FC236}">
-                <a16:creationId xmlns:a16="http://schemas.microsoft.com/office/drawing/2014/main" id="{96CD065C-0F58-44C4-A6CC-79E76F39D5C8}"/>
+                <a16:creationId xmlns:a16="http://schemas.microsoft.com/office/drawing/2014/main" id="{1CF3A2A1-DA9D-4AB0-AA4F-DF8A5313F9E9}"/>
               </a:ext>
             </a:extLst>
           </p:cNvPr>
@@ -19406,7 +19711,7 @@
           <p:cNvPr id="536" name="">
             <a:extLst xmlns:a="http://schemas.openxmlformats.org/drawingml/2006/main">
               <a:ext uri="{FF2B5EF4-FFF2-40B4-BE49-F238E27FC236}">
-                <a16:creationId xmlns:a16="http://schemas.microsoft.com/office/drawing/2014/main" id="{648102C5-73E5-4E11-92F9-5B12B3BB87D2}"/>
+                <a16:creationId xmlns:a16="http://schemas.microsoft.com/office/drawing/2014/main" id="{2D4DE789-35B4-40BB-8CBE-3F4038DEF3DE}"/>
               </a:ext>
             </a:extLst>
           </p:cNvPr>
@@ -19527,7 +19832,7 @@
                 <a:latin typeface="Helvetica Neue"/>
                 <a:ea typeface="Helvetica Neue"/>
                 <a:cs typeface="Helvetica Neue"/>
-                <a:hlinkClick xmlns:r="http://schemas.openxmlformats.org/officeDocument/2006/relationships" r:id="R2ad4b702158a4064"/>
+                <a:hlinkClick xmlns:r="http://schemas.openxmlformats.org/officeDocument/2006/relationships" r:id="R85de6d08a45c430c"/>
               </a:rPr>
               <a:t>Hong et al., SOLA, MLSys 2025. Original Figure 1</a:t>
             </a:r>
@@ -19650,7 +19955,7 @@
           <p:nvPr/>
         </p:nvPicPr>
         <p:blipFill>
-          <a:blip xmlns:r="http://schemas.openxmlformats.org/officeDocument/2006/relationships" xmlns:a="http://schemas.openxmlformats.org/drawingml/2006/main" r:embed="R3a74ed1078974eeb"/>
+          <a:blip xmlns:r="http://schemas.openxmlformats.org/officeDocument/2006/relationships" xmlns:a="http://schemas.openxmlformats.org/drawingml/2006/main" r:embed="R52c969f5b73648a6"/>
           <a:stretch xmlns:a="http://schemas.openxmlformats.org/drawingml/2006/main"/>
         </p:blipFill>
         <p:spPr>
@@ -19668,7 +19973,7 @@
           <p:cNvPr id="535" name="">
             <a:extLst xmlns:a="http://schemas.openxmlformats.org/drawingml/2006/main">
               <a:ext uri="{FF2B5EF4-FFF2-40B4-BE49-F238E27FC236}">
-                <a16:creationId xmlns:a16="http://schemas.microsoft.com/office/drawing/2014/main" id="{BF76E13B-85BC-4213-BD50-29F2B3C40D88}"/>
+                <a16:creationId xmlns:a16="http://schemas.microsoft.com/office/drawing/2014/main" id="{C64A7F79-1DD2-47F9-9291-3484B26AE55F}"/>
               </a:ext>
             </a:extLst>
           </p:cNvPr>
@@ -19748,7 +20053,7 @@
           <p:cNvPr id="536" name="">
             <a:extLst xmlns:a="http://schemas.openxmlformats.org/drawingml/2006/main">
               <a:ext uri="{FF2B5EF4-FFF2-40B4-BE49-F238E27FC236}">
-                <a16:creationId xmlns:a16="http://schemas.microsoft.com/office/drawing/2014/main" id="{72D9F420-3753-4DA1-AD73-BC2773DA2FAF}"/>
+                <a16:creationId xmlns:a16="http://schemas.microsoft.com/office/drawing/2014/main" id="{F7FF2044-CAAE-4CD0-9B03-BADEED99AFCE}"/>
               </a:ext>
             </a:extLst>
           </p:cNvPr>
@@ -19805,7 +20110,7 @@
           <p:cNvPr id="537" name="">
             <a:extLst xmlns:a="http://schemas.openxmlformats.org/drawingml/2006/main">
               <a:ext uri="{FF2B5EF4-FFF2-40B4-BE49-F238E27FC236}">
-                <a16:creationId xmlns:a16="http://schemas.microsoft.com/office/drawing/2014/main" id="{59F6CFCB-1CD3-428F-9E1E-DAA0AE4D8829}"/>
+                <a16:creationId xmlns:a16="http://schemas.microsoft.com/office/drawing/2014/main" id="{ECFA7D2D-29D2-437E-AFE9-BDD0A4033CE3}"/>
               </a:ext>
             </a:extLst>
           </p:cNvPr>
@@ -19862,7 +20167,7 @@
           <p:cNvPr id="538" name="">
             <a:extLst xmlns:a="http://schemas.openxmlformats.org/drawingml/2006/main">
               <a:ext uri="{FF2B5EF4-FFF2-40B4-BE49-F238E27FC236}">
-                <a16:creationId xmlns:a16="http://schemas.microsoft.com/office/drawing/2014/main" id="{5C661DDC-BF29-4C92-8C74-C129E4563FFF}"/>
+                <a16:creationId xmlns:a16="http://schemas.microsoft.com/office/drawing/2014/main" id="{E2BE16DB-C584-403B-96EE-94DDE7BF0E76}"/>
               </a:ext>
             </a:extLst>
           </p:cNvPr>
@@ -19919,7 +20224,7 @@
           <p:cNvPr id="539" name="">
             <a:extLst xmlns:a="http://schemas.openxmlformats.org/drawingml/2006/main">
               <a:ext uri="{FF2B5EF4-FFF2-40B4-BE49-F238E27FC236}">
-                <a16:creationId xmlns:a16="http://schemas.microsoft.com/office/drawing/2014/main" id="{0B2A5541-6291-439F-9F22-CCDE0A1EC83C}"/>
+                <a16:creationId xmlns:a16="http://schemas.microsoft.com/office/drawing/2014/main" id="{1B78162B-3EA9-46C2-BDAD-5DF422C2D414}"/>
               </a:ext>
             </a:extLst>
           </p:cNvPr>
@@ -19976,7 +20281,7 @@
           <p:cNvPr id="540" name="">
             <a:extLst xmlns:a="http://schemas.openxmlformats.org/drawingml/2006/main">
               <a:ext uri="{FF2B5EF4-FFF2-40B4-BE49-F238E27FC236}">
-                <a16:creationId xmlns:a16="http://schemas.microsoft.com/office/drawing/2014/main" id="{4471423A-E32F-4788-8038-9FFB062F2BCA}"/>
+                <a16:creationId xmlns:a16="http://schemas.microsoft.com/office/drawing/2014/main" id="{C115E2B6-769A-42ED-87B3-89E92E1EAABE}"/>
               </a:ext>
             </a:extLst>
           </p:cNvPr>
@@ -20033,7 +20338,7 @@
           <p:cNvPr id="541" name="">
             <a:extLst xmlns:a="http://schemas.openxmlformats.org/drawingml/2006/main">
               <a:ext uri="{FF2B5EF4-FFF2-40B4-BE49-F238E27FC236}">
-                <a16:creationId xmlns:a16="http://schemas.microsoft.com/office/drawing/2014/main" id="{389ADF0D-44C4-4031-937F-B96A6E428714}"/>
+                <a16:creationId xmlns:a16="http://schemas.microsoft.com/office/drawing/2014/main" id="{8C133F2B-F0CF-475F-AFA8-F2BEBE47DD07}"/>
               </a:ext>
             </a:extLst>
           </p:cNvPr>
@@ -20154,7 +20459,7 @@
                 <a:latin typeface="Helvetica Neue"/>
                 <a:ea typeface="Helvetica Neue"/>
                 <a:cs typeface="Helvetica Neue"/>
-                <a:hlinkClick xmlns:r="http://schemas.openxmlformats.org/officeDocument/2006/relationships" r:id="Ra6fecedc4e9e4390"/>
+                <a:hlinkClick xmlns:r="http://schemas.openxmlformats.org/officeDocument/2006/relationships" r:id="R9aa26c17701c43e5"/>
               </a:rPr>
               <a:t>Gao et al., DuetServe, ICML 2026. Figure 6 and §5.2</a:t>
             </a:r>
@@ -20277,7 +20582,7 @@
           <p:nvPr/>
         </p:nvPicPr>
         <p:blipFill>
-          <a:blip xmlns:r="http://schemas.openxmlformats.org/officeDocument/2006/relationships" xmlns:a="http://schemas.openxmlformats.org/drawingml/2006/main" r:embed="R09e6e82d889f4e54"/>
+          <a:blip xmlns:r="http://schemas.openxmlformats.org/officeDocument/2006/relationships" xmlns:a="http://schemas.openxmlformats.org/drawingml/2006/main" r:embed="Rf476dd89263f4aeb"/>
           <a:stretch xmlns:a="http://schemas.openxmlformats.org/drawingml/2006/main"/>
         </p:blipFill>
         <p:spPr>
@@ -20295,7 +20600,7 @@
           <p:cNvPr id="535" name="">
             <a:extLst xmlns:a="http://schemas.openxmlformats.org/drawingml/2006/main">
               <a:ext uri="{FF2B5EF4-FFF2-40B4-BE49-F238E27FC236}">
-                <a16:creationId xmlns:a16="http://schemas.microsoft.com/office/drawing/2014/main" id="{96422061-BF7B-4B47-9E9C-2B6F732ACAC5}"/>
+                <a16:creationId xmlns:a16="http://schemas.microsoft.com/office/drawing/2014/main" id="{FE202DA1-7AC5-40D2-9017-1BB0C55E407F}"/>
               </a:ext>
             </a:extLst>
           </p:cNvPr>
@@ -20379,7 +20684,7 @@
           <p:nvPr/>
         </p:nvPicPr>
         <p:blipFill>
-          <a:blip xmlns:r="http://schemas.openxmlformats.org/officeDocument/2006/relationships" xmlns:a="http://schemas.openxmlformats.org/drawingml/2006/main" r:embed="Rda874ec98da34abe"/>
+          <a:blip xmlns:r="http://schemas.openxmlformats.org/officeDocument/2006/relationships" xmlns:a="http://schemas.openxmlformats.org/drawingml/2006/main" r:embed="R505bc6629ff046fa"/>
           <a:stretch xmlns:a="http://schemas.openxmlformats.org/drawingml/2006/main"/>
         </p:blipFill>
         <p:spPr>
@@ -20397,7 +20702,7 @@
           <p:cNvPr id="537" name="">
             <a:extLst xmlns:a="http://schemas.openxmlformats.org/drawingml/2006/main">
               <a:ext uri="{FF2B5EF4-FFF2-40B4-BE49-F238E27FC236}">
-                <a16:creationId xmlns:a16="http://schemas.microsoft.com/office/drawing/2014/main" id="{5CFA7613-687E-46A1-9754-237CBD326148}"/>
+                <a16:creationId xmlns:a16="http://schemas.microsoft.com/office/drawing/2014/main" id="{6EC2A242-A14A-4F89-9F88-E9D029AA2B5B}"/>
               </a:ext>
             </a:extLst>
           </p:cNvPr>
@@ -20454,7 +20759,7 @@
           <p:cNvPr id="538" name="">
             <a:extLst xmlns:a="http://schemas.openxmlformats.org/drawingml/2006/main">
               <a:ext uri="{FF2B5EF4-FFF2-40B4-BE49-F238E27FC236}">
-                <a16:creationId xmlns:a16="http://schemas.microsoft.com/office/drawing/2014/main" id="{2E6E0D12-E666-4C5C-B5CF-350C0E05C0C9}"/>
+                <a16:creationId xmlns:a16="http://schemas.microsoft.com/office/drawing/2014/main" id="{3F594FFD-0A45-4D9C-AA46-5FC53B16850F}"/>
               </a:ext>
             </a:extLst>
           </p:cNvPr>
@@ -20511,7 +20816,7 @@
           <p:cNvPr id="539" name="">
             <a:extLst xmlns:a="http://schemas.openxmlformats.org/drawingml/2006/main">
               <a:ext uri="{FF2B5EF4-FFF2-40B4-BE49-F238E27FC236}">
-                <a16:creationId xmlns:a16="http://schemas.microsoft.com/office/drawing/2014/main" id="{0D984156-147E-4C7F-BA00-2B2425A1F44D}"/>
+                <a16:creationId xmlns:a16="http://schemas.microsoft.com/office/drawing/2014/main" id="{CE307264-77FF-4A26-8F58-274B4900C77A}"/>
               </a:ext>
             </a:extLst>
           </p:cNvPr>
@@ -20568,7 +20873,7 @@
           <p:cNvPr id="540" name="">
             <a:extLst xmlns:a="http://schemas.openxmlformats.org/drawingml/2006/main">
               <a:ext uri="{FF2B5EF4-FFF2-40B4-BE49-F238E27FC236}">
-                <a16:creationId xmlns:a16="http://schemas.microsoft.com/office/drawing/2014/main" id="{65F5A740-77BA-49E1-B816-08662D270836}"/>
+                <a16:creationId xmlns:a16="http://schemas.microsoft.com/office/drawing/2014/main" id="{70F2D38F-1906-4CAC-B298-EBEC598E9C88}"/>
               </a:ext>
             </a:extLst>
           </p:cNvPr>
@@ -20625,7 +20930,7 @@
           <p:cNvPr id="541" name="">
             <a:extLst xmlns:a="http://schemas.openxmlformats.org/drawingml/2006/main">
               <a:ext uri="{FF2B5EF4-FFF2-40B4-BE49-F238E27FC236}">
-                <a16:creationId xmlns:a16="http://schemas.microsoft.com/office/drawing/2014/main" id="{CF945564-015D-4C07-9D9C-E76D2330A038}"/>
+                <a16:creationId xmlns:a16="http://schemas.microsoft.com/office/drawing/2014/main" id="{83803811-A531-4E72-BC6B-9CC02E5C7A94}"/>
               </a:ext>
             </a:extLst>
           </p:cNvPr>
@@ -20682,7 +20987,7 @@
           <p:cNvPr id="542" name="">
             <a:extLst xmlns:a="http://schemas.openxmlformats.org/drawingml/2006/main">
               <a:ext uri="{FF2B5EF4-FFF2-40B4-BE49-F238E27FC236}">
-                <a16:creationId xmlns:a16="http://schemas.microsoft.com/office/drawing/2014/main" id="{09BD47BA-92EA-4D70-83A7-7C5F4D02F75E}"/>
+                <a16:creationId xmlns:a16="http://schemas.microsoft.com/office/drawing/2014/main" id="{53FD78D7-B40D-4CE4-B839-AE19937EB04C}"/>
               </a:ext>
             </a:extLst>
           </p:cNvPr>
@@ -20803,7 +21108,7 @@
                 <a:latin typeface="Helvetica Neue"/>
                 <a:ea typeface="Helvetica Neue"/>
                 <a:cs typeface="Helvetica Neue"/>
-                <a:hlinkClick xmlns:r="http://schemas.openxmlformats.org/officeDocument/2006/relationships" r:id="Rb16fa643e9ee4e34"/>
+                <a:hlinkClick xmlns:r="http://schemas.openxmlformats.org/officeDocument/2006/relationships" r:id="R1384ae997a134388"/>
               </a:rPr>
               <a:t>Yang et al., GPU-Disaggregated DLRM Serving, NSDI 2025. Figure 17</a:t>
             </a:r>
@@ -20922,7 +21227,7 @@
           <p:cNvPr id="534" name="">
             <a:extLst xmlns:a="http://schemas.openxmlformats.org/drawingml/2006/main">
               <a:ext uri="{FF2B5EF4-FFF2-40B4-BE49-F238E27FC236}">
-                <a16:creationId xmlns:a16="http://schemas.microsoft.com/office/drawing/2014/main" id="{0705C5C4-9061-49A1-BAC5-FF5F0E32B087}"/>
+                <a16:creationId xmlns:a16="http://schemas.microsoft.com/office/drawing/2014/main" id="{7FF367D6-2F58-4D85-AE73-A4CE1869E8C1}"/>
               </a:ext>
             </a:extLst>
           </p:cNvPr>
@@ -20983,7 +21288,7 @@
           <p:nvPr/>
         </p:nvPicPr>
         <p:blipFill>
-          <a:blip xmlns:r="http://schemas.openxmlformats.org/officeDocument/2006/relationships" xmlns:a="http://schemas.openxmlformats.org/drawingml/2006/main" r:embed="R14f40248b07f4934"/>
+          <a:blip xmlns:r="http://schemas.openxmlformats.org/officeDocument/2006/relationships" xmlns:a="http://schemas.openxmlformats.org/drawingml/2006/main" r:embed="R8bfb9331844140f4"/>
           <a:stretch xmlns:a="http://schemas.openxmlformats.org/drawingml/2006/main"/>
         </p:blipFill>
         <p:spPr>
@@ -21001,7 +21306,7 @@
           <p:cNvPr id="536" name="">
             <a:extLst xmlns:a="http://schemas.openxmlformats.org/drawingml/2006/main">
               <a:ext uri="{FF2B5EF4-FFF2-40B4-BE49-F238E27FC236}">
-                <a16:creationId xmlns:a16="http://schemas.microsoft.com/office/drawing/2014/main" id="{4B9E81DD-0F7E-47B8-9EBF-555E3B0EF37E}"/>
+                <a16:creationId xmlns:a16="http://schemas.microsoft.com/office/drawing/2014/main" id="{25506B85-8E99-49C0-B759-E29E66D9B689}"/>
               </a:ext>
             </a:extLst>
           </p:cNvPr>
@@ -21081,7 +21386,7 @@
           <p:cNvPr id="537" name="">
             <a:extLst xmlns:a="http://schemas.openxmlformats.org/drawingml/2006/main">
               <a:ext uri="{FF2B5EF4-FFF2-40B4-BE49-F238E27FC236}">
-                <a16:creationId xmlns:a16="http://schemas.microsoft.com/office/drawing/2014/main" id="{C90D12B4-E729-42AF-8FB0-F5021E83CBF3}"/>
+                <a16:creationId xmlns:a16="http://schemas.microsoft.com/office/drawing/2014/main" id="{2FBD75A2-B863-4FDD-9E27-4BA06BE930AE}"/>
               </a:ext>
             </a:extLst>
           </p:cNvPr>
@@ -21138,7 +21443,7 @@
           <p:cNvPr id="538" name="">
             <a:extLst xmlns:a="http://schemas.openxmlformats.org/drawingml/2006/main">
               <a:ext uri="{FF2B5EF4-FFF2-40B4-BE49-F238E27FC236}">
-                <a16:creationId xmlns:a16="http://schemas.microsoft.com/office/drawing/2014/main" id="{6F03A157-089A-44F3-B2A9-39187F88F50D}"/>
+                <a16:creationId xmlns:a16="http://schemas.microsoft.com/office/drawing/2014/main" id="{ACC9BE6E-328E-4364-A1A3-69528D5B89DF}"/>
               </a:ext>
             </a:extLst>
           </p:cNvPr>
@@ -21195,7 +21500,7 @@
           <p:cNvPr id="539" name="">
             <a:extLst xmlns:a="http://schemas.openxmlformats.org/drawingml/2006/main">
               <a:ext uri="{FF2B5EF4-FFF2-40B4-BE49-F238E27FC236}">
-                <a16:creationId xmlns:a16="http://schemas.microsoft.com/office/drawing/2014/main" id="{78EE556C-F2EF-4315-AD3B-DB8EA06907B6}"/>
+                <a16:creationId xmlns:a16="http://schemas.microsoft.com/office/drawing/2014/main" id="{F4036E60-6693-40E7-82F6-903F81F5BD89}"/>
               </a:ext>
             </a:extLst>
           </p:cNvPr>
@@ -21252,7 +21557,7 @@
           <p:cNvPr id="540" name="">
             <a:extLst xmlns:a="http://schemas.openxmlformats.org/drawingml/2006/main">
               <a:ext uri="{FF2B5EF4-FFF2-40B4-BE49-F238E27FC236}">
-                <a16:creationId xmlns:a16="http://schemas.microsoft.com/office/drawing/2014/main" id="{79571CA6-CC67-4E59-AF5D-4657CFE76BFF}"/>
+                <a16:creationId xmlns:a16="http://schemas.microsoft.com/office/drawing/2014/main" id="{FE6BE08B-C1C6-4483-9049-1C20EEFE90D6}"/>
               </a:ext>
             </a:extLst>
           </p:cNvPr>
@@ -21309,7 +21614,7 @@
           <p:cNvPr id="541" name="">
             <a:extLst xmlns:a="http://schemas.openxmlformats.org/drawingml/2006/main">
               <a:ext uri="{FF2B5EF4-FFF2-40B4-BE49-F238E27FC236}">
-                <a16:creationId xmlns:a16="http://schemas.microsoft.com/office/drawing/2014/main" id="{D0ED4318-BBCD-49BA-8F9D-2C4918818B1B}"/>
+                <a16:creationId xmlns:a16="http://schemas.microsoft.com/office/drawing/2014/main" id="{A1E3F87D-AA22-4863-9C36-A1B7222C4E07}"/>
               </a:ext>
             </a:extLst>
           </p:cNvPr>
@@ -21366,7 +21671,7 @@
           <p:cNvPr id="542" name="">
             <a:extLst xmlns:a="http://schemas.openxmlformats.org/drawingml/2006/main">
               <a:ext uri="{FF2B5EF4-FFF2-40B4-BE49-F238E27FC236}">
-                <a16:creationId xmlns:a16="http://schemas.microsoft.com/office/drawing/2014/main" id="{448988AB-307B-4FD4-8634-422DD10953B9}"/>
+                <a16:creationId xmlns:a16="http://schemas.microsoft.com/office/drawing/2014/main" id="{608F292D-3996-4E3F-B8BB-5C639C636734}"/>
               </a:ext>
             </a:extLst>
           </p:cNvPr>
@@ -21606,7 +21911,7 @@
           <p:cNvPr id="534" name="">
             <a:extLst xmlns:a="http://schemas.openxmlformats.org/drawingml/2006/main">
               <a:ext uri="{FF2B5EF4-FFF2-40B4-BE49-F238E27FC236}">
-                <a16:creationId xmlns:a16="http://schemas.microsoft.com/office/drawing/2014/main" id="{05A5952A-47A7-47C8-91E4-6604DB1F964C}"/>
+                <a16:creationId xmlns:a16="http://schemas.microsoft.com/office/drawing/2014/main" id="{4FC4AD88-68ED-4C3D-8E82-EA7D21EB5733}"/>
               </a:ext>
             </a:extLst>
           </p:cNvPr>
@@ -21709,7 +22014,7 @@
                 <a:latin typeface="Helvetica Neue"/>
                 <a:ea typeface="Helvetica Neue"/>
                 <a:cs typeface="Helvetica Neue"/>
-                <a:hlinkClick xmlns:r="http://schemas.openxmlformats.org/officeDocument/2006/relationships" r:id="Rde2cf3068e934eca"/>
+                <a:hlinkClick xmlns:r="http://schemas.openxmlformats.org/officeDocument/2006/relationships" r:id="R942858dcee0c4f21"/>
               </a:rPr>
               <a:t>Recorded system and model revisions</a:t>
             </a:r>
@@ -21729,7 +22034,7 @@
                 <a:latin typeface="Helvetica Neue"/>
                 <a:ea typeface="Helvetica Neue"/>
                 <a:cs typeface="Helvetica Neue"/>
-                <a:hlinkClick xmlns:r="http://schemas.openxmlformats.org/officeDocument/2006/relationships" r:id="Rae8ac7e3bcbb4991"/>
+                <a:hlinkClick xmlns:r="http://schemas.openxmlformats.org/officeDocument/2006/relationships" r:id="Rdbe3666fa49d47b6"/>
               </a:rPr>
               <a:t>NVIDIA metric definition</a:t>
             </a:r>
@@ -22235,7 +22540,7 @@
           <p:cNvPr id="535" name="">
             <a:extLst xmlns:a="http://schemas.openxmlformats.org/drawingml/2006/main">
               <a:ext uri="{FF2B5EF4-FFF2-40B4-BE49-F238E27FC236}">
-                <a16:creationId xmlns:a16="http://schemas.microsoft.com/office/drawing/2014/main" id="{402EC61B-991B-4DD1-88F2-169ACD5AABCB}"/>
+                <a16:creationId xmlns:a16="http://schemas.microsoft.com/office/drawing/2014/main" id="{83A0C007-9076-414E-898F-9E2D6C78E127}"/>
               </a:ext>
             </a:extLst>
           </p:cNvPr>
@@ -22292,7 +22597,7 @@
           <p:cNvPr id="536" name="">
             <a:extLst xmlns:a="http://schemas.openxmlformats.org/drawingml/2006/main">
               <a:ext uri="{FF2B5EF4-FFF2-40B4-BE49-F238E27FC236}">
-                <a16:creationId xmlns:a16="http://schemas.microsoft.com/office/drawing/2014/main" id="{9CAC0667-D3BE-4168-B89C-D1D8D0D3D4B3}"/>
+                <a16:creationId xmlns:a16="http://schemas.microsoft.com/office/drawing/2014/main" id="{8E876970-8080-4AF8-9BFB-B4A2F0EF278B}"/>
               </a:ext>
             </a:extLst>
           </p:cNvPr>
@@ -22349,7 +22654,7 @@
           <p:cNvPr id="537" name="">
             <a:extLst xmlns:a="http://schemas.openxmlformats.org/drawingml/2006/main">
               <a:ext uri="{FF2B5EF4-FFF2-40B4-BE49-F238E27FC236}">
-                <a16:creationId xmlns:a16="http://schemas.microsoft.com/office/drawing/2014/main" id="{8451ADF1-2E67-4632-99DD-E9EB756D2176}"/>
+                <a16:creationId xmlns:a16="http://schemas.microsoft.com/office/drawing/2014/main" id="{1B37CE33-4787-4449-ADF6-71D98EC410F4}"/>
               </a:ext>
             </a:extLst>
           </p:cNvPr>
@@ -22406,7 +22711,7 @@
           <p:cNvPr id="538" name="">
             <a:extLst xmlns:a="http://schemas.openxmlformats.org/drawingml/2006/main">
               <a:ext uri="{FF2B5EF4-FFF2-40B4-BE49-F238E27FC236}">
-                <a16:creationId xmlns:a16="http://schemas.microsoft.com/office/drawing/2014/main" id="{3869D8FD-05AD-4FD9-8EF6-03BA357AEED4}"/>
+                <a16:creationId xmlns:a16="http://schemas.microsoft.com/office/drawing/2014/main" id="{9E9C43E1-CAB3-4D4D-937A-72E8BABACF3C}"/>
               </a:ext>
             </a:extLst>
           </p:cNvPr>
@@ -22463,7 +22768,7 @@
           <p:cNvPr id="539" name="">
             <a:extLst xmlns:a="http://schemas.openxmlformats.org/drawingml/2006/main">
               <a:ext uri="{FF2B5EF4-FFF2-40B4-BE49-F238E27FC236}">
-                <a16:creationId xmlns:a16="http://schemas.microsoft.com/office/drawing/2014/main" id="{1D5502BA-2F1B-4463-86C9-A26348B05A21}"/>
+                <a16:creationId xmlns:a16="http://schemas.microsoft.com/office/drawing/2014/main" id="{FA424166-082E-415D-9A04-AE171398A2B7}"/>
               </a:ext>
             </a:extLst>
           </p:cNvPr>
@@ -22520,7 +22825,7 @@
           <p:cNvPr id="540" name="">
             <a:extLst xmlns:a="http://schemas.openxmlformats.org/drawingml/2006/main">
               <a:ext uri="{FF2B5EF4-FFF2-40B4-BE49-F238E27FC236}">
-                <a16:creationId xmlns:a16="http://schemas.microsoft.com/office/drawing/2014/main" id="{B6837C05-96D1-4C09-B84D-6521632A4C9E}"/>
+                <a16:creationId xmlns:a16="http://schemas.microsoft.com/office/drawing/2014/main" id="{215014A6-F294-4358-943E-D957309114B8}"/>
               </a:ext>
             </a:extLst>
           </p:cNvPr>
@@ -22577,7 +22882,7 @@
           <p:cNvPr id="541" name="">
             <a:extLst xmlns:a="http://schemas.openxmlformats.org/drawingml/2006/main">
               <a:ext uri="{FF2B5EF4-FFF2-40B4-BE49-F238E27FC236}">
-                <a16:creationId xmlns:a16="http://schemas.microsoft.com/office/drawing/2014/main" id="{00F7A371-07FF-4144-A668-FABC5F54AC7A}"/>
+                <a16:creationId xmlns:a16="http://schemas.microsoft.com/office/drawing/2014/main" id="{93C3ED1B-03F3-451B-BE0E-06191CEDA76A}"/>
               </a:ext>
             </a:extLst>
           </p:cNvPr>

</xml_diff>